<commit_message>
Rewrite agenda-201 talk 08 insight PPT around Cost/Token
Hand-craft a 2-page insight deck for ACK × 小红书: Cost/Token north
star + Serving Stack, then static PD → dynamic RBG with production metrics.

Co-authored-by: Annie <Annie-Summer@users.noreply.github.com>
</commit_message>
<xml_diff>
--- a/yunqi-2026-agenda-201/docs/洞察一页-08-容器服务 × 小红书：大模型推理与 Agent RL.pptx
+++ b/yunqi-2026-agenda-201/docs/洞察一页-08-容器服务 × 小红书：大模型推理与 Agent RL.pptx
@@ -7,6 +7,7 @@
   <p:sldIdLst>
     <p:sldId id="256" r:id="rId7"/>
     <p:sldId id="257" r:id="rId8"/>
+    <p:sldId id="258" r:id="rId9"/>
   </p:sldIdLst>
   <p:sldSz cx="12191695" cy="6858000" type="screen4x3"/>
   <p:notesSz cx="6858000" cy="9144000"/>
@@ -3141,7 +3142,7 @@
         <p:spPr>
           <a:xfrm>
             <a:off x="0" y="0"/>
-            <a:ext cx="12191695" cy="1097280"/>
+            <a:ext cx="12191695" cy="1078992"/>
           </a:xfrm>
           <a:prstGeom prst="rect">
             <a:avLst/>
@@ -3206,7 +3207,7 @@
                 <a:latin typeface="Microsoft YaHei"/>
                 <a:ea typeface="Microsoft YaHei"/>
               </a:rPr>
-              <a:t>08 · 车漾 / 熊峰 · 阿里云容器服务 / 小红书</a:t>
+              <a:t>08 · 车漾 / 熊峰 · 阿里云容器服务 ACK × 小红书</a:t>
             </a:r>
           </a:p>
         </p:txBody>
@@ -3220,7 +3221,7 @@
         <p:spPr>
           <a:xfrm>
             <a:off x="320040" y="347472"/>
-            <a:ext cx="11521440" cy="658368"/>
+            <a:ext cx="11521440" cy="640080"/>
           </a:xfrm>
           <a:prstGeom prst="rect">
             <a:avLst/>
@@ -3242,7 +3243,7 @@
                 <a:latin typeface="Microsoft YaHei"/>
                 <a:ea typeface="Microsoft YaHei"/>
               </a:rPr>
-              <a:t>洞察：Cost/Token 是推理平台经营与技术的共同北极星，Serving Stack 需全链路可归因。</a:t>
+              <a:t>洞察：以 Cost/Token 为北极星——降 GPU 单价、抬单卡吞吐、抬利用率三杠杆并用；ACK AI Serving Stack（网关 + InferenceKit + ModelScale）直接打在分母上</a:t>
             </a:r>
           </a:p>
         </p:txBody>
@@ -3255,8 +3256,8 @@
         </p:nvSpPr>
         <p:spPr>
           <a:xfrm>
-            <a:off x="274320" y="1207008"/>
-            <a:ext cx="11612880" cy="749808"/>
+            <a:off x="274320" y="1188720"/>
+            <a:ext cx="11612880" cy="713232"/>
           </a:xfrm>
           <a:prstGeom prst="rect">
             <a:avLst/>
@@ -3301,7 +3302,7 @@
         <p:spPr>
           <a:xfrm>
             <a:off x="411480" y="1261872"/>
-            <a:ext cx="11338560" cy="640080"/>
+            <a:ext cx="11338560" cy="585216"/>
           </a:xfrm>
           <a:prstGeom prst="rect">
             <a:avLst/>
@@ -3323,7 +3324,7 @@
                 <a:latin typeface="Microsoft YaHei"/>
                 <a:ea typeface="Microsoft YaHei"/>
               </a:rPr>
-              <a:t>一句话判断：小红书 Agent Sandbox / ACK——以 Cost per Token 为 Day1 北极星，通过 ACK AI Serving Stack（推理网关、InferenceKit、Mooncake/ModelScale 权重分发、分布式 KV）与小红书侧静态 PD→RBG 多角色编排、动态 PD 弹性及 Agent Sandbox/Rollout 管线，把冷启动、吞吐、发布与 RL 轨迹成本压到生产可接受区间。</a:t>
+              <a:t>一句话判断：阿里云 ACK × 小红书——Cost/Million Tokens = GPU 小时成本 ÷ (Throughput × Utilization)；NVIDIA 亦将 Cost per token 定义为推理 TCO 指标。网关智能路由（TTFT -75%、ITL -40%、吞吐 3×）+ ModelScale 权重秒级加载 + InferenceKit 注入式拓扑优化，把单卡效率做成可复制平台能力。</a:t>
             </a:r>
           </a:p>
         </p:txBody>
@@ -3336,8 +3337,8 @@
         </p:nvSpPr>
         <p:spPr>
           <a:xfrm>
-            <a:off x="274320" y="2084831"/>
-            <a:ext cx="3749039" cy="2267712"/>
+            <a:off x="274320" y="2029968"/>
+            <a:ext cx="3749039" cy="2331720"/>
           </a:xfrm>
           <a:prstGeom prst="rect">
             <a:avLst/>
@@ -3381,7 +3382,7 @@
         </p:nvSpPr>
         <p:spPr>
           <a:xfrm>
-            <a:off x="402336" y="2176271"/>
+            <a:off x="402336" y="2121408"/>
             <a:ext cx="3493007" cy="292608"/>
           </a:xfrm>
           <a:prstGeom prst="rect">
@@ -3404,7 +3405,7 @@
                 <a:latin typeface="Microsoft YaHei"/>
                 <a:ea typeface="Microsoft YaHei"/>
               </a:rPr>
-              <a:t>01  Cost per Token</a:t>
+              <a:t>01  Cost/Token 三杠杆</a:t>
             </a:r>
           </a:p>
         </p:txBody>
@@ -3417,8 +3418,8 @@
         </p:nvSpPr>
         <p:spPr>
           <a:xfrm>
-            <a:off x="402336" y="2487167"/>
-            <a:ext cx="3493007" cy="1764792"/>
+            <a:off x="402336" y="2432304"/>
+            <a:ext cx="3493007" cy="1828800"/>
           </a:xfrm>
           <a:prstGeom prst="rect">
             <a:avLst/>
@@ -3444,7 +3445,7 @@
                 <a:latin typeface="Microsoft YaHei"/>
                 <a:ea typeface="Microsoft YaHei"/>
               </a:rPr>
-              <a:t>推理经营看板应以 Cost/Token（或 Token 毛利）替代单纯卡时售卖</a:t>
+              <a:t>公式：GPU Cost/Hour ÷ (Throughput × Utilization)</a:t>
             </a:r>
           </a:p>
           <a:p>
@@ -3461,7 +3462,7 @@
                 <a:latin typeface="Microsoft YaHei"/>
                 <a:ea typeface="Microsoft YaHei"/>
               </a:rPr>
-              <a:t>• 公式：Cost per Million Tokens = GPU 小时成本 / (吞吐 tokens/s × GPU 利用率)</a:t>
+              <a:t>• 分子：GPU 选型、潮汐混部、Spot 降单位成本</a:t>
             </a:r>
           </a:p>
           <a:p>
@@ -3478,7 +3479,7 @@
                 <a:latin typeface="Microsoft YaHei"/>
                 <a:ea typeface="Microsoft YaHei"/>
               </a:rPr>
-              <a:t>• 分子降本：GPU 选型、潮汐混部、Spot。</a:t>
+              <a:t>• 分母吞吐：PD 分离、EP/DP、KVCache Offload/Reuse</a:t>
             </a:r>
           </a:p>
           <a:p>
@@ -3495,7 +3496,7 @@
                 <a:latin typeface="Microsoft YaHei"/>
                 <a:ea typeface="Microsoft YaHei"/>
               </a:rPr>
-              <a:t>• 分母提效：PD 分离、EP/DP 并行、KVCache Offload/复用</a:t>
+              <a:t>• 分母利用率：弹性伸缩、KV 感知路由、数据缓存</a:t>
             </a:r>
           </a:p>
         </p:txBody>
@@ -3508,8 +3509,8 @@
         </p:nvSpPr>
         <p:spPr>
           <a:xfrm>
-            <a:off x="4187951" y="2084831"/>
-            <a:ext cx="3749039" cy="2267712"/>
+            <a:off x="4187951" y="2029968"/>
+            <a:ext cx="3749039" cy="2331720"/>
           </a:xfrm>
           <a:prstGeom prst="rect">
             <a:avLst/>
@@ -3553,7 +3554,7 @@
         </p:nvSpPr>
         <p:spPr>
           <a:xfrm>
-            <a:off x="4315967" y="2176271"/>
+            <a:off x="4315967" y="2121408"/>
             <a:ext cx="3493007" cy="292608"/>
           </a:xfrm>
           <a:prstGeom prst="rect">
@@ -3576,7 +3577,7 @@
                 <a:latin typeface="Microsoft YaHei"/>
                 <a:ea typeface="Microsoft YaHei"/>
               </a:rPr>
-              <a:t>02  全链路降 Token 成本</a:t>
+              <a:t>02  Serving Stack 三件套</a:t>
             </a:r>
           </a:p>
         </p:txBody>
@@ -3589,8 +3590,8 @@
         </p:nvSpPr>
         <p:spPr>
           <a:xfrm>
-            <a:off x="4315967" y="2487167"/>
-            <a:ext cx="3493007" cy="1764792"/>
+            <a:off x="4315967" y="2432304"/>
+            <a:ext cx="3493007" cy="1828800"/>
           </a:xfrm>
           <a:prstGeom prst="rect">
             <a:avLst/>
@@ -3616,7 +3617,7 @@
                 <a:latin typeface="Microsoft YaHei"/>
                 <a:ea typeface="Microsoft YaHei"/>
               </a:rPr>
-              <a:t>对标打造「推理网关 + 引擎注入层 + 权重/KV 分发 + PD 编排」完整 Serving Stack，而不是只封装开源引擎</a:t>
+              <a:t>每层能力都直接作用于降本</a:t>
             </a:r>
           </a:p>
           <a:p>
@@ -3633,7 +3634,7 @@
                 <a:latin typeface="Microsoft YaHei"/>
                 <a:ea typeface="Microsoft YaHei"/>
               </a:rPr>
-              <a:t>• 栈结构：ACK 推理网关 → 模型层 → InferenceKit（Webhook/Python Wrapper/进程内插件三级注入：启动加速、NUMA、投机解码）→ RBG/LWS 负载管理（vLLM/SGLang/TRT-LLM/lm-deploy，TP/PP/EP，PD 分离 + 外置分布式 KV）→ ModelScale 权重缓存（Mooncake RDMA P2P）→ 灵骏/ECS/EGS + eRDMA/CPFS</a:t>
+              <a:t>• ModelScale：RDMA+GDR 分层权重，P2P 随规模扩展</a:t>
             </a:r>
           </a:p>
           <a:p>
@@ -3650,7 +3651,24 @@
                 <a:latin typeface="Microsoft YaHei"/>
                 <a:ea typeface="Microsoft YaHei"/>
               </a:rPr>
-              <a:t>• 实测相对开源基线显著提升冷启与场景吞吐。</a:t>
+              <a:t>• InferenceKit：Webhook→Wrapper→插件，无静默自证</a:t>
+            </a:r>
+          </a:p>
+          <a:p>
+            <a:pPr algn="l">
+              <a:spcAft>
+                <a:spcPts val="200"/>
+              </a:spcAft>
+            </a:pPr>
+            <a:r>
+              <a:rPr sz="1100" b="0">
+                <a:solidFill>
+                  <a:srgbClr val="4A4A4A"/>
+                </a:solidFill>
+                <a:latin typeface="Microsoft YaHei"/>
+                <a:ea typeface="Microsoft YaHei"/>
+              </a:rPr>
+              <a:t>• 推理网关：公平调度 + 负载感知 + 缓存亲和路由</a:t>
             </a:r>
           </a:p>
         </p:txBody>
@@ -3663,8 +3681,8 @@
         </p:nvSpPr>
         <p:spPr>
           <a:xfrm>
-            <a:off x="8101582" y="2084831"/>
-            <a:ext cx="3749039" cy="2267712"/>
+            <a:off x="8101582" y="2029968"/>
+            <a:ext cx="3749039" cy="2331720"/>
           </a:xfrm>
           <a:prstGeom prst="rect">
             <a:avLst/>
@@ -3708,7 +3726,7 @@
         </p:nvSpPr>
         <p:spPr>
           <a:xfrm>
-            <a:off x="8229598" y="2176271"/>
+            <a:off x="8229598" y="2121408"/>
             <a:ext cx="3493007" cy="292608"/>
           </a:xfrm>
           <a:prstGeom prst="rect">
@@ -3731,7 +3749,7 @@
                 <a:latin typeface="Microsoft YaHei"/>
                 <a:ea typeface="Microsoft YaHei"/>
               </a:rPr>
-              <a:t>03  RDMA 原生权重分层搬运</a:t>
+              <a:t>03  关键实测收益</a:t>
             </a:r>
           </a:p>
         </p:txBody>
@@ -3744,8 +3762,8 @@
         </p:nvSpPr>
         <p:spPr>
           <a:xfrm>
-            <a:off x="8229598" y="2487167"/>
-            <a:ext cx="3493007" cy="1764792"/>
+            <a:off x="8229598" y="2432304"/>
+            <a:ext cx="3493007" cy="1828800"/>
           </a:xfrm>
           <a:prstGeom prst="rect">
             <a:avLst/>
@@ -3771,7 +3789,7 @@
                 <a:latin typeface="Microsoft YaHei"/>
                 <a:ea typeface="Microsoft YaHei"/>
               </a:rPr>
-              <a:t>专属云若无 RDMA/GDR 与分布式权重缓存，大模型弹性扩容会卡在分钟级加载</a:t>
+              <a:t>从加载、路由到场景吞吐全面兑现</a:t>
             </a:r>
           </a:p>
           <a:p>
@@ -3788,7 +3806,7 @@
                 <a:latin typeface="Microsoft YaHei"/>
                 <a:ea typeface="Microsoft YaHei"/>
               </a:rPr>
-              <a:t>• 痛点：TCP/无 GDR/无 P2P/存储带宽不随弹性扩展，导致百 GB–TB 级权重加载拖垮冷启与弹性 SLA。</a:t>
+              <a:t>• 模型加载 120s → 20s（ModelScale + Mooncake）</a:t>
             </a:r>
           </a:p>
           <a:p>
@@ -3805,7 +3823,24 @@
                 <a:latin typeface="Microsoft YaHei"/>
                 <a:ea typeface="Microsoft YaHei"/>
               </a:rPr>
-              <a:t>• 方案：冷（OSS）→ 温（Mooncake DRAM/SSD）→ 热（FlashGPU HBM）</a:t>
+              <a:t>• Agent Coding 2.69× / RAG 1.44× / 写作 1.80×</a:t>
+            </a:r>
+          </a:p>
+          <a:p>
+            <a:pPr algn="l">
+              <a:spcAft>
+                <a:spcPts val="200"/>
+              </a:spcAft>
+            </a:pPr>
+            <a:r>
+              <a:rPr sz="1100" b="0">
+                <a:solidFill>
+                  <a:srgbClr val="4A4A4A"/>
+                </a:solidFill>
+                <a:latin typeface="Microsoft YaHei"/>
+                <a:ea typeface="Microsoft YaHei"/>
+              </a:rPr>
+              <a:t>• Qwen3-32B P2P 加载相对 OSS 提速约 13.5×</a:t>
             </a:r>
           </a:p>
         </p:txBody>
@@ -3818,8 +3853,8 @@
         </p:nvSpPr>
         <p:spPr>
           <a:xfrm>
-            <a:off x="274320" y="4553712"/>
-            <a:ext cx="7315200" cy="237744"/>
+            <a:off x="274320" y="4498848"/>
+            <a:ext cx="9144000" cy="237744"/>
           </a:xfrm>
           <a:prstGeom prst="rect">
             <a:avLst/>
@@ -3854,8 +3889,8 @@
         </p:nvSpPr>
         <p:spPr>
           <a:xfrm>
-            <a:off x="274320" y="4809744"/>
-            <a:ext cx="1874519" cy="960120"/>
+            <a:off x="274320" y="4754880"/>
+            <a:ext cx="1874519" cy="914400"/>
           </a:xfrm>
           <a:prstGeom prst="rect">
             <a:avLst/>
@@ -3899,7 +3934,7 @@
         </p:nvSpPr>
         <p:spPr>
           <a:xfrm>
-            <a:off x="365760" y="4864608"/>
+            <a:off x="365760" y="4809744"/>
             <a:ext cx="1709927" cy="201168"/>
           </a:xfrm>
           <a:prstGeom prst="rect">
@@ -3922,7 +3957,7 @@
                 <a:latin typeface="Microsoft YaHei"/>
                 <a:ea typeface="Microsoft YaHei"/>
               </a:rPr>
-              <a:t>RAG 1.44x；长文写作</a:t>
+              <a:t>网关 TTFT</a:t>
             </a:r>
           </a:p>
         </p:txBody>
@@ -3935,7 +3970,7 @@
         </p:nvSpPr>
         <p:spPr>
           <a:xfrm>
-            <a:off x="365760" y="5065776"/>
+            <a:off x="365760" y="5010912"/>
             <a:ext cx="1709927" cy="256032"/>
           </a:xfrm>
           <a:prstGeom prst="rect">
@@ -3958,7 +3993,7 @@
                 <a:latin typeface="Microsoft YaHei"/>
                 <a:ea typeface="Microsoft YaHei"/>
               </a:rPr>
-              <a:t>全链路降 Token 成本</a:t>
+              <a:t>典型测试场景</a:t>
             </a:r>
           </a:p>
         </p:txBody>
@@ -3971,8 +4006,8 @@
         </p:nvSpPr>
         <p:spPr>
           <a:xfrm>
-            <a:off x="365760" y="5340096"/>
-            <a:ext cx="1709927" cy="365760"/>
+            <a:off x="365760" y="5266944"/>
+            <a:ext cx="1709927" cy="329184"/>
           </a:xfrm>
           <a:prstGeom prst="rect">
             <a:avLst/>
@@ -3987,14 +4022,14 @@
           <a:p>
             <a:pPr algn="l"/>
             <a:r>
-              <a:rPr sz="1200" b="1">
+              <a:rPr sz="1400" b="1">
                 <a:solidFill>
                   <a:srgbClr val="8B1A2B"/>
                 </a:solidFill>
                 <a:latin typeface="Microsoft YaHei"/>
                 <a:ea typeface="Microsoft YaHei"/>
               </a:rPr>
-              <a:t>1.80x</a:t>
+              <a:t>-75%</a:t>
             </a:r>
           </a:p>
         </p:txBody>
@@ -4007,8 +4042,8 @@
         </p:nvSpPr>
         <p:spPr>
           <a:xfrm>
-            <a:off x="2240279" y="4809744"/>
-            <a:ext cx="1874519" cy="960120"/>
+            <a:off x="2240279" y="4754880"/>
+            <a:ext cx="1874519" cy="914400"/>
           </a:xfrm>
           <a:prstGeom prst="rect">
             <a:avLst/>
@@ -4052,7 +4087,7 @@
         </p:nvSpPr>
         <p:spPr>
           <a:xfrm>
-            <a:off x="2331719" y="4864608"/>
+            <a:off x="2331719" y="4809744"/>
             <a:ext cx="1709927" cy="201168"/>
           </a:xfrm>
           <a:prstGeom prst="rect">
@@ -4075,7 +4110,7 @@
                 <a:latin typeface="Microsoft YaHei"/>
                 <a:ea typeface="Microsoft YaHei"/>
               </a:rPr>
-              <a:t>P2P 相对 OSS</a:t>
+              <a:t>网关 ITL</a:t>
             </a:r>
           </a:p>
         </p:txBody>
@@ -4088,7 +4123,7 @@
         </p:nvSpPr>
         <p:spPr>
           <a:xfrm>
-            <a:off x="2331719" y="5065776"/>
+            <a:off x="2331719" y="5010912"/>
             <a:ext cx="1709927" cy="256032"/>
           </a:xfrm>
           <a:prstGeom prst="rect">
@@ -4111,7 +4146,7 @@
                 <a:latin typeface="Microsoft YaHei"/>
                 <a:ea typeface="Microsoft YaHei"/>
               </a:rPr>
-              <a:t>Modelet 五链路实测</a:t>
+              <a:t>典型测试场景</a:t>
             </a:r>
           </a:p>
         </p:txBody>
@@ -4124,8 +4159,8 @@
         </p:nvSpPr>
         <p:spPr>
           <a:xfrm>
-            <a:off x="2331719" y="5340096"/>
-            <a:ext cx="1709927" cy="365760"/>
+            <a:off x="2331719" y="5266944"/>
+            <a:ext cx="1709927" cy="329184"/>
           </a:xfrm>
           <a:prstGeom prst="rect">
             <a:avLst/>
@@ -4140,14 +4175,14 @@
           <a:p>
             <a:pPr algn="l"/>
             <a:r>
-              <a:rPr sz="1200" b="1">
+              <a:rPr sz="1400" b="1">
                 <a:solidFill>
                   <a:srgbClr val="8B1A2B"/>
                 </a:solidFill>
                 <a:latin typeface="Microsoft YaHei"/>
                 <a:ea typeface="Microsoft YaHei"/>
               </a:rPr>
-              <a:t>约 9–13.5x</a:t>
+              <a:t>-40%</a:t>
             </a:r>
           </a:p>
         </p:txBody>
@@ -4160,8 +4195,8 @@
         </p:nvSpPr>
         <p:spPr>
           <a:xfrm>
-            <a:off x="4206238" y="4809744"/>
-            <a:ext cx="1874519" cy="960120"/>
+            <a:off x="4206238" y="4754880"/>
+            <a:ext cx="1874519" cy="914400"/>
           </a:xfrm>
           <a:prstGeom prst="rect">
             <a:avLst/>
@@ -4205,7 +4240,7 @@
         </p:nvSpPr>
         <p:spPr>
           <a:xfrm>
-            <a:off x="4297678" y="4864608"/>
+            <a:off x="4297678" y="4809744"/>
             <a:ext cx="1709927" cy="201168"/>
           </a:xfrm>
           <a:prstGeom prst="rect">
@@ -4228,7 +4263,7 @@
                 <a:latin typeface="Microsoft YaHei"/>
                 <a:ea typeface="Microsoft YaHei"/>
               </a:rPr>
-              <a:t>全链路降 Token 成本</a:t>
+              <a:t>网关吞吐</a:t>
             </a:r>
           </a:p>
         </p:txBody>
@@ -4241,7 +4276,7 @@
         </p:nvSpPr>
         <p:spPr>
           <a:xfrm>
-            <a:off x="4297678" y="5065776"/>
+            <a:off x="4297678" y="5010912"/>
             <a:ext cx="1709927" cy="256032"/>
           </a:xfrm>
           <a:prstGeom prst="rect">
@@ -4264,7 +4299,7 @@
                 <a:latin typeface="Microsoft YaHei"/>
                 <a:ea typeface="Microsoft YaHei"/>
               </a:rPr>
-              <a:t>模型加载：120s</a:t>
+              <a:t>典型测试场景</a:t>
             </a:r>
           </a:p>
         </p:txBody>
@@ -4277,8 +4312,8 @@
         </p:nvSpPr>
         <p:spPr>
           <a:xfrm>
-            <a:off x="4297678" y="5340096"/>
-            <a:ext cx="1709927" cy="365760"/>
+            <a:off x="4297678" y="5266944"/>
+            <a:ext cx="1709927" cy="329184"/>
           </a:xfrm>
           <a:prstGeom prst="rect">
             <a:avLst/>
@@ -4293,14 +4328,14 @@
           <a:p>
             <a:pPr algn="l"/>
             <a:r>
-              <a:rPr sz="1200" b="1">
+              <a:rPr sz="1400" b="1">
                 <a:solidFill>
                   <a:srgbClr val="8B1A2B"/>
                 </a:solidFill>
                 <a:latin typeface="Microsoft YaHei"/>
                 <a:ea typeface="Microsoft YaHei"/>
               </a:rPr>
-              <a:t>20s（约 6x）</a:t>
+              <a:t>3×</a:t>
             </a:r>
           </a:p>
         </p:txBody>
@@ -4313,8 +4348,8 @@
         </p:nvSpPr>
         <p:spPr>
           <a:xfrm>
-            <a:off x="6172197" y="4809744"/>
-            <a:ext cx="1874519" cy="960120"/>
+            <a:off x="6172197" y="4754880"/>
+            <a:ext cx="1874519" cy="914400"/>
           </a:xfrm>
           <a:prstGeom prst="rect">
             <a:avLst/>
@@ -4358,7 +4393,7 @@
         </p:nvSpPr>
         <p:spPr>
           <a:xfrm>
-            <a:off x="6263637" y="4864608"/>
+            <a:off x="6263637" y="4809744"/>
             <a:ext cx="1709927" cy="201168"/>
           </a:xfrm>
           <a:prstGeom prst="rect">
@@ -4381,7 +4416,7 @@
                 <a:latin typeface="Microsoft YaHei"/>
                 <a:ea typeface="Microsoft YaHei"/>
               </a:rPr>
-              <a:t>Agentic Coding 吞吐</a:t>
+              <a:t>权重加载</a:t>
             </a:r>
           </a:p>
         </p:txBody>
@@ -4394,7 +4429,7 @@
         </p:nvSpPr>
         <p:spPr>
           <a:xfrm>
-            <a:off x="6263637" y="5065776"/>
+            <a:off x="6263637" y="5010912"/>
             <a:ext cx="1709927" cy="256032"/>
           </a:xfrm>
           <a:prstGeom prst="rect">
@@ -4417,7 +4452,7 @@
                 <a:latin typeface="Microsoft YaHei"/>
                 <a:ea typeface="Microsoft YaHei"/>
               </a:rPr>
-              <a:t>全链路降 Token 成本</a:t>
+              <a:t>120s → 20s</a:t>
             </a:r>
           </a:p>
         </p:txBody>
@@ -4430,8 +4465,8 @@
         </p:nvSpPr>
         <p:spPr>
           <a:xfrm>
-            <a:off x="6263637" y="5340096"/>
-            <a:ext cx="1709927" cy="365760"/>
+            <a:off x="6263637" y="5266944"/>
+            <a:ext cx="1709927" cy="329184"/>
           </a:xfrm>
           <a:prstGeom prst="rect">
             <a:avLst/>
@@ -4446,14 +4481,14 @@
           <a:p>
             <a:pPr algn="l"/>
             <a:r>
-              <a:rPr sz="1200" b="1">
+              <a:rPr sz="1400" b="1">
                 <a:solidFill>
                   <a:srgbClr val="8B1A2B"/>
                 </a:solidFill>
                 <a:latin typeface="Microsoft YaHei"/>
                 <a:ea typeface="Microsoft YaHei"/>
               </a:rPr>
-              <a:t>2.69x</a:t>
+              <a:t>约 6×</a:t>
             </a:r>
           </a:p>
         </p:txBody>
@@ -4466,8 +4501,8 @@
         </p:nvSpPr>
         <p:spPr>
           <a:xfrm>
-            <a:off x="8138156" y="4809744"/>
-            <a:ext cx="1874519" cy="960120"/>
+            <a:off x="8138156" y="4754880"/>
+            <a:ext cx="1874519" cy="914400"/>
           </a:xfrm>
           <a:prstGeom prst="rect">
             <a:avLst/>
@@ -4511,7 +4546,7 @@
         </p:nvSpPr>
         <p:spPr>
           <a:xfrm>
-            <a:off x="8229596" y="4864608"/>
+            <a:off x="8229596" y="4809744"/>
             <a:ext cx="1709927" cy="201168"/>
           </a:xfrm>
           <a:prstGeom prst="rect">
@@ -4534,7 +4569,7 @@
                 <a:latin typeface="Microsoft YaHei"/>
                 <a:ea typeface="Microsoft YaHei"/>
               </a:rPr>
-              <a:t>小红书静态 PD</a:t>
+              <a:t>P2P vs OSS</a:t>
             </a:r>
           </a:p>
         </p:txBody>
@@ -4547,7 +4582,7 @@
         </p:nvSpPr>
         <p:spPr>
           <a:xfrm>
-            <a:off x="8229596" y="5065776"/>
+            <a:off x="8229596" y="5010912"/>
             <a:ext cx="1709927" cy="256032"/>
           </a:xfrm>
           <a:prstGeom prst="rect">
@@ -4570,7 +4605,7 @@
                 <a:latin typeface="Microsoft YaHei"/>
                 <a:ea typeface="Microsoft YaHei"/>
               </a:rPr>
-              <a:t>升级耗时：数十分钟</a:t>
+              <a:t>Qwen3-32B 65GB</a:t>
             </a:r>
           </a:p>
         </p:txBody>
@@ -4583,8 +4618,8 @@
         </p:nvSpPr>
         <p:spPr>
           <a:xfrm>
-            <a:off x="8229596" y="5340096"/>
-            <a:ext cx="1709927" cy="365760"/>
+            <a:off x="8229596" y="5266944"/>
+            <a:ext cx="1709927" cy="329184"/>
           </a:xfrm>
           <a:prstGeom prst="rect">
             <a:avLst/>
@@ -4599,14 +4634,14 @@
           <a:p>
             <a:pPr algn="l"/>
             <a:r>
-              <a:rPr sz="1200" b="1">
+              <a:rPr sz="1400" b="1">
                 <a:solidFill>
                   <a:srgbClr val="8B1A2B"/>
                 </a:solidFill>
                 <a:latin typeface="Microsoft YaHei"/>
                 <a:ea typeface="Microsoft YaHei"/>
               </a:rPr>
-              <a:t>数分钟</a:t>
+              <a:t>13.5×</a:t>
             </a:r>
           </a:p>
         </p:txBody>
@@ -4619,8 +4654,8 @@
         </p:nvSpPr>
         <p:spPr>
           <a:xfrm>
-            <a:off x="10104115" y="4809744"/>
-            <a:ext cx="1874519" cy="960120"/>
+            <a:off x="10104115" y="4754880"/>
+            <a:ext cx="1874519" cy="914400"/>
           </a:xfrm>
           <a:prstGeom prst="rect">
             <a:avLst/>
@@ -4664,7 +4699,7 @@
         </p:nvSpPr>
         <p:spPr>
           <a:xfrm>
-            <a:off x="10195555" y="4864608"/>
+            <a:off x="10195555" y="4809744"/>
             <a:ext cx="1709927" cy="201168"/>
           </a:xfrm>
           <a:prstGeom prst="rect">
@@ -4687,7 +4722,7 @@
                 <a:latin typeface="Microsoft YaHei"/>
                 <a:ea typeface="Microsoft YaHei"/>
               </a:rPr>
-              <a:t>目标</a:t>
+              <a:t>跨 NUMA 代价</a:t>
             </a:r>
           </a:p>
         </p:txBody>
@@ -4700,7 +4735,7 @@
         </p:nvSpPr>
         <p:spPr>
           <a:xfrm>
-            <a:off x="10195555" y="5065776"/>
+            <a:off x="10195555" y="5010912"/>
             <a:ext cx="1709927" cy="256032"/>
           </a:xfrm>
           <a:prstGeom prst="rect">
@@ -4723,7 +4758,7 @@
                 <a:latin typeface="Microsoft YaHei"/>
                 <a:ea typeface="Microsoft YaHei"/>
               </a:rPr>
-              <a:t>RDMA 原生权重分层搬运</a:t>
+              <a:t>吞吐劣化</a:t>
             </a:r>
           </a:p>
         </p:txBody>
@@ -4736,8 +4771,8 @@
         </p:nvSpPr>
         <p:spPr>
           <a:xfrm>
-            <a:off x="10195555" y="5340096"/>
-            <a:ext cx="1709927" cy="365760"/>
+            <a:off x="10195555" y="5266944"/>
+            <a:ext cx="1709927" cy="329184"/>
           </a:xfrm>
           <a:prstGeom prst="rect">
             <a:avLst/>
@@ -4752,14 +4787,14 @@
           <a:p>
             <a:pPr algn="l"/>
             <a:r>
-              <a:rPr sz="1200" b="1">
+              <a:rPr sz="1400" b="1">
                 <a:solidFill>
                   <a:srgbClr val="8B1A2B"/>
                 </a:solidFill>
                 <a:latin typeface="Microsoft YaHei"/>
                 <a:ea typeface="Microsoft YaHei"/>
               </a:rPr>
-              <a:t>权重加载进入秒级时代</a:t>
+              <a:t>-13.4%</a:t>
             </a:r>
           </a:p>
         </p:txBody>
@@ -4772,8 +4807,8 @@
         </p:nvSpPr>
         <p:spPr>
           <a:xfrm>
-            <a:off x="0" y="5870448"/>
-            <a:ext cx="12191695" cy="987552"/>
+            <a:off x="0" y="5852160"/>
+            <a:ext cx="12191695" cy="1005840"/>
           </a:xfrm>
           <a:prstGeom prst="rect">
             <a:avLst/>
@@ -4815,8 +4850,8 @@
         </p:nvSpPr>
         <p:spPr>
           <a:xfrm>
-            <a:off x="320040" y="5943600"/>
-            <a:ext cx="11521440" cy="502920"/>
+            <a:off x="320040" y="5925312"/>
+            <a:ext cx="11521440" cy="457200"/>
           </a:xfrm>
           <a:prstGeom prst="rect">
             <a:avLst/>
@@ -4838,7 +4873,7 @@
                 <a:latin typeface="Microsoft YaHei"/>
                 <a:ea typeface="Microsoft YaHei"/>
               </a:rPr>
-              <a:t>启示要点：Cost/Token 是推理平台经营与技术的共同北极星，Serving Stack 需全链路可归因；权重分层（OSS→Mooncake→FlashGPU）与 PD/RBG 编排是互联网大模型生产的两块硬骨头；静态组级发布是过渡态，Role 级策略协同 + KV 感知路由 + RL 快照管线才是 Agent 时代基础设施形态。</a:t>
+              <a:t>启示要点：先立 Cost/Token 公式再选型；Serving Stack 优先打通「权重秒级加载 + 拓扑无静默注入 + KV 感知路由」；NUMA/ICN64 等拓扑错误会静默吃掉吞吐，必须 Summary 自证生效。</a:t>
             </a:r>
           </a:p>
         </p:txBody>
@@ -4851,7 +4886,7 @@
         </p:nvSpPr>
         <p:spPr>
           <a:xfrm>
-            <a:off x="320040" y="6437376"/>
+            <a:off x="320040" y="6382512"/>
             <a:ext cx="11521440" cy="256032"/>
           </a:xfrm>
           <a:prstGeom prst="rect">
@@ -4874,7 +4909,7 @@
                 <a:latin typeface="Microsoft YaHei"/>
                 <a:ea typeface="Microsoft YaHei"/>
               </a:rPr>
-              <a:t>来源：https://yunqi.aliyun.com/2026/session?agendaId=201 · Talk 08 车漾 / 熊峰</a:t>
+              <a:t>来源：https://yunqi.aliyun.com/2026/session?agendaId=201 · Talk 08 车漾 / 熊峰 · 第 1/2 页</a:t>
             </a:r>
           </a:p>
         </p:txBody>
@@ -4949,7 +4984,7 @@
         <p:spPr>
           <a:xfrm>
             <a:off x="0" y="0"/>
-            <a:ext cx="12191695" cy="868680"/>
+            <a:ext cx="12191695" cy="1005840"/>
           </a:xfrm>
           <a:prstGeom prst="rect">
             <a:avLst/>
@@ -4991,8 +5026,8 @@
         </p:nvSpPr>
         <p:spPr>
           <a:xfrm>
-            <a:off x="365760" y="146304"/>
-            <a:ext cx="11430000" cy="256032"/>
+            <a:off x="320040" y="91440"/>
+            <a:ext cx="11521440" cy="237744"/>
           </a:xfrm>
           <a:prstGeom prst="rect">
             <a:avLst/>
@@ -5014,7 +5049,7 @@
                 <a:latin typeface="Microsoft YaHei"/>
                 <a:ea typeface="Microsoft YaHei"/>
               </a:rPr>
-              <a:t>08 · 车漾 / 熊峰 · 阿里云容器服务 / 小红书</a:t>
+              <a:t>08 · 续 · 小红书推理编排演进与生产成果</a:t>
             </a:r>
           </a:p>
         </p:txBody>
@@ -5027,8 +5062,8 @@
         </p:nvSpPr>
         <p:spPr>
           <a:xfrm>
-            <a:off x="365760" y="384048"/>
-            <a:ext cx="11430000" cy="365760"/>
+            <a:off x="320040" y="347472"/>
+            <a:ext cx="11521440" cy="548640"/>
           </a:xfrm>
           <a:prstGeom prst="rect">
             <a:avLst/>
@@ -5043,14 +5078,14 @@
           <a:p>
             <a:pPr algn="l"/>
             <a:r>
-              <a:rPr sz="2200" b="1">
+              <a:rPr sz="1600" b="1">
                 <a:solidFill>
                   <a:srgbClr val="1A1A1A"/>
                 </a:solidFill>
                 <a:latin typeface="Microsoft YaHei"/>
                 <a:ea typeface="Microsoft YaHei"/>
               </a:rPr>
-              <a:t>数据佐证｜官方回放截图</a:t>
+              <a:t>洞察：性能驱动架构持续演进——从单 Pod 到静态 PD（GroupSet），再到动态 PD（RBG 角色化）；编排、调度与拓扑感知必须同步升级</a:t>
             </a:r>
           </a:p>
         </p:txBody>
@@ -5063,8 +5098,8 @@
         </p:nvSpPr>
         <p:spPr>
           <a:xfrm>
-            <a:off x="320040" y="1051560"/>
-            <a:ext cx="3716426" cy="5074920"/>
+            <a:off x="274320" y="1097280"/>
+            <a:ext cx="11612880" cy="566928"/>
           </a:xfrm>
           <a:prstGeom prst="rect">
             <a:avLst/>
@@ -5108,8 +5143,8 @@
         </p:nvSpPr>
         <p:spPr>
           <a:xfrm>
-            <a:off x="429768" y="1143000"/>
-            <a:ext cx="3496970" cy="384048"/>
+            <a:off x="411480" y="1170432"/>
+            <a:ext cx="11338560" cy="438912"/>
           </a:xfrm>
           <a:prstGeom prst="rect">
             <a:avLst/>
@@ -5126,86 +5161,26 @@
             <a:r>
               <a:rPr sz="1200" b="1">
                 <a:solidFill>
-                  <a:srgbClr val="8B1A2B"/>
-                </a:solidFill>
-                <a:latin typeface="Microsoft YaHei"/>
-                <a:ea typeface="Microsoft YaHei"/>
-              </a:rPr>
-              <a:t>北极星：Cost per Million Tokens · 三杠杆：GPU 成本 / 吞吐 / 利用率</a:t>
-            </a:r>
-          </a:p>
-        </p:txBody>
-      </p:sp>
-      <p:pic>
-        <p:nvPicPr>
-          <p:cNvPr id="8" name="Picture 7" descr="t02-52-00-crop.png"/>
-          <p:cNvPicPr>
-            <a:picLocks noChangeAspect="1"/>
-          </p:cNvPicPr>
-          <p:nvPr/>
-        </p:nvPicPr>
-        <p:blipFill>
-          <a:blip r:embed="rId2"/>
-          <a:stretch>
-            <a:fillRect/>
-          </a:stretch>
-        </p:blipFill>
-        <p:spPr>
-          <a:xfrm>
-            <a:off x="429768" y="1946380"/>
-            <a:ext cx="3496970" cy="2965239"/>
-          </a:xfrm>
-          <a:prstGeom prst="rect">
-            <a:avLst/>
-          </a:prstGeom>
-        </p:spPr>
-      </p:pic>
-      <p:sp>
-        <p:nvSpPr>
-          <p:cNvPr id="9" name="TextBox 8"/>
-          <p:cNvSpPr txBox="1"/>
-          <p:nvPr/>
-        </p:nvSpPr>
-        <p:spPr>
-          <a:xfrm>
-            <a:off x="429768" y="5486400"/>
-            <a:ext cx="3496970" cy="502920"/>
-          </a:xfrm>
-          <a:prstGeom prst="rect">
-            <a:avLst/>
-          </a:prstGeom>
-          <a:noFill/>
-        </p:spPr>
-        <p:txBody>
-          <a:bodyPr wrap="square">
-            <a:spAutoFit/>
-          </a:bodyPr>
-          <a:lstStyle/>
-          <a:p>
-            <a:pPr algn="l"/>
-            <a:r>
-              <a:rPr sz="1100" b="0">
-                <a:solidFill>
-                  <a:srgbClr val="4A4A4A"/>
-                </a:solidFill>
-                <a:latin typeface="Microsoft YaHei"/>
-                <a:ea typeface="Microsoft YaHei"/>
-              </a:rPr>
-              <a:t>Day1 北极星：Cost per Token</a:t>
-            </a:r>
-          </a:p>
-        </p:txBody>
-      </p:sp>
-      <p:sp>
-        <p:nvSpPr>
-          <p:cNvPr id="10" name="Rectangle 9"/>
+                  <a:srgbClr val="1A1A1A"/>
+                </a:solidFill>
+                <a:latin typeface="Microsoft YaHei"/>
+                <a:ea typeface="Microsoft YaHei"/>
+              </a:rPr>
+              <a:t>一句话判断：小红书 × 阿里云 ACK——同 SLO 下吞吐提升 2~3×、GPU 资源节省约 50%；生产能力沉淀为开源 RoleBasedGroup（github.com/sgl-project/rbg），适配 vLLM / SGLang。</a:t>
+            </a:r>
+          </a:p>
+        </p:txBody>
+      </p:sp>
+      <p:sp>
+        <p:nvSpPr>
+          <p:cNvPr id="8" name="Rectangle 7"/>
           <p:cNvSpPr/>
           <p:nvPr/>
         </p:nvSpPr>
         <p:spPr>
           <a:xfrm>
-            <a:off x="4237634" y="1051560"/>
-            <a:ext cx="3716426" cy="5074920"/>
+            <a:off x="274320" y="1810512"/>
+            <a:ext cx="3749039" cy="2468880"/>
           </a:xfrm>
           <a:prstGeom prst="rect">
             <a:avLst/>
@@ -5243,14 +5218,14 @@
       </p:sp>
       <p:sp>
         <p:nvSpPr>
-          <p:cNvPr id="11" name="TextBox 10"/>
+          <p:cNvPr id="9" name="TextBox 8"/>
           <p:cNvSpPr txBox="1"/>
           <p:nvPr/>
         </p:nvSpPr>
         <p:spPr>
           <a:xfrm>
-            <a:off x="4347362" y="1143000"/>
-            <a:ext cx="3496970" cy="384048"/>
+            <a:off x="402336" y="1901952"/>
+            <a:ext cx="3493007" cy="292608"/>
           </a:xfrm>
           <a:prstGeom prst="rect">
             <a:avLst/>
@@ -5265,52 +5240,28 @@
           <a:p>
             <a:pPr algn="l"/>
             <a:r>
-              <a:rPr sz="1200" b="1">
+              <a:rPr sz="1400" b="1">
                 <a:solidFill>
                   <a:srgbClr val="8B1A2B"/>
                 </a:solidFill>
                 <a:latin typeface="Microsoft YaHei"/>
                 <a:ea typeface="Microsoft YaHei"/>
               </a:rPr>
-              <a:t>模型加载：120s → 20s（约 6x） · Agentic Coding 吞吐 2.69x</a:t>
-            </a:r>
-          </a:p>
-        </p:txBody>
-      </p:sp>
-      <p:pic>
-        <p:nvPicPr>
-          <p:cNvPr id="12" name="Picture 11" descr="t02-54-00-crop.png"/>
-          <p:cNvPicPr>
-            <a:picLocks noChangeAspect="1"/>
-          </p:cNvPicPr>
-          <p:nvPr/>
-        </p:nvPicPr>
-        <p:blipFill>
-          <a:blip r:embed="rId3"/>
-          <a:stretch>
-            <a:fillRect/>
-          </a:stretch>
-        </p:blipFill>
-        <p:spPr>
-          <a:xfrm>
-            <a:off x="4347362" y="1946380"/>
-            <a:ext cx="3496970" cy="2965239"/>
-          </a:xfrm>
-          <a:prstGeom prst="rect">
-            <a:avLst/>
-          </a:prstGeom>
-        </p:spPr>
-      </p:pic>
-      <p:sp>
-        <p:nvSpPr>
-          <p:cNvPr id="13" name="TextBox 12"/>
+              <a:t>01  静态 PD：GroupSet</a:t>
+            </a:r>
+          </a:p>
+        </p:txBody>
+      </p:sp>
+      <p:sp>
+        <p:nvSpPr>
+          <p:cNvPr id="10" name="TextBox 9"/>
           <p:cNvSpPr txBox="1"/>
           <p:nvPr/>
         </p:nvSpPr>
         <p:spPr>
           <a:xfrm>
-            <a:off x="4347362" y="5486400"/>
-            <a:ext cx="3496970" cy="502920"/>
+            <a:off x="402336" y="2212848"/>
+            <a:ext cx="3493007" cy="1965960"/>
           </a:xfrm>
           <a:prstGeom prst="rect">
             <a:avLst/>
@@ -5323,7 +5274,28 @@
           </a:bodyPr>
           <a:lstStyle/>
           <a:p>
-            <a:pPr algn="l"/>
+            <a:pPr algn="l">
+              <a:spcAft>
+                <a:spcPts val="300"/>
+              </a:spcAft>
+            </a:pPr>
+            <a:r>
+              <a:rPr sz="1100" b="1">
+                <a:solidFill>
+                  <a:srgbClr val="1A1A1A"/>
+                </a:solidFill>
+                <a:latin typeface="Microsoft YaHei"/>
+                <a:ea typeface="Microsoft YaHei"/>
+              </a:rPr>
+              <a:t>组内配比固定，弹性靠组副本数</a:t>
+            </a:r>
+          </a:p>
+          <a:p>
+            <a:pPr algn="l">
+              <a:spcAft>
+                <a:spcPts val="300"/>
+              </a:spcAft>
+            </a:pPr>
             <a:r>
               <a:rPr sz="1100" b="0">
                 <a:solidFill>
@@ -5332,21 +5304,55 @@
                 <a:latin typeface="Microsoft YaHei"/>
                 <a:ea typeface="Microsoft YaHei"/>
               </a:rPr>
-              <a:t>ACK AI Serving Stack：全链路降 Token 成本</a:t>
-            </a:r>
-          </a:p>
-        </p:txBody>
-      </p:sp>
-      <p:sp>
-        <p:nvSpPr>
-          <p:cNvPr id="14" name="Rectangle 13"/>
+              <a:t>• PodGroup 固定 P:D（如 2P:1D），Gang 成组调度</a:t>
+            </a:r>
+          </a:p>
+          <a:p>
+            <a:pPr algn="l">
+              <a:spcAft>
+                <a:spcPts val="300"/>
+              </a:spcAft>
+            </a:pPr>
+            <a:r>
+              <a:rPr sz="1100" b="0">
+                <a:solidFill>
+                  <a:srgbClr val="4A4A4A"/>
+                </a:solidFill>
+                <a:latin typeface="Microsoft YaHei"/>
+                <a:ea typeface="Microsoft YaHei"/>
+              </a:rPr>
+              <a:t>• 原地升级 + 四级缓存：镜像/权重/Kernel/KV</a:t>
+            </a:r>
+          </a:p>
+          <a:p>
+            <a:pPr algn="l">
+              <a:spcAft>
+                <a:spcPts val="300"/>
+              </a:spcAft>
+            </a:pPr>
+            <a:r>
+              <a:rPr sz="1100" b="0">
+                <a:solidFill>
+                  <a:srgbClr val="4A4A4A"/>
+                </a:solidFill>
+                <a:latin typeface="Microsoft YaHei"/>
+                <a:ea typeface="Microsoft YaHei"/>
+              </a:rPr>
+              <a:t>• 升级耗时从数十分钟 → 数分钟；分批暂停与容量底线防护</a:t>
+            </a:r>
+          </a:p>
+        </p:txBody>
+      </p:sp>
+      <p:sp>
+        <p:nvSpPr>
+          <p:cNvPr id="11" name="Rectangle 10"/>
           <p:cNvSpPr/>
           <p:nvPr/>
         </p:nvSpPr>
         <p:spPr>
           <a:xfrm>
-            <a:off x="8155228" y="1051560"/>
-            <a:ext cx="3716426" cy="5074920"/>
+            <a:off x="4187951" y="1810512"/>
+            <a:ext cx="3749039" cy="2468880"/>
           </a:xfrm>
           <a:prstGeom prst="rect">
             <a:avLst/>
@@ -5384,14 +5390,14 @@
       </p:sp>
       <p:sp>
         <p:nvSpPr>
-          <p:cNvPr id="15" name="TextBox 14"/>
+          <p:cNvPr id="12" name="TextBox 11"/>
           <p:cNvSpPr txBox="1"/>
           <p:nvPr/>
         </p:nvSpPr>
         <p:spPr>
           <a:xfrm>
-            <a:off x="8264956" y="1143000"/>
-            <a:ext cx="3496970" cy="384048"/>
+            <a:off x="4315967" y="1901952"/>
+            <a:ext cx="3493007" cy="292608"/>
           </a:xfrm>
           <a:prstGeom prst="rect">
             <a:avLst/>
@@ -5406,6 +5412,1595 @@
           <a:p>
             <a:pPr algn="l"/>
             <a:r>
+              <a:rPr sz="1400" b="1">
+                <a:solidFill>
+                  <a:srgbClr val="8B1A2B"/>
+                </a:solidFill>
+                <a:latin typeface="Microsoft YaHei"/>
+                <a:ea typeface="Microsoft YaHei"/>
+              </a:rPr>
+              <a:t>02  动态 PD：RBG</a:t>
+            </a:r>
+          </a:p>
+        </p:txBody>
+      </p:sp>
+      <p:sp>
+        <p:nvSpPr>
+          <p:cNvPr id="13" name="TextBox 12"/>
+          <p:cNvSpPr txBox="1"/>
+          <p:nvPr/>
+        </p:nvSpPr>
+        <p:spPr>
+          <a:xfrm>
+            <a:off x="4315967" y="2212848"/>
+            <a:ext cx="3493007" cy="1965960"/>
+          </a:xfrm>
+          <a:prstGeom prst="rect">
+            <a:avLst/>
+          </a:prstGeom>
+          <a:noFill/>
+        </p:spPr>
+        <p:txBody>
+          <a:bodyPr wrap="square">
+            <a:spAutoFit/>
+          </a:bodyPr>
+          <a:lstStyle/>
+          <a:p>
+            <a:pPr algn="l">
+              <a:spcAft>
+                <a:spcPts val="300"/>
+              </a:spcAft>
+            </a:pPr>
+            <a:r>
+              <a:rPr sz="1100" b="1">
+                <a:solidFill>
+                  <a:srgbClr val="1A1A1A"/>
+                </a:solidFill>
+                <a:latin typeface="Microsoft YaHei"/>
+                <a:ea typeface="Microsoft YaHei"/>
+              </a:rPr>
+              <a:t>Role 为一等编排单元，策略表达协同</a:t>
+            </a:r>
+          </a:p>
+          <a:p>
+            <a:pPr algn="l">
+              <a:spcAft>
+                <a:spcPts val="300"/>
+              </a:spcAft>
+            </a:pPr>
+            <a:r>
+              <a:rPr sz="1100" b="0">
+                <a:solidFill>
+                  <a:srgbClr val="4A4A4A"/>
+                </a:solidFill>
+                <a:latin typeface="Microsoft YaHei"/>
+                <a:ea typeface="Microsoft YaHei"/>
+              </a:rPr>
+              <a:t>• Router/Prefill/Decode/KV 各自扩缩与发布</a:t>
+            </a:r>
+          </a:p>
+          <a:p>
+            <a:pPr algn="l">
+              <a:spcAft>
+                <a:spcPts val="300"/>
+              </a:spcAft>
+            </a:pPr>
+            <a:r>
+              <a:rPr sz="1100" b="0">
+                <a:solidFill>
+                  <a:srgbClr val="4A4A4A"/>
+                </a:solidFill>
+                <a:latin typeface="Microsoft YaHei"/>
+                <a:ea typeface="Microsoft YaHei"/>
+              </a:rPr>
+              <a:t>• 双层 Gang + CoordinatedPolicy（maxSkew）</a:t>
+            </a:r>
+          </a:p>
+          <a:p>
+            <a:pPr algn="l">
+              <a:spcAft>
+                <a:spcPts val="300"/>
+              </a:spcAft>
+            </a:pPr>
+            <a:r>
+              <a:rPr sz="1100" b="0">
+                <a:solidFill>
+                  <a:srgbClr val="4A4A4A"/>
+                </a:solidFill>
+                <a:latin typeface="Microsoft YaHei"/>
+                <a:ea typeface="Microsoft YaHei"/>
+              </a:rPr>
+              <a:t>• KVCache-Aware 全局选路：命中率 + 负载健康</a:t>
+            </a:r>
+          </a:p>
+        </p:txBody>
+      </p:sp>
+      <p:sp>
+        <p:nvSpPr>
+          <p:cNvPr id="14" name="Rectangle 13"/>
+          <p:cNvSpPr/>
+          <p:nvPr/>
+        </p:nvSpPr>
+        <p:spPr>
+          <a:xfrm>
+            <a:off x="8101582" y="1810512"/>
+            <a:ext cx="3749039" cy="2468880"/>
+          </a:xfrm>
+          <a:prstGeom prst="rect">
+            <a:avLst/>
+          </a:prstGeom>
+          <a:solidFill>
+            <a:srgbClr val="FFFFFF"/>
+          </a:solidFill>
+          <a:ln w="12700">
+            <a:solidFill>
+              <a:srgbClr val="D0D8DE"/>
+            </a:solidFill>
+          </a:ln>
+        </p:spPr>
+        <p:style>
+          <a:lnRef idx="1">
+            <a:schemeClr val="accent1"/>
+          </a:lnRef>
+          <a:fillRef idx="3">
+            <a:schemeClr val="accent1"/>
+          </a:fillRef>
+          <a:effectRef idx="2">
+            <a:schemeClr val="accent1"/>
+          </a:effectRef>
+          <a:fontRef idx="minor">
+            <a:schemeClr val="lt1"/>
+          </a:fontRef>
+        </p:style>
+        <p:txBody>
+          <a:bodyPr rtlCol="0" anchor="ctr"/>
+          <a:lstStyle/>
+          <a:p>
+            <a:pPr algn="ctr"/>
+          </a:p>
+        </p:txBody>
+      </p:sp>
+      <p:sp>
+        <p:nvSpPr>
+          <p:cNvPr id="15" name="TextBox 14"/>
+          <p:cNvSpPr txBox="1"/>
+          <p:nvPr/>
+        </p:nvSpPr>
+        <p:spPr>
+          <a:xfrm>
+            <a:off x="8229598" y="1901952"/>
+            <a:ext cx="3493007" cy="292608"/>
+          </a:xfrm>
+          <a:prstGeom prst="rect">
+            <a:avLst/>
+          </a:prstGeom>
+          <a:noFill/>
+        </p:spPr>
+        <p:txBody>
+          <a:bodyPr wrap="square">
+            <a:spAutoFit/>
+          </a:bodyPr>
+          <a:lstStyle/>
+          <a:p>
+            <a:pPr algn="l"/>
+            <a:r>
+              <a:rPr sz="1400" b="1">
+                <a:solidFill>
+                  <a:srgbClr val="8B1A2B"/>
+                </a:solidFill>
+                <a:latin typeface="Microsoft YaHei"/>
+                <a:ea typeface="Microsoft YaHei"/>
+              </a:rPr>
+              <a:t>03  RL 与工具链延伸</a:t>
+            </a:r>
+          </a:p>
+        </p:txBody>
+      </p:sp>
+      <p:sp>
+        <p:nvSpPr>
+          <p:cNvPr id="16" name="TextBox 15"/>
+          <p:cNvSpPr txBox="1"/>
+          <p:nvPr/>
+        </p:nvSpPr>
+        <p:spPr>
+          <a:xfrm>
+            <a:off x="8229598" y="2212848"/>
+            <a:ext cx="3493007" cy="1965960"/>
+          </a:xfrm>
+          <a:prstGeom prst="rect">
+            <a:avLst/>
+          </a:prstGeom>
+          <a:noFill/>
+        </p:spPr>
+        <p:txBody>
+          <a:bodyPr wrap="square">
+            <a:spAutoFit/>
+          </a:bodyPr>
+          <a:lstStyle/>
+          <a:p>
+            <a:pPr algn="l">
+              <a:spcAft>
+                <a:spcPts val="300"/>
+              </a:spcAft>
+            </a:pPr>
+            <a:r>
+              <a:rPr sz="1100" b="1">
+                <a:solidFill>
+                  <a:srgbClr val="1A1A1A"/>
+                </a:solidFill>
+                <a:latin typeface="Microsoft YaHei"/>
+                <a:ea typeface="Microsoft YaHei"/>
+              </a:rPr>
+              <a:t>状态复用贯通训练与评测</a:t>
+            </a:r>
+          </a:p>
+          <a:p>
+            <a:pPr algn="l">
+              <a:spcAft>
+                <a:spcPts val="300"/>
+              </a:spcAft>
+            </a:pPr>
+            <a:r>
+              <a:rPr sz="1100" b="0">
+                <a:solidFill>
+                  <a:srgbClr val="4A4A4A"/>
+                </a:solidFill>
+                <a:latin typeface="Microsoft YaHei"/>
+                <a:ea typeface="Microsoft YaHei"/>
+              </a:rPr>
+              <a:t>• 快照四要素：rootfs / 存储 / 内存 / 轨迹 WAL</a:t>
+            </a:r>
+          </a:p>
+          <a:p>
+            <a:pPr algn="l">
+              <a:spcAft>
+                <a:spcPts val="300"/>
+              </a:spcAft>
+            </a:pPr>
+            <a:r>
+              <a:rPr sz="1100" b="0">
+                <a:solidFill>
+                  <a:srgbClr val="4A4A4A"/>
+                </a:solidFill>
+                <a:latin typeface="Microsoft YaHei"/>
+                <a:ea typeface="Microsoft YaHei"/>
+              </a:rPr>
+              <a:t>• Rollout 托管：Env 接入 + Agent Harness 管线</a:t>
+            </a:r>
+          </a:p>
+          <a:p>
+            <a:pPr algn="l">
+              <a:spcAft>
+                <a:spcPts val="300"/>
+              </a:spcAft>
+            </a:pPr>
+            <a:r>
+              <a:rPr sz="1100" b="0">
+                <a:solidFill>
+                  <a:srgbClr val="4A4A4A"/>
+                </a:solidFill>
+                <a:latin typeface="Microsoft YaHei"/>
+                <a:ea typeface="Microsoft YaHei"/>
+              </a:rPr>
+              <a:t>• arena llm：配比生成 / 自动寻优 / 一键部署</a:t>
+            </a:r>
+          </a:p>
+        </p:txBody>
+      </p:sp>
+      <p:sp>
+        <p:nvSpPr>
+          <p:cNvPr id="17" name="TextBox 16"/>
+          <p:cNvSpPr txBox="1"/>
+          <p:nvPr/>
+        </p:nvSpPr>
+        <p:spPr>
+          <a:xfrm>
+            <a:off x="274320" y="4434840"/>
+            <a:ext cx="9144000" cy="237744"/>
+          </a:xfrm>
+          <a:prstGeom prst="rect">
+            <a:avLst/>
+          </a:prstGeom>
+          <a:noFill/>
+        </p:spPr>
+        <p:txBody>
+          <a:bodyPr wrap="square">
+            <a:spAutoFit/>
+          </a:bodyPr>
+          <a:lstStyle/>
+          <a:p>
+            <a:pPr algn="l"/>
+            <a:r>
+              <a:rPr sz="1300" b="1">
+                <a:solidFill>
+                  <a:srgbClr val="1A1A1A"/>
+                </a:solidFill>
+                <a:latin typeface="Microsoft YaHei"/>
+                <a:ea typeface="Microsoft YaHei"/>
+              </a:rPr>
+              <a:t>生产成果与关键能力指标</a:t>
+            </a:r>
+          </a:p>
+        </p:txBody>
+      </p:sp>
+      <p:sp>
+        <p:nvSpPr>
+          <p:cNvPr id="18" name="Rectangle 17"/>
+          <p:cNvSpPr/>
+          <p:nvPr/>
+        </p:nvSpPr>
+        <p:spPr>
+          <a:xfrm>
+            <a:off x="274320" y="4690872"/>
+            <a:ext cx="1874519" cy="914400"/>
+          </a:xfrm>
+          <a:prstGeom prst="rect">
+            <a:avLst/>
+          </a:prstGeom>
+          <a:solidFill>
+            <a:srgbClr val="FFFFFF"/>
+          </a:solidFill>
+          <a:ln w="12700">
+            <a:solidFill>
+              <a:srgbClr val="D0D8DE"/>
+            </a:solidFill>
+          </a:ln>
+        </p:spPr>
+        <p:style>
+          <a:lnRef idx="1">
+            <a:schemeClr val="accent1"/>
+          </a:lnRef>
+          <a:fillRef idx="3">
+            <a:schemeClr val="accent1"/>
+          </a:fillRef>
+          <a:effectRef idx="2">
+            <a:schemeClr val="accent1"/>
+          </a:effectRef>
+          <a:fontRef idx="minor">
+            <a:schemeClr val="lt1"/>
+          </a:fontRef>
+        </p:style>
+        <p:txBody>
+          <a:bodyPr rtlCol="0" anchor="ctr"/>
+          <a:lstStyle/>
+          <a:p>
+            <a:pPr algn="ctr"/>
+          </a:p>
+        </p:txBody>
+      </p:sp>
+      <p:sp>
+        <p:nvSpPr>
+          <p:cNvPr id="19" name="TextBox 18"/>
+          <p:cNvSpPr txBox="1"/>
+          <p:nvPr/>
+        </p:nvSpPr>
+        <p:spPr>
+          <a:xfrm>
+            <a:off x="365760" y="4745736"/>
+            <a:ext cx="1709927" cy="201168"/>
+          </a:xfrm>
+          <a:prstGeom prst="rect">
+            <a:avLst/>
+          </a:prstGeom>
+          <a:noFill/>
+        </p:spPr>
+        <p:txBody>
+          <a:bodyPr wrap="square">
+            <a:spAutoFit/>
+          </a:bodyPr>
+          <a:lstStyle/>
+          <a:p>
+            <a:pPr algn="l"/>
+            <a:r>
+              <a:rPr sz="1000" b="0">
+                <a:solidFill>
+                  <a:srgbClr val="6B6B6B"/>
+                </a:solidFill>
+                <a:latin typeface="Microsoft YaHei"/>
+                <a:ea typeface="Microsoft YaHei"/>
+              </a:rPr>
+              <a:t>同 SLO 吞吐</a:t>
+            </a:r>
+          </a:p>
+        </p:txBody>
+      </p:sp>
+      <p:sp>
+        <p:nvSpPr>
+          <p:cNvPr id="20" name="TextBox 19"/>
+          <p:cNvSpPr txBox="1"/>
+          <p:nvPr/>
+        </p:nvSpPr>
+        <p:spPr>
+          <a:xfrm>
+            <a:off x="365760" y="4946904"/>
+            <a:ext cx="1709927" cy="256032"/>
+          </a:xfrm>
+          <a:prstGeom prst="rect">
+            <a:avLst/>
+          </a:prstGeom>
+          <a:noFill/>
+        </p:spPr>
+        <p:txBody>
+          <a:bodyPr wrap="square">
+            <a:spAutoFit/>
+          </a:bodyPr>
+          <a:lstStyle/>
+          <a:p>
+            <a:pPr algn="l"/>
+            <a:r>
+              <a:rPr sz="1000" b="0">
+                <a:solidFill>
+                  <a:srgbClr val="4A4A4A"/>
+                </a:solidFill>
+                <a:latin typeface="Microsoft YaHei"/>
+                <a:ea typeface="Microsoft YaHei"/>
+              </a:rPr>
+              <a:t>生产验证</a:t>
+            </a:r>
+          </a:p>
+        </p:txBody>
+      </p:sp>
+      <p:sp>
+        <p:nvSpPr>
+          <p:cNvPr id="21" name="TextBox 20"/>
+          <p:cNvSpPr txBox="1"/>
+          <p:nvPr/>
+        </p:nvSpPr>
+        <p:spPr>
+          <a:xfrm>
+            <a:off x="365760" y="5202936"/>
+            <a:ext cx="1709927" cy="329184"/>
+          </a:xfrm>
+          <a:prstGeom prst="rect">
+            <a:avLst/>
+          </a:prstGeom>
+          <a:noFill/>
+        </p:spPr>
+        <p:txBody>
+          <a:bodyPr wrap="square">
+            <a:spAutoFit/>
+          </a:bodyPr>
+          <a:lstStyle/>
+          <a:p>
+            <a:pPr algn="l"/>
+            <a:r>
+              <a:rPr sz="1300" b="1">
+                <a:solidFill>
+                  <a:srgbClr val="8B1A2B"/>
+                </a:solidFill>
+                <a:latin typeface="Microsoft YaHei"/>
+                <a:ea typeface="Microsoft YaHei"/>
+              </a:rPr>
+              <a:t>2~3×</a:t>
+            </a:r>
+          </a:p>
+        </p:txBody>
+      </p:sp>
+      <p:sp>
+        <p:nvSpPr>
+          <p:cNvPr id="22" name="Rectangle 21"/>
+          <p:cNvSpPr/>
+          <p:nvPr/>
+        </p:nvSpPr>
+        <p:spPr>
+          <a:xfrm>
+            <a:off x="2240279" y="4690872"/>
+            <a:ext cx="1874519" cy="914400"/>
+          </a:xfrm>
+          <a:prstGeom prst="rect">
+            <a:avLst/>
+          </a:prstGeom>
+          <a:solidFill>
+            <a:srgbClr val="FFFFFF"/>
+          </a:solidFill>
+          <a:ln w="12700">
+            <a:solidFill>
+              <a:srgbClr val="D0D8DE"/>
+            </a:solidFill>
+          </a:ln>
+        </p:spPr>
+        <p:style>
+          <a:lnRef idx="1">
+            <a:schemeClr val="accent1"/>
+          </a:lnRef>
+          <a:fillRef idx="3">
+            <a:schemeClr val="accent1"/>
+          </a:fillRef>
+          <a:effectRef idx="2">
+            <a:schemeClr val="accent1"/>
+          </a:effectRef>
+          <a:fontRef idx="minor">
+            <a:schemeClr val="lt1"/>
+          </a:fontRef>
+        </p:style>
+        <p:txBody>
+          <a:bodyPr rtlCol="0" anchor="ctr"/>
+          <a:lstStyle/>
+          <a:p>
+            <a:pPr algn="ctr"/>
+          </a:p>
+        </p:txBody>
+      </p:sp>
+      <p:sp>
+        <p:nvSpPr>
+          <p:cNvPr id="23" name="TextBox 22"/>
+          <p:cNvSpPr txBox="1"/>
+          <p:nvPr/>
+        </p:nvSpPr>
+        <p:spPr>
+          <a:xfrm>
+            <a:off x="2331719" y="4745736"/>
+            <a:ext cx="1709927" cy="201168"/>
+          </a:xfrm>
+          <a:prstGeom prst="rect">
+            <a:avLst/>
+          </a:prstGeom>
+          <a:noFill/>
+        </p:spPr>
+        <p:txBody>
+          <a:bodyPr wrap="square">
+            <a:spAutoFit/>
+          </a:bodyPr>
+          <a:lstStyle/>
+          <a:p>
+            <a:pPr algn="l"/>
+            <a:r>
+              <a:rPr sz="1000" b="0">
+                <a:solidFill>
+                  <a:srgbClr val="6B6B6B"/>
+                </a:solidFill>
+                <a:latin typeface="Microsoft YaHei"/>
+                <a:ea typeface="Microsoft YaHei"/>
+              </a:rPr>
+              <a:t>GPU 资源</a:t>
+            </a:r>
+          </a:p>
+        </p:txBody>
+      </p:sp>
+      <p:sp>
+        <p:nvSpPr>
+          <p:cNvPr id="24" name="TextBox 23"/>
+          <p:cNvSpPr txBox="1"/>
+          <p:nvPr/>
+        </p:nvSpPr>
+        <p:spPr>
+          <a:xfrm>
+            <a:off x="2331719" y="4946904"/>
+            <a:ext cx="1709927" cy="256032"/>
+          </a:xfrm>
+          <a:prstGeom prst="rect">
+            <a:avLst/>
+          </a:prstGeom>
+          <a:noFill/>
+        </p:spPr>
+        <p:txBody>
+          <a:bodyPr wrap="square">
+            <a:spAutoFit/>
+          </a:bodyPr>
+          <a:lstStyle/>
+          <a:p>
+            <a:pPr algn="l"/>
+            <a:r>
+              <a:rPr sz="1000" b="0">
+                <a:solidFill>
+                  <a:srgbClr val="4A4A4A"/>
+                </a:solidFill>
+                <a:latin typeface="Microsoft YaHei"/>
+                <a:ea typeface="Microsoft YaHei"/>
+              </a:rPr>
+              <a:t>生产验证</a:t>
+            </a:r>
+          </a:p>
+        </p:txBody>
+      </p:sp>
+      <p:sp>
+        <p:nvSpPr>
+          <p:cNvPr id="25" name="TextBox 24"/>
+          <p:cNvSpPr txBox="1"/>
+          <p:nvPr/>
+        </p:nvSpPr>
+        <p:spPr>
+          <a:xfrm>
+            <a:off x="2331719" y="5202936"/>
+            <a:ext cx="1709927" cy="329184"/>
+          </a:xfrm>
+          <a:prstGeom prst="rect">
+            <a:avLst/>
+          </a:prstGeom>
+          <a:noFill/>
+        </p:spPr>
+        <p:txBody>
+          <a:bodyPr wrap="square">
+            <a:spAutoFit/>
+          </a:bodyPr>
+          <a:lstStyle/>
+          <a:p>
+            <a:pPr algn="l"/>
+            <a:r>
+              <a:rPr sz="1300" b="1">
+                <a:solidFill>
+                  <a:srgbClr val="8B1A2B"/>
+                </a:solidFill>
+                <a:latin typeface="Microsoft YaHei"/>
+                <a:ea typeface="Microsoft YaHei"/>
+              </a:rPr>
+              <a:t>节省 50%</a:t>
+            </a:r>
+          </a:p>
+        </p:txBody>
+      </p:sp>
+      <p:sp>
+        <p:nvSpPr>
+          <p:cNvPr id="26" name="Rectangle 25"/>
+          <p:cNvSpPr/>
+          <p:nvPr/>
+        </p:nvSpPr>
+        <p:spPr>
+          <a:xfrm>
+            <a:off x="4206238" y="4690872"/>
+            <a:ext cx="1874519" cy="914400"/>
+          </a:xfrm>
+          <a:prstGeom prst="rect">
+            <a:avLst/>
+          </a:prstGeom>
+          <a:solidFill>
+            <a:srgbClr val="FFFFFF"/>
+          </a:solidFill>
+          <a:ln w="12700">
+            <a:solidFill>
+              <a:srgbClr val="D0D8DE"/>
+            </a:solidFill>
+          </a:ln>
+        </p:spPr>
+        <p:style>
+          <a:lnRef idx="1">
+            <a:schemeClr val="accent1"/>
+          </a:lnRef>
+          <a:fillRef idx="3">
+            <a:schemeClr val="accent1"/>
+          </a:fillRef>
+          <a:effectRef idx="2">
+            <a:schemeClr val="accent1"/>
+          </a:effectRef>
+          <a:fontRef idx="minor">
+            <a:schemeClr val="lt1"/>
+          </a:fontRef>
+        </p:style>
+        <p:txBody>
+          <a:bodyPr rtlCol="0" anchor="ctr"/>
+          <a:lstStyle/>
+          <a:p>
+            <a:pPr algn="ctr"/>
+          </a:p>
+        </p:txBody>
+      </p:sp>
+      <p:sp>
+        <p:nvSpPr>
+          <p:cNvPr id="27" name="TextBox 26"/>
+          <p:cNvSpPr txBox="1"/>
+          <p:nvPr/>
+        </p:nvSpPr>
+        <p:spPr>
+          <a:xfrm>
+            <a:off x="4297678" y="4745736"/>
+            <a:ext cx="1709927" cy="201168"/>
+          </a:xfrm>
+          <a:prstGeom prst="rect">
+            <a:avLst/>
+          </a:prstGeom>
+          <a:noFill/>
+        </p:spPr>
+        <p:txBody>
+          <a:bodyPr wrap="square">
+            <a:spAutoFit/>
+          </a:bodyPr>
+          <a:lstStyle/>
+          <a:p>
+            <a:pPr algn="l"/>
+            <a:r>
+              <a:rPr sz="1000" b="0">
+                <a:solidFill>
+                  <a:srgbClr val="6B6B6B"/>
+                </a:solidFill>
+                <a:latin typeface="Microsoft YaHei"/>
+                <a:ea typeface="Microsoft YaHei"/>
+              </a:rPr>
+              <a:t>FlashGPU 驻留</a:t>
+            </a:r>
+          </a:p>
+        </p:txBody>
+      </p:sp>
+      <p:sp>
+        <p:nvSpPr>
+          <p:cNvPr id="28" name="TextBox 27"/>
+          <p:cNvSpPr txBox="1"/>
+          <p:nvPr/>
+        </p:nvSpPr>
+        <p:spPr>
+          <a:xfrm>
+            <a:off x="4297678" y="4946904"/>
+            <a:ext cx="1709927" cy="256032"/>
+          </a:xfrm>
+          <a:prstGeom prst="rect">
+            <a:avLst/>
+          </a:prstGeom>
+          <a:noFill/>
+        </p:spPr>
+        <p:txBody>
+          <a:bodyPr wrap="square">
+            <a:spAutoFit/>
+          </a:bodyPr>
+          <a:lstStyle/>
+          <a:p>
+            <a:pPr algn="l"/>
+            <a:r>
+              <a:rPr sz="1000" b="0">
+                <a:solidFill>
+                  <a:srgbClr val="4A4A4A"/>
+                </a:solidFill>
+                <a:latin typeface="Microsoft YaHei"/>
+                <a:ea typeface="Microsoft YaHei"/>
+              </a:rPr>
+              <a:t>权重切换</a:t>
+            </a:r>
+          </a:p>
+        </p:txBody>
+      </p:sp>
+      <p:sp>
+        <p:nvSpPr>
+          <p:cNvPr id="29" name="TextBox 28"/>
+          <p:cNvSpPr txBox="1"/>
+          <p:nvPr/>
+        </p:nvSpPr>
+        <p:spPr>
+          <a:xfrm>
+            <a:off x="4297678" y="5202936"/>
+            <a:ext cx="1709927" cy="329184"/>
+          </a:xfrm>
+          <a:prstGeom prst="rect">
+            <a:avLst/>
+          </a:prstGeom>
+          <a:noFill/>
+        </p:spPr>
+        <p:txBody>
+          <a:bodyPr wrap="square">
+            <a:spAutoFit/>
+          </a:bodyPr>
+          <a:lstStyle/>
+          <a:p>
+            <a:pPr algn="l"/>
+            <a:r>
+              <a:rPr sz="1300" b="1">
+                <a:solidFill>
+                  <a:srgbClr val="8B1A2B"/>
+                </a:solidFill>
+                <a:latin typeface="Microsoft YaHei"/>
+                <a:ea typeface="Microsoft YaHei"/>
+              </a:rPr>
+              <a:t>0.6–1.5s</a:t>
+            </a:r>
+          </a:p>
+        </p:txBody>
+      </p:sp>
+      <p:sp>
+        <p:nvSpPr>
+          <p:cNvPr id="30" name="Rectangle 29"/>
+          <p:cNvSpPr/>
+          <p:nvPr/>
+        </p:nvSpPr>
+        <p:spPr>
+          <a:xfrm>
+            <a:off x="6172197" y="4690872"/>
+            <a:ext cx="1874519" cy="914400"/>
+          </a:xfrm>
+          <a:prstGeom prst="rect">
+            <a:avLst/>
+          </a:prstGeom>
+          <a:solidFill>
+            <a:srgbClr val="FFFFFF"/>
+          </a:solidFill>
+          <a:ln w="12700">
+            <a:solidFill>
+              <a:srgbClr val="D0D8DE"/>
+            </a:solidFill>
+          </a:ln>
+        </p:spPr>
+        <p:style>
+          <a:lnRef idx="1">
+            <a:schemeClr val="accent1"/>
+          </a:lnRef>
+          <a:fillRef idx="3">
+            <a:schemeClr val="accent1"/>
+          </a:fillRef>
+          <a:effectRef idx="2">
+            <a:schemeClr val="accent1"/>
+          </a:effectRef>
+          <a:fontRef idx="minor">
+            <a:schemeClr val="lt1"/>
+          </a:fontRef>
+        </p:style>
+        <p:txBody>
+          <a:bodyPr rtlCol="0" anchor="ctr"/>
+          <a:lstStyle/>
+          <a:p>
+            <a:pPr algn="ctr"/>
+          </a:p>
+        </p:txBody>
+      </p:sp>
+      <p:sp>
+        <p:nvSpPr>
+          <p:cNvPr id="31" name="TextBox 30"/>
+          <p:cNvSpPr txBox="1"/>
+          <p:nvPr/>
+        </p:nvSpPr>
+        <p:spPr>
+          <a:xfrm>
+            <a:off x="6263637" y="4745736"/>
+            <a:ext cx="1709927" cy="201168"/>
+          </a:xfrm>
+          <a:prstGeom prst="rect">
+            <a:avLst/>
+          </a:prstGeom>
+          <a:noFill/>
+        </p:spPr>
+        <p:txBody>
+          <a:bodyPr wrap="square">
+            <a:spAutoFit/>
+          </a:bodyPr>
+          <a:lstStyle/>
+          <a:p>
+            <a:pPr algn="l"/>
+            <a:r>
+              <a:rPr sz="1000" b="0">
+                <a:solidFill>
+                  <a:srgbClr val="6B6B6B"/>
+                </a:solidFill>
+                <a:latin typeface="Microsoft YaHei"/>
+                <a:ea typeface="Microsoft YaHei"/>
+              </a:rPr>
+              <a:t>ICN64 vs RDMA</a:t>
+            </a:r>
+          </a:p>
+        </p:txBody>
+      </p:sp>
+      <p:sp>
+        <p:nvSpPr>
+          <p:cNvPr id="32" name="TextBox 31"/>
+          <p:cNvSpPr txBox="1"/>
+          <p:nvPr/>
+        </p:nvSpPr>
+        <p:spPr>
+          <a:xfrm>
+            <a:off x="6263637" y="4946904"/>
+            <a:ext cx="1709927" cy="256032"/>
+          </a:xfrm>
+          <a:prstGeom prst="rect">
+            <a:avLst/>
+          </a:prstGeom>
+          <a:noFill/>
+        </p:spPr>
+        <p:txBody>
+          <a:bodyPr wrap="square">
+            <a:spAutoFit/>
+          </a:bodyPr>
+          <a:lstStyle/>
+          <a:p>
+            <a:pPr algn="l"/>
+            <a:r>
+              <a:rPr sz="1000" b="0">
+                <a:solidFill>
+                  <a:srgbClr val="4A4A4A"/>
+                </a:solidFill>
+                <a:latin typeface="Microsoft YaHei"/>
+                <a:ea typeface="Microsoft YaHei"/>
+              </a:rPr>
+              <a:t>吞吐提升</a:t>
+            </a:r>
+          </a:p>
+        </p:txBody>
+      </p:sp>
+      <p:sp>
+        <p:nvSpPr>
+          <p:cNvPr id="33" name="TextBox 32"/>
+          <p:cNvSpPr txBox="1"/>
+          <p:nvPr/>
+        </p:nvSpPr>
+        <p:spPr>
+          <a:xfrm>
+            <a:off x="6263637" y="5202936"/>
+            <a:ext cx="1709927" cy="329184"/>
+          </a:xfrm>
+          <a:prstGeom prst="rect">
+            <a:avLst/>
+          </a:prstGeom>
+          <a:noFill/>
+        </p:spPr>
+        <p:txBody>
+          <a:bodyPr wrap="square">
+            <a:spAutoFit/>
+          </a:bodyPr>
+          <a:lstStyle/>
+          <a:p>
+            <a:pPr algn="l"/>
+            <a:r>
+              <a:rPr sz="1300" b="1">
+                <a:solidFill>
+                  <a:srgbClr val="8B1A2B"/>
+                </a:solidFill>
+                <a:latin typeface="Microsoft YaHei"/>
+                <a:ea typeface="Microsoft YaHei"/>
+              </a:rPr>
+              <a:t>+40%~55%</a:t>
+            </a:r>
+          </a:p>
+        </p:txBody>
+      </p:sp>
+      <p:sp>
+        <p:nvSpPr>
+          <p:cNvPr id="34" name="Rectangle 33"/>
+          <p:cNvSpPr/>
+          <p:nvPr/>
+        </p:nvSpPr>
+        <p:spPr>
+          <a:xfrm>
+            <a:off x="8138156" y="4690872"/>
+            <a:ext cx="1874519" cy="914400"/>
+          </a:xfrm>
+          <a:prstGeom prst="rect">
+            <a:avLst/>
+          </a:prstGeom>
+          <a:solidFill>
+            <a:srgbClr val="FFFFFF"/>
+          </a:solidFill>
+          <a:ln w="12700">
+            <a:solidFill>
+              <a:srgbClr val="D0D8DE"/>
+            </a:solidFill>
+          </a:ln>
+        </p:spPr>
+        <p:style>
+          <a:lnRef idx="1">
+            <a:schemeClr val="accent1"/>
+          </a:lnRef>
+          <a:fillRef idx="3">
+            <a:schemeClr val="accent1"/>
+          </a:fillRef>
+          <a:effectRef idx="2">
+            <a:schemeClr val="accent1"/>
+          </a:effectRef>
+          <a:fontRef idx="minor">
+            <a:schemeClr val="lt1"/>
+          </a:fontRef>
+        </p:style>
+        <p:txBody>
+          <a:bodyPr rtlCol="0" anchor="ctr"/>
+          <a:lstStyle/>
+          <a:p>
+            <a:pPr algn="ctr"/>
+          </a:p>
+        </p:txBody>
+      </p:sp>
+      <p:sp>
+        <p:nvSpPr>
+          <p:cNvPr id="35" name="TextBox 34"/>
+          <p:cNvSpPr txBox="1"/>
+          <p:nvPr/>
+        </p:nvSpPr>
+        <p:spPr>
+          <a:xfrm>
+            <a:off x="8229596" y="4745736"/>
+            <a:ext cx="1709927" cy="201168"/>
+          </a:xfrm>
+          <a:prstGeom prst="rect">
+            <a:avLst/>
+          </a:prstGeom>
+          <a:noFill/>
+        </p:spPr>
+        <p:txBody>
+          <a:bodyPr wrap="square">
+            <a:spAutoFit/>
+          </a:bodyPr>
+          <a:lstStyle/>
+          <a:p>
+            <a:pPr algn="l"/>
+            <a:r>
+              <a:rPr sz="1000" b="0">
+                <a:solidFill>
+                  <a:srgbClr val="6B6B6B"/>
+                </a:solidFill>
+                <a:latin typeface="Microsoft YaHei"/>
+                <a:ea typeface="Microsoft YaHei"/>
+              </a:rPr>
+              <a:t>ICN64 TTFT</a:t>
+            </a:r>
+          </a:p>
+        </p:txBody>
+      </p:sp>
+      <p:sp>
+        <p:nvSpPr>
+          <p:cNvPr id="36" name="TextBox 35"/>
+          <p:cNvSpPr txBox="1"/>
+          <p:nvPr/>
+        </p:nvSpPr>
+        <p:spPr>
+          <a:xfrm>
+            <a:off x="8229596" y="4946904"/>
+            <a:ext cx="1709927" cy="256032"/>
+          </a:xfrm>
+          <a:prstGeom prst="rect">
+            <a:avLst/>
+          </a:prstGeom>
+          <a:noFill/>
+        </p:spPr>
+        <p:txBody>
+          <a:bodyPr wrap="square">
+            <a:spAutoFit/>
+          </a:bodyPr>
+          <a:lstStyle/>
+          <a:p>
+            <a:pPr algn="l"/>
+            <a:r>
+              <a:rPr sz="1000" b="0">
+                <a:solidFill>
+                  <a:srgbClr val="4A4A4A"/>
+                </a:solidFill>
+                <a:latin typeface="Microsoft YaHei"/>
+                <a:ea typeface="Microsoft YaHei"/>
+              </a:rPr>
+              <a:t>长输入更明显</a:t>
+            </a:r>
+          </a:p>
+        </p:txBody>
+      </p:sp>
+      <p:sp>
+        <p:nvSpPr>
+          <p:cNvPr id="37" name="TextBox 36"/>
+          <p:cNvSpPr txBox="1"/>
+          <p:nvPr/>
+        </p:nvSpPr>
+        <p:spPr>
+          <a:xfrm>
+            <a:off x="8229596" y="5202936"/>
+            <a:ext cx="1709927" cy="329184"/>
+          </a:xfrm>
+          <a:prstGeom prst="rect">
+            <a:avLst/>
+          </a:prstGeom>
+          <a:noFill/>
+        </p:spPr>
+        <p:txBody>
+          <a:bodyPr wrap="square">
+            <a:spAutoFit/>
+          </a:bodyPr>
+          <a:lstStyle/>
+          <a:p>
+            <a:pPr algn="l"/>
+            <a:r>
+              <a:rPr sz="1300" b="1">
+                <a:solidFill>
+                  <a:srgbClr val="8B1A2B"/>
+                </a:solidFill>
+                <a:latin typeface="Microsoft YaHei"/>
+                <a:ea typeface="Microsoft YaHei"/>
+              </a:rPr>
+              <a:t>-28%~-35%</a:t>
+            </a:r>
+          </a:p>
+        </p:txBody>
+      </p:sp>
+      <p:sp>
+        <p:nvSpPr>
+          <p:cNvPr id="38" name="Rectangle 37"/>
+          <p:cNvSpPr/>
+          <p:nvPr/>
+        </p:nvSpPr>
+        <p:spPr>
+          <a:xfrm>
+            <a:off x="10104115" y="4690872"/>
+            <a:ext cx="1874519" cy="914400"/>
+          </a:xfrm>
+          <a:prstGeom prst="rect">
+            <a:avLst/>
+          </a:prstGeom>
+          <a:solidFill>
+            <a:srgbClr val="FFFFFF"/>
+          </a:solidFill>
+          <a:ln w="12700">
+            <a:solidFill>
+              <a:srgbClr val="D0D8DE"/>
+            </a:solidFill>
+          </a:ln>
+        </p:spPr>
+        <p:style>
+          <a:lnRef idx="1">
+            <a:schemeClr val="accent1"/>
+          </a:lnRef>
+          <a:fillRef idx="3">
+            <a:schemeClr val="accent1"/>
+          </a:fillRef>
+          <a:effectRef idx="2">
+            <a:schemeClr val="accent1"/>
+          </a:effectRef>
+          <a:fontRef idx="minor">
+            <a:schemeClr val="lt1"/>
+          </a:fontRef>
+        </p:style>
+        <p:txBody>
+          <a:bodyPr rtlCol="0" anchor="ctr"/>
+          <a:lstStyle/>
+          <a:p>
+            <a:pPr algn="ctr"/>
+          </a:p>
+        </p:txBody>
+      </p:sp>
+      <p:sp>
+        <p:nvSpPr>
+          <p:cNvPr id="39" name="TextBox 38"/>
+          <p:cNvSpPr txBox="1"/>
+          <p:nvPr/>
+        </p:nvSpPr>
+        <p:spPr>
+          <a:xfrm>
+            <a:off x="10195555" y="4745736"/>
+            <a:ext cx="1709927" cy="201168"/>
+          </a:xfrm>
+          <a:prstGeom prst="rect">
+            <a:avLst/>
+          </a:prstGeom>
+          <a:noFill/>
+        </p:spPr>
+        <p:txBody>
+          <a:bodyPr wrap="square">
+            <a:spAutoFit/>
+          </a:bodyPr>
+          <a:lstStyle/>
+          <a:p>
+            <a:pPr algn="l"/>
+            <a:r>
+              <a:rPr sz="1000" b="0">
+                <a:solidFill>
+                  <a:srgbClr val="6B6B6B"/>
+                </a:solidFill>
+                <a:latin typeface="Microsoft YaHei"/>
+                <a:ea typeface="Microsoft YaHei"/>
+              </a:rPr>
+              <a:t>开源 RBG</a:t>
+            </a:r>
+          </a:p>
+        </p:txBody>
+      </p:sp>
+      <p:sp>
+        <p:nvSpPr>
+          <p:cNvPr id="40" name="TextBox 39"/>
+          <p:cNvSpPr txBox="1"/>
+          <p:nvPr/>
+        </p:nvSpPr>
+        <p:spPr>
+          <a:xfrm>
+            <a:off x="10195555" y="4946904"/>
+            <a:ext cx="1709927" cy="256032"/>
+          </a:xfrm>
+          <a:prstGeom prst="rect">
+            <a:avLst/>
+          </a:prstGeom>
+          <a:noFill/>
+        </p:spPr>
+        <p:txBody>
+          <a:bodyPr wrap="square">
+            <a:spAutoFit/>
+          </a:bodyPr>
+          <a:lstStyle/>
+          <a:p>
+            <a:pPr algn="l"/>
+            <a:r>
+              <a:rPr sz="1000" b="0">
+                <a:solidFill>
+                  <a:srgbClr val="4A4A4A"/>
+                </a:solidFill>
+                <a:latin typeface="Microsoft YaHei"/>
+                <a:ea typeface="Microsoft YaHei"/>
+              </a:rPr>
+              <a:t>小红书×ACK</a:t>
+            </a:r>
+          </a:p>
+        </p:txBody>
+      </p:sp>
+      <p:sp>
+        <p:nvSpPr>
+          <p:cNvPr id="41" name="TextBox 40"/>
+          <p:cNvSpPr txBox="1"/>
+          <p:nvPr/>
+        </p:nvSpPr>
+        <p:spPr>
+          <a:xfrm>
+            <a:off x="10195555" y="5202936"/>
+            <a:ext cx="1709927" cy="329184"/>
+          </a:xfrm>
+          <a:prstGeom prst="rect">
+            <a:avLst/>
+          </a:prstGeom>
+          <a:noFill/>
+        </p:spPr>
+        <p:txBody>
+          <a:bodyPr wrap="square">
+            <a:spAutoFit/>
+          </a:bodyPr>
+          <a:lstStyle/>
+          <a:p>
+            <a:pPr algn="l"/>
+            <a:r>
+              <a:rPr sz="1300" b="1">
+                <a:solidFill>
+                  <a:srgbClr val="8B1A2B"/>
+                </a:solidFill>
+                <a:latin typeface="Microsoft YaHei"/>
+                <a:ea typeface="Microsoft YaHei"/>
+              </a:rPr>
+              <a:t>sgl-project/rbg</a:t>
+            </a:r>
+          </a:p>
+        </p:txBody>
+      </p:sp>
+      <p:sp>
+        <p:nvSpPr>
+          <p:cNvPr id="42" name="Rectangle 41"/>
+          <p:cNvSpPr/>
+          <p:nvPr/>
+        </p:nvSpPr>
+        <p:spPr>
+          <a:xfrm>
+            <a:off x="0" y="5806440"/>
+            <a:ext cx="12191695" cy="1051560"/>
+          </a:xfrm>
+          <a:prstGeom prst="rect">
+            <a:avLst/>
+          </a:prstGeom>
+          <a:solidFill>
+            <a:srgbClr val="FFFFFF"/>
+          </a:solidFill>
+          <a:ln>
+            <a:noFill/>
+          </a:ln>
+        </p:spPr>
+        <p:style>
+          <a:lnRef idx="1">
+            <a:schemeClr val="accent1"/>
+          </a:lnRef>
+          <a:fillRef idx="3">
+            <a:schemeClr val="accent1"/>
+          </a:fillRef>
+          <a:effectRef idx="2">
+            <a:schemeClr val="accent1"/>
+          </a:effectRef>
+          <a:fontRef idx="minor">
+            <a:schemeClr val="lt1"/>
+          </a:fontRef>
+        </p:style>
+        <p:txBody>
+          <a:bodyPr rtlCol="0" anchor="ctr"/>
+          <a:lstStyle/>
+          <a:p>
+            <a:pPr algn="ctr"/>
+          </a:p>
+        </p:txBody>
+      </p:sp>
+      <p:sp>
+        <p:nvSpPr>
+          <p:cNvPr id="43" name="TextBox 42"/>
+          <p:cNvSpPr txBox="1"/>
+          <p:nvPr/>
+        </p:nvSpPr>
+        <p:spPr>
+          <a:xfrm>
+            <a:off x="320040" y="5879592"/>
+            <a:ext cx="11521440" cy="475488"/>
+          </a:xfrm>
+          <a:prstGeom prst="rect">
+            <a:avLst/>
+          </a:prstGeom>
+          <a:noFill/>
+        </p:spPr>
+        <p:txBody>
+          <a:bodyPr wrap="square">
+            <a:spAutoFit/>
+          </a:bodyPr>
+          <a:lstStyle/>
+          <a:p>
+            <a:pPr algn="l"/>
+            <a:r>
+              <a:rPr sz="1100" b="1">
+                <a:solidFill>
+                  <a:srgbClr val="1A1A1A"/>
+                </a:solidFill>
+                <a:latin typeface="Microsoft YaHei"/>
+                <a:ea typeface="Microsoft YaHei"/>
+              </a:rPr>
+              <a:t>启示要点：静态 PD 先把「成组调度 + 原地升级 + 容量防护」跑稳；动态 PD 再把 Role 拆开，用策略协同替代固定配比；最终把快照复用与 Rollout 托管接到训推一体，并用开源 RBG 回馈社区。</a:t>
+            </a:r>
+          </a:p>
+        </p:txBody>
+      </p:sp>
+      <p:sp>
+        <p:nvSpPr>
+          <p:cNvPr id="44" name="TextBox 43"/>
+          <p:cNvSpPr txBox="1"/>
+          <p:nvPr/>
+        </p:nvSpPr>
+        <p:spPr>
+          <a:xfrm>
+            <a:off x="320040" y="6336792"/>
+            <a:ext cx="11521440" cy="256032"/>
+          </a:xfrm>
+          <a:prstGeom prst="rect">
+            <a:avLst/>
+          </a:prstGeom>
+          <a:noFill/>
+        </p:spPr>
+        <p:txBody>
+          <a:bodyPr wrap="square">
+            <a:spAutoFit/>
+          </a:bodyPr>
+          <a:lstStyle/>
+          <a:p>
+            <a:pPr algn="l"/>
+            <a:r>
+              <a:rPr sz="900" b="0">
+                <a:solidFill>
+                  <a:srgbClr val="6B6B6B"/>
+                </a:solidFill>
+                <a:latin typeface="Microsoft YaHei"/>
+                <a:ea typeface="Microsoft YaHei"/>
+              </a:rPr>
+              <a:t>来源：https://yunqi.aliyun.com/2026/session?agendaId=201 · Talk 08 车漾 / 熊峰 · 第 2/2 页</a:t>
+            </a:r>
+          </a:p>
+        </p:txBody>
+      </p:sp>
+    </p:spTree>
+  </p:cSld>
+  <p:clrMapOvr>
+    <a:masterClrMapping/>
+  </p:clrMapOvr>
+</p:sld>
+</file>
+
+<file path=ppt/slides/slide3.xml><?xml version="1.0" encoding="utf-8"?>
+<p:sld xmlns:a="http://schemas.openxmlformats.org/drawingml/2006/main" xmlns:p="http://schemas.openxmlformats.org/presentationml/2006/main" xmlns:r="http://schemas.openxmlformats.org/officeDocument/2006/relationships">
+  <p:cSld>
+    <p:spTree>
+      <p:nvGrpSpPr>
+        <p:cNvPr id="1" name=""/>
+        <p:cNvGrpSpPr/>
+        <p:nvPr/>
+      </p:nvGrpSpPr>
+      <p:grpSpPr/>
+      <p:sp>
+        <p:nvSpPr>
+          <p:cNvPr id="2" name="Rectangle 1"/>
+          <p:cNvSpPr/>
+          <p:nvPr/>
+        </p:nvSpPr>
+        <p:spPr>
+          <a:xfrm>
+            <a:off x="0" y="0"/>
+            <a:ext cx="12191695" cy="6858000"/>
+          </a:xfrm>
+          <a:prstGeom prst="rect">
+            <a:avLst/>
+          </a:prstGeom>
+          <a:solidFill>
+            <a:srgbClr val="F5F7F9"/>
+          </a:solidFill>
+          <a:ln>
+            <a:noFill/>
+          </a:ln>
+        </p:spPr>
+        <p:style>
+          <a:lnRef idx="1">
+            <a:schemeClr val="accent1"/>
+          </a:lnRef>
+          <a:fillRef idx="3">
+            <a:schemeClr val="accent1"/>
+          </a:fillRef>
+          <a:effectRef idx="2">
+            <a:schemeClr val="accent1"/>
+          </a:effectRef>
+          <a:fontRef idx="minor">
+            <a:schemeClr val="lt1"/>
+          </a:fontRef>
+        </p:style>
+        <p:txBody>
+          <a:bodyPr rtlCol="0" anchor="ctr"/>
+          <a:lstStyle/>
+          <a:p>
+            <a:pPr algn="ctr"/>
+          </a:p>
+        </p:txBody>
+      </p:sp>
+      <p:sp>
+        <p:nvSpPr>
+          <p:cNvPr id="3" name="Rectangle 2"/>
+          <p:cNvSpPr/>
+          <p:nvPr/>
+        </p:nvSpPr>
+        <p:spPr>
+          <a:xfrm>
+            <a:off x="0" y="0"/>
+            <a:ext cx="12191695" cy="868680"/>
+          </a:xfrm>
+          <a:prstGeom prst="rect">
+            <a:avLst/>
+          </a:prstGeom>
+          <a:solidFill>
+            <a:srgbClr val="FFFFFF"/>
+          </a:solidFill>
+          <a:ln>
+            <a:noFill/>
+          </a:ln>
+        </p:spPr>
+        <p:style>
+          <a:lnRef idx="1">
+            <a:schemeClr val="accent1"/>
+          </a:lnRef>
+          <a:fillRef idx="3">
+            <a:schemeClr val="accent1"/>
+          </a:fillRef>
+          <a:effectRef idx="2">
+            <a:schemeClr val="accent1"/>
+          </a:effectRef>
+          <a:fontRef idx="minor">
+            <a:schemeClr val="lt1"/>
+          </a:fontRef>
+        </p:style>
+        <p:txBody>
+          <a:bodyPr rtlCol="0" anchor="ctr"/>
+          <a:lstStyle/>
+          <a:p>
+            <a:pPr algn="ctr"/>
+          </a:p>
+        </p:txBody>
+      </p:sp>
+      <p:sp>
+        <p:nvSpPr>
+          <p:cNvPr id="4" name="TextBox 3"/>
+          <p:cNvSpPr txBox="1"/>
+          <p:nvPr/>
+        </p:nvSpPr>
+        <p:spPr>
+          <a:xfrm>
+            <a:off x="365760" y="146304"/>
+            <a:ext cx="11430000" cy="256032"/>
+          </a:xfrm>
+          <a:prstGeom prst="rect">
+            <a:avLst/>
+          </a:prstGeom>
+          <a:noFill/>
+        </p:spPr>
+        <p:txBody>
+          <a:bodyPr wrap="square">
+            <a:spAutoFit/>
+          </a:bodyPr>
+          <a:lstStyle/>
+          <a:p>
+            <a:pPr algn="l"/>
+            <a:r>
+              <a:rPr sz="1200" b="0">
+                <a:solidFill>
+                  <a:srgbClr val="6B6B6B"/>
+                </a:solidFill>
+                <a:latin typeface="Microsoft YaHei"/>
+                <a:ea typeface="Microsoft YaHei"/>
+              </a:rPr>
+              <a:t>08 · 车漾 / 熊峰 · 阿里云容器服务 ACK × 小红书</a:t>
+            </a:r>
+          </a:p>
+        </p:txBody>
+      </p:sp>
+      <p:sp>
+        <p:nvSpPr>
+          <p:cNvPr id="5" name="TextBox 4"/>
+          <p:cNvSpPr txBox="1"/>
+          <p:nvPr/>
+        </p:nvSpPr>
+        <p:spPr>
+          <a:xfrm>
+            <a:off x="365760" y="384048"/>
+            <a:ext cx="11430000" cy="365760"/>
+          </a:xfrm>
+          <a:prstGeom prst="rect">
+            <a:avLst/>
+          </a:prstGeom>
+          <a:noFill/>
+        </p:spPr>
+        <p:txBody>
+          <a:bodyPr wrap="square">
+            <a:spAutoFit/>
+          </a:bodyPr>
+          <a:lstStyle/>
+          <a:p>
+            <a:pPr algn="l"/>
+            <a:r>
+              <a:rPr sz="2200" b="1">
+                <a:solidFill>
+                  <a:srgbClr val="1A1A1A"/>
+                </a:solidFill>
+                <a:latin typeface="Microsoft YaHei"/>
+                <a:ea typeface="Microsoft YaHei"/>
+              </a:rPr>
+              <a:t>数据佐证｜官方回放截图</a:t>
+            </a:r>
+          </a:p>
+        </p:txBody>
+      </p:sp>
+      <p:sp>
+        <p:nvSpPr>
+          <p:cNvPr id="6" name="Rectangle 5"/>
+          <p:cNvSpPr/>
+          <p:nvPr/>
+        </p:nvSpPr>
+        <p:spPr>
+          <a:xfrm>
+            <a:off x="320040" y="1051560"/>
+            <a:ext cx="3716426" cy="5074920"/>
+          </a:xfrm>
+          <a:prstGeom prst="rect">
+            <a:avLst/>
+          </a:prstGeom>
+          <a:solidFill>
+            <a:srgbClr val="FFFFFF"/>
+          </a:solidFill>
+          <a:ln w="12700">
+            <a:solidFill>
+              <a:srgbClr val="D0D8DE"/>
+            </a:solidFill>
+          </a:ln>
+        </p:spPr>
+        <p:style>
+          <a:lnRef idx="1">
+            <a:schemeClr val="accent1"/>
+          </a:lnRef>
+          <a:fillRef idx="3">
+            <a:schemeClr val="accent1"/>
+          </a:fillRef>
+          <a:effectRef idx="2">
+            <a:schemeClr val="accent1"/>
+          </a:effectRef>
+          <a:fontRef idx="minor">
+            <a:schemeClr val="lt1"/>
+          </a:fontRef>
+        </p:style>
+        <p:txBody>
+          <a:bodyPr rtlCol="0" anchor="ctr"/>
+          <a:lstStyle/>
+          <a:p>
+            <a:pPr algn="ctr"/>
+          </a:p>
+        </p:txBody>
+      </p:sp>
+      <p:sp>
+        <p:nvSpPr>
+          <p:cNvPr id="7" name="TextBox 6"/>
+          <p:cNvSpPr txBox="1"/>
+          <p:nvPr/>
+        </p:nvSpPr>
+        <p:spPr>
+          <a:xfrm>
+            <a:off x="429768" y="1143000"/>
+            <a:ext cx="3496970" cy="365760"/>
+          </a:xfrm>
+          <a:prstGeom prst="rect">
+            <a:avLst/>
+          </a:prstGeom>
+          <a:noFill/>
+        </p:spPr>
+        <p:txBody>
+          <a:bodyPr wrap="square">
+            <a:spAutoFit/>
+          </a:bodyPr>
+          <a:lstStyle/>
+          <a:p>
+            <a:pPr algn="l"/>
+            <a:r>
               <a:rPr sz="1200" b="1">
                 <a:solidFill>
                   <a:srgbClr val="8B1A2B"/>
@@ -5413,14 +7008,296 @@
                 <a:latin typeface="Microsoft YaHei"/>
                 <a:ea typeface="Microsoft YaHei"/>
               </a:rPr>
-              <a:t>目标：权重加载进入秒级时代 · 路径：OSS / Mooncake / FlashGPU / P2P</a:t>
+              <a:t>Cost/Token 公式与三杠杆</a:t>
             </a:r>
           </a:p>
         </p:txBody>
       </p:sp>
       <p:pic>
         <p:nvPicPr>
-          <p:cNvPr id="16" name="Picture 15" descr="t02-56-00-crop.png"/>
+          <p:cNvPr id="8" name="Picture 7" descr="t02-52-00-crop.png"/>
+          <p:cNvPicPr>
+            <a:picLocks noChangeAspect="1"/>
+          </p:cNvPicPr>
+          <p:nvPr/>
+        </p:nvPicPr>
+        <p:blipFill>
+          <a:blip r:embed="rId2"/>
+          <a:stretch>
+            <a:fillRect/>
+          </a:stretch>
+        </p:blipFill>
+        <p:spPr>
+          <a:xfrm>
+            <a:off x="429768" y="1946380"/>
+            <a:ext cx="3496970" cy="2965239"/>
+          </a:xfrm>
+          <a:prstGeom prst="rect">
+            <a:avLst/>
+          </a:prstGeom>
+        </p:spPr>
+      </p:pic>
+      <p:sp>
+        <p:nvSpPr>
+          <p:cNvPr id="9" name="TextBox 8"/>
+          <p:cNvSpPr txBox="1"/>
+          <p:nvPr/>
+        </p:nvSpPr>
+        <p:spPr>
+          <a:xfrm>
+            <a:off x="429768" y="5486400"/>
+            <a:ext cx="3496970" cy="502920"/>
+          </a:xfrm>
+          <a:prstGeom prst="rect">
+            <a:avLst/>
+          </a:prstGeom>
+          <a:noFill/>
+        </p:spPr>
+        <p:txBody>
+          <a:bodyPr wrap="square">
+            <a:spAutoFit/>
+          </a:bodyPr>
+          <a:lstStyle/>
+          <a:p>
+            <a:pPr algn="l"/>
+            <a:r>
+              <a:rPr sz="1100" b="0">
+                <a:solidFill>
+                  <a:srgbClr val="4A4A4A"/>
+                </a:solidFill>
+                <a:latin typeface="Microsoft YaHei"/>
+                <a:ea typeface="Microsoft YaHei"/>
+              </a:rPr>
+              <a:t>Cost per Token 北极星</a:t>
+            </a:r>
+          </a:p>
+        </p:txBody>
+      </p:sp>
+      <p:sp>
+        <p:nvSpPr>
+          <p:cNvPr id="10" name="Rectangle 9"/>
+          <p:cNvSpPr/>
+          <p:nvPr/>
+        </p:nvSpPr>
+        <p:spPr>
+          <a:xfrm>
+            <a:off x="4237634" y="1051560"/>
+            <a:ext cx="3716426" cy="5074920"/>
+          </a:xfrm>
+          <a:prstGeom prst="rect">
+            <a:avLst/>
+          </a:prstGeom>
+          <a:solidFill>
+            <a:srgbClr val="FFFFFF"/>
+          </a:solidFill>
+          <a:ln w="12700">
+            <a:solidFill>
+              <a:srgbClr val="D0D8DE"/>
+            </a:solidFill>
+          </a:ln>
+        </p:spPr>
+        <p:style>
+          <a:lnRef idx="1">
+            <a:schemeClr val="accent1"/>
+          </a:lnRef>
+          <a:fillRef idx="3">
+            <a:schemeClr val="accent1"/>
+          </a:fillRef>
+          <a:effectRef idx="2">
+            <a:schemeClr val="accent1"/>
+          </a:effectRef>
+          <a:fontRef idx="minor">
+            <a:schemeClr val="lt1"/>
+          </a:fontRef>
+        </p:style>
+        <p:txBody>
+          <a:bodyPr rtlCol="0" anchor="ctr"/>
+          <a:lstStyle/>
+          <a:p>
+            <a:pPr algn="ctr"/>
+          </a:p>
+        </p:txBody>
+      </p:sp>
+      <p:sp>
+        <p:nvSpPr>
+          <p:cNvPr id="11" name="TextBox 10"/>
+          <p:cNvSpPr txBox="1"/>
+          <p:nvPr/>
+        </p:nvSpPr>
+        <p:spPr>
+          <a:xfrm>
+            <a:off x="4347362" y="1143000"/>
+            <a:ext cx="3496970" cy="365760"/>
+          </a:xfrm>
+          <a:prstGeom prst="rect">
+            <a:avLst/>
+          </a:prstGeom>
+          <a:noFill/>
+        </p:spPr>
+        <p:txBody>
+          <a:bodyPr wrap="square">
+            <a:spAutoFit/>
+          </a:bodyPr>
+          <a:lstStyle/>
+          <a:p>
+            <a:pPr algn="l"/>
+            <a:r>
+              <a:rPr sz="1200" b="1">
+                <a:solidFill>
+                  <a:srgbClr val="8B1A2B"/>
+                </a:solidFill>
+                <a:latin typeface="Microsoft YaHei"/>
+                <a:ea typeface="Microsoft YaHei"/>
+              </a:rPr>
+              <a:t>ACK AI Serving Stack 分层</a:t>
+            </a:r>
+          </a:p>
+        </p:txBody>
+      </p:sp>
+      <p:pic>
+        <p:nvPicPr>
+          <p:cNvPr id="12" name="Picture 11" descr="t02-54-00-crop.png"/>
+          <p:cNvPicPr>
+            <a:picLocks noChangeAspect="1"/>
+          </p:cNvPicPr>
+          <p:nvPr/>
+        </p:nvPicPr>
+        <p:blipFill>
+          <a:blip r:embed="rId3"/>
+          <a:stretch>
+            <a:fillRect/>
+          </a:stretch>
+        </p:blipFill>
+        <p:spPr>
+          <a:xfrm>
+            <a:off x="4347362" y="1946380"/>
+            <a:ext cx="3496970" cy="2965239"/>
+          </a:xfrm>
+          <a:prstGeom prst="rect">
+            <a:avLst/>
+          </a:prstGeom>
+        </p:spPr>
+      </p:pic>
+      <p:sp>
+        <p:nvSpPr>
+          <p:cNvPr id="13" name="TextBox 12"/>
+          <p:cNvSpPr txBox="1"/>
+          <p:nvPr/>
+        </p:nvSpPr>
+        <p:spPr>
+          <a:xfrm>
+            <a:off x="4347362" y="5486400"/>
+            <a:ext cx="3496970" cy="502920"/>
+          </a:xfrm>
+          <a:prstGeom prst="rect">
+            <a:avLst/>
+          </a:prstGeom>
+          <a:noFill/>
+        </p:spPr>
+        <p:txBody>
+          <a:bodyPr wrap="square">
+            <a:spAutoFit/>
+          </a:bodyPr>
+          <a:lstStyle/>
+          <a:p>
+            <a:pPr algn="l"/>
+            <a:r>
+              <a:rPr sz="1100" b="0">
+                <a:solidFill>
+                  <a:srgbClr val="4A4A4A"/>
+                </a:solidFill>
+                <a:latin typeface="Microsoft YaHei"/>
+                <a:ea typeface="Microsoft YaHei"/>
+              </a:rPr>
+              <a:t>网关 / InferenceKit / 存储</a:t>
+            </a:r>
+          </a:p>
+        </p:txBody>
+      </p:sp>
+      <p:sp>
+        <p:nvSpPr>
+          <p:cNvPr id="14" name="Rectangle 13"/>
+          <p:cNvSpPr/>
+          <p:nvPr/>
+        </p:nvSpPr>
+        <p:spPr>
+          <a:xfrm>
+            <a:off x="8155228" y="1051560"/>
+            <a:ext cx="3716426" cy="5074920"/>
+          </a:xfrm>
+          <a:prstGeom prst="rect">
+            <a:avLst/>
+          </a:prstGeom>
+          <a:solidFill>
+            <a:srgbClr val="FFFFFF"/>
+          </a:solidFill>
+          <a:ln w="12700">
+            <a:solidFill>
+              <a:srgbClr val="D0D8DE"/>
+            </a:solidFill>
+          </a:ln>
+        </p:spPr>
+        <p:style>
+          <a:lnRef idx="1">
+            <a:schemeClr val="accent1"/>
+          </a:lnRef>
+          <a:fillRef idx="3">
+            <a:schemeClr val="accent1"/>
+          </a:fillRef>
+          <a:effectRef idx="2">
+            <a:schemeClr val="accent1"/>
+          </a:effectRef>
+          <a:fontRef idx="minor">
+            <a:schemeClr val="lt1"/>
+          </a:fontRef>
+        </p:style>
+        <p:txBody>
+          <a:bodyPr rtlCol="0" anchor="ctr"/>
+          <a:lstStyle/>
+          <a:p>
+            <a:pPr algn="ctr"/>
+          </a:p>
+        </p:txBody>
+      </p:sp>
+      <p:sp>
+        <p:nvSpPr>
+          <p:cNvPr id="15" name="TextBox 14"/>
+          <p:cNvSpPr txBox="1"/>
+          <p:nvPr/>
+        </p:nvSpPr>
+        <p:spPr>
+          <a:xfrm>
+            <a:off x="8264956" y="1143000"/>
+            <a:ext cx="3496970" cy="365760"/>
+          </a:xfrm>
+          <a:prstGeom prst="rect">
+            <a:avLst/>
+          </a:prstGeom>
+          <a:noFill/>
+        </p:spPr>
+        <p:txBody>
+          <a:bodyPr wrap="square">
+            <a:spAutoFit/>
+          </a:bodyPr>
+          <a:lstStyle/>
+          <a:p>
+            <a:pPr algn="l"/>
+            <a:r>
+              <a:rPr sz="1200" b="1">
+                <a:solidFill>
+                  <a:srgbClr val="8B1A2B"/>
+                </a:solidFill>
+                <a:latin typeface="Microsoft YaHei"/>
+                <a:ea typeface="Microsoft YaHei"/>
+              </a:rPr>
+              <a:t>静态 PD → 动态 RBG 演进</a:t>
+            </a:r>
+          </a:p>
+        </p:txBody>
+      </p:sp>
+      <p:pic>
+        <p:nvPicPr>
+          <p:cNvPr id="16" name="Picture 15" descr="t03-07-00-crop.png"/>
           <p:cNvPicPr>
             <a:picLocks noChangeAspect="1"/>
           </p:cNvPicPr>
@@ -5473,7 +7350,7 @@
                 <a:latin typeface="Microsoft YaHei"/>
                 <a:ea typeface="Microsoft YaHei"/>
               </a:rPr>
-              <a:t>Fluid ModelScale：RDMA 原生权重分层搬运</a:t>
+              <a:t>小红书编排两阶段</a:t>
             </a:r>
           </a:p>
         </p:txBody>

</xml_diff>

<commit_message>
Rebuild ACK×小红书 insight as a single-page PPT
Compress Cost/Token, Serving Stack, and static PD→RBG into one
CIPU-style insight slide with technical takeaways and key metrics.

Co-authored-by: Annie <Annie-Summer@users.noreply.github.com>
</commit_message>
<xml_diff>
--- a/yunqi-2026-agenda-201/docs/洞察一页-08-容器服务 × 小红书：大模型推理与 Agent RL.pptx
+++ b/yunqi-2026-agenda-201/docs/洞察一页-08-容器服务 × 小红书：大模型推理与 Agent RL.pptx
@@ -6,8 +6,6 @@
   </p:sldMasterIdLst>
   <p:sldIdLst>
     <p:sldId id="256" r:id="rId7"/>
-    <p:sldId id="257" r:id="rId8"/>
-    <p:sldId id="258" r:id="rId9"/>
   </p:sldIdLst>
   <p:sldSz cx="12191695" cy="6858000" type="screen4x3"/>
   <p:notesSz cx="6858000" cy="9144000"/>
@@ -3142,7 +3140,7 @@
         <p:spPr>
           <a:xfrm>
             <a:off x="0" y="0"/>
-            <a:ext cx="12191695" cy="1078992"/>
+            <a:ext cx="12191695" cy="1115568"/>
           </a:xfrm>
           <a:prstGeom prst="rect">
             <a:avLst/>
@@ -3184,8 +3182,8 @@
         </p:nvSpPr>
         <p:spPr>
           <a:xfrm>
-            <a:off x="320040" y="91440"/>
-            <a:ext cx="11521440" cy="237744"/>
+            <a:off x="320040" y="73152"/>
+            <a:ext cx="11521440" cy="219456"/>
           </a:xfrm>
           <a:prstGeom prst="rect">
             <a:avLst/>
@@ -3200,7 +3198,7 @@
           <a:p>
             <a:pPr algn="l"/>
             <a:r>
-              <a:rPr sz="1200" b="0">
+              <a:rPr sz="1100" b="0">
                 <a:solidFill>
                   <a:srgbClr val="6B6B6B"/>
                 </a:solidFill>
@@ -3220,8 +3218,8 @@
         </p:nvSpPr>
         <p:spPr>
           <a:xfrm>
-            <a:off x="320040" y="347472"/>
-            <a:ext cx="11521440" cy="640080"/>
+            <a:off x="320040" y="310896"/>
+            <a:ext cx="11521440" cy="658368"/>
           </a:xfrm>
           <a:prstGeom prst="rect">
             <a:avLst/>
@@ -3236,14 +3234,14 @@
           <a:p>
             <a:pPr algn="l"/>
             <a:r>
-              <a:rPr sz="1600" b="1">
+              <a:rPr sz="1700" b="1">
                 <a:solidFill>
                   <a:srgbClr val="1A1A1A"/>
                 </a:solidFill>
                 <a:latin typeface="Microsoft YaHei"/>
                 <a:ea typeface="Microsoft YaHei"/>
               </a:rPr>
-              <a:t>洞察：以 Cost/Token 为北极星——降 GPU 单价、抬单卡吞吐、抬利用率三杠杆并用；ACK AI Serving Stack（网关 + InferenceKit + ModelScale）直接打在分母上</a:t>
+              <a:t>从「容器服务 × 小红书」议题看 ACK 围绕 Cost/Token 的 AI 推理降本与编排演进实践</a:t>
             </a:r>
           </a:p>
         </p:txBody>
@@ -3256,8 +3254,8 @@
         </p:nvSpPr>
         <p:spPr>
           <a:xfrm>
-            <a:off x="274320" y="1188720"/>
-            <a:ext cx="11612880" cy="713232"/>
+            <a:off x="274320" y="1207008"/>
+            <a:ext cx="11612880" cy="621792"/>
           </a:xfrm>
           <a:prstGeom prst="rect">
             <a:avLst/>
@@ -3302,7 +3300,7 @@
         <p:spPr>
           <a:xfrm>
             <a:off x="411480" y="1261872"/>
-            <a:ext cx="11338560" cy="585216"/>
+            <a:ext cx="11338560" cy="512064"/>
           </a:xfrm>
           <a:prstGeom prst="rect">
             <a:avLst/>
@@ -3317,14 +3315,14 @@
           <a:p>
             <a:pPr algn="l"/>
             <a:r>
-              <a:rPr sz="1200" b="1">
+              <a:rPr sz="1100" b="1">
                 <a:solidFill>
                   <a:srgbClr val="1A1A1A"/>
                 </a:solidFill>
                 <a:latin typeface="Microsoft YaHei"/>
                 <a:ea typeface="Microsoft YaHei"/>
               </a:rPr>
-              <a:t>一句话判断：阿里云 ACK × 小红书——Cost/Million Tokens = GPU 小时成本 ÷ (Throughput × Utilization)；NVIDIA 亦将 Cost per token 定义为推理 TCO 指标。网关智能路由（TTFT -75%、ITL -40%、吞吐 3×）+ ModelScale 权重秒级加载 + InferenceKit 注入式拓扑优化，把单卡效率做成可复制平台能力。</a:t>
+              <a:t>一句话判断：阿里云 ACK × 小红书以 Cost/Million Tokens = GPU小时成本 ÷ (Throughput × Utilization) 为北极星；用网关智能路由 + ModelScale 权重秒级加载 + InferenceKit 拓扑注入抬分母，用静态 PD→动态 RBG 演进编排，同 SLO 吞吐 2~3×、GPU 节省约 50%。</a:t>
             </a:r>
           </a:p>
         </p:txBody>
@@ -3337,8 +3335,8 @@
         </p:nvSpPr>
         <p:spPr>
           <a:xfrm>
-            <a:off x="274320" y="2029968"/>
-            <a:ext cx="3749039" cy="2331720"/>
+            <a:off x="274320" y="1956816"/>
+            <a:ext cx="3749039" cy="2450592"/>
           </a:xfrm>
           <a:prstGeom prst="rect">
             <a:avLst/>
@@ -3382,8 +3380,8 @@
         </p:nvSpPr>
         <p:spPr>
           <a:xfrm>
-            <a:off x="402336" y="2121408"/>
-            <a:ext cx="3493007" cy="292608"/>
+            <a:off x="384048" y="2029968"/>
+            <a:ext cx="3529583" cy="274320"/>
           </a:xfrm>
           <a:prstGeom prst="rect">
             <a:avLst/>
@@ -3398,7 +3396,7 @@
           <a:p>
             <a:pPr algn="l"/>
             <a:r>
-              <a:rPr sz="1400" b="1">
+              <a:rPr sz="1300" b="1">
                 <a:solidFill>
                   <a:srgbClr val="8B1A2B"/>
                 </a:solidFill>
@@ -3418,8 +3416,8 @@
         </p:nvSpPr>
         <p:spPr>
           <a:xfrm>
-            <a:off x="402336" y="2432304"/>
-            <a:ext cx="3493007" cy="1828800"/>
+            <a:off x="384048" y="2322576"/>
+            <a:ext cx="3529583" cy="1993392"/>
           </a:xfrm>
           <a:prstGeom prst="rect">
             <a:avLst/>
@@ -3434,28 +3432,28 @@
           <a:p>
             <a:pPr algn="l">
               <a:spcAft>
-                <a:spcPts val="200"/>
+                <a:spcPts val="100"/>
               </a:spcAft>
             </a:pPr>
             <a:r>
-              <a:rPr sz="1100" b="1">
+              <a:rPr sz="1000" b="1">
                 <a:solidFill>
                   <a:srgbClr val="1A1A1A"/>
                 </a:solidFill>
                 <a:latin typeface="Microsoft YaHei"/>
                 <a:ea typeface="Microsoft YaHei"/>
               </a:rPr>
-              <a:t>公式：GPU Cost/Hour ÷ (Throughput × Utilization)</a:t>
+              <a:t>技术启示：先立经营目标函数，再选型与调参</a:t>
             </a:r>
           </a:p>
           <a:p>
             <a:pPr algn="l">
               <a:spcAft>
-                <a:spcPts val="200"/>
+                <a:spcPts val="100"/>
               </a:spcAft>
             </a:pPr>
             <a:r>
-              <a:rPr sz="1100" b="0">
+              <a:rPr sz="1000" b="0">
                 <a:solidFill>
                   <a:srgbClr val="4A4A4A"/>
                 </a:solidFill>
@@ -3468,11 +3466,11 @@
           <a:p>
             <a:pPr algn="l">
               <a:spcAft>
-                <a:spcPts val="200"/>
+                <a:spcPts val="100"/>
               </a:spcAft>
             </a:pPr>
             <a:r>
-              <a:rPr sz="1100" b="0">
+              <a:rPr sz="1000" b="0">
                 <a:solidFill>
                   <a:srgbClr val="4A4A4A"/>
                 </a:solidFill>
@@ -3485,18 +3483,35 @@
           <a:p>
             <a:pPr algn="l">
               <a:spcAft>
-                <a:spcPts val="200"/>
+                <a:spcPts val="100"/>
               </a:spcAft>
             </a:pPr>
             <a:r>
-              <a:rPr sz="1100" b="0">
+              <a:rPr sz="1000" b="0">
                 <a:solidFill>
                   <a:srgbClr val="4A4A4A"/>
                 </a:solidFill>
                 <a:latin typeface="Microsoft YaHei"/>
                 <a:ea typeface="Microsoft YaHei"/>
               </a:rPr>
-              <a:t>• 分母利用率：弹性伸缩、KV 感知路由、数据缓存</a:t>
+              <a:t>• 分母利用率：弹性伸缩、KV 感知路由、数据缓存加速</a:t>
+            </a:r>
+          </a:p>
+          <a:p>
+            <a:pPr algn="l">
+              <a:spcAft>
+                <a:spcPts val="100"/>
+              </a:spcAft>
+            </a:pPr>
+            <a:r>
+              <a:rPr sz="1000" b="0">
+                <a:solidFill>
+                  <a:srgbClr val="4A4A4A"/>
+                </a:solidFill>
+                <a:latin typeface="Microsoft YaHei"/>
+                <a:ea typeface="Microsoft YaHei"/>
+              </a:rPr>
+              <a:t>• NVIDIA：Cost per token 定义推理 TCO，非单看算力/FLOP</a:t>
             </a:r>
           </a:p>
         </p:txBody>
@@ -3509,8 +3524,8 @@
         </p:nvSpPr>
         <p:spPr>
           <a:xfrm>
-            <a:off x="4187951" y="2029968"/>
-            <a:ext cx="3749039" cy="2331720"/>
+            <a:off x="4187951" y="1956816"/>
+            <a:ext cx="3749039" cy="2450592"/>
           </a:xfrm>
           <a:prstGeom prst="rect">
             <a:avLst/>
@@ -3554,8 +3569,8 @@
         </p:nvSpPr>
         <p:spPr>
           <a:xfrm>
-            <a:off x="4315967" y="2121408"/>
-            <a:ext cx="3493007" cy="292608"/>
+            <a:off x="4297679" y="2029968"/>
+            <a:ext cx="3529583" cy="274320"/>
           </a:xfrm>
           <a:prstGeom prst="rect">
             <a:avLst/>
@@ -3570,7 +3585,7 @@
           <a:p>
             <a:pPr algn="l"/>
             <a:r>
-              <a:rPr sz="1400" b="1">
+              <a:rPr sz="1300" b="1">
                 <a:solidFill>
                   <a:srgbClr val="8B1A2B"/>
                 </a:solidFill>
@@ -3590,8 +3605,8 @@
         </p:nvSpPr>
         <p:spPr>
           <a:xfrm>
-            <a:off x="4315967" y="2432304"/>
-            <a:ext cx="3493007" cy="1828800"/>
+            <a:off x="4297679" y="2322576"/>
+            <a:ext cx="3529583" cy="1993392"/>
           </a:xfrm>
           <a:prstGeom prst="rect">
             <a:avLst/>
@@ -3606,69 +3621,86 @@
           <a:p>
             <a:pPr algn="l">
               <a:spcAft>
-                <a:spcPts val="200"/>
+                <a:spcPts val="100"/>
               </a:spcAft>
             </a:pPr>
             <a:r>
-              <a:rPr sz="1100" b="1">
+              <a:rPr sz="1000" b="1">
                 <a:solidFill>
                   <a:srgbClr val="1A1A1A"/>
                 </a:solidFill>
                 <a:latin typeface="Microsoft YaHei"/>
                 <a:ea typeface="Microsoft YaHei"/>
               </a:rPr>
-              <a:t>每层能力都直接作用于降本</a:t>
+              <a:t>技术启示：路由+权重分发+拓扑注入做成平台默认能力</a:t>
             </a:r>
           </a:p>
           <a:p>
             <a:pPr algn="l">
               <a:spcAft>
-                <a:spcPts val="200"/>
+                <a:spcPts val="100"/>
               </a:spcAft>
             </a:pPr>
             <a:r>
-              <a:rPr sz="1100" b="0">
+              <a:rPr sz="1000" b="0">
                 <a:solidFill>
                   <a:srgbClr val="4A4A4A"/>
                 </a:solidFill>
                 <a:latin typeface="Microsoft YaHei"/>
                 <a:ea typeface="Microsoft YaHei"/>
               </a:rPr>
-              <a:t>• ModelScale：RDMA+GDR 分层权重，P2P 随规模扩展</a:t>
+              <a:t>• 网关：公平调度+负载/缓存亲和；TTFT -75%、ITL -40%、吞吐 3×</a:t>
             </a:r>
           </a:p>
           <a:p>
             <a:pPr algn="l">
               <a:spcAft>
-                <a:spcPts val="200"/>
+                <a:spcPts val="100"/>
               </a:spcAft>
             </a:pPr>
             <a:r>
-              <a:rPr sz="1100" b="0">
+              <a:rPr sz="1000" b="0">
                 <a:solidFill>
                   <a:srgbClr val="4A4A4A"/>
                 </a:solidFill>
                 <a:latin typeface="Microsoft YaHei"/>
                 <a:ea typeface="Microsoft YaHei"/>
               </a:rPr>
-              <a:t>• InferenceKit：Webhook→Wrapper→插件，无静默自证</a:t>
+              <a:t>• ModelScale：RDMA+GDR+P2P 分层权重；加载 120s→20s</a:t>
             </a:r>
           </a:p>
           <a:p>
             <a:pPr algn="l">
               <a:spcAft>
-                <a:spcPts val="200"/>
+                <a:spcPts val="100"/>
               </a:spcAft>
             </a:pPr>
             <a:r>
-              <a:rPr sz="1100" b="0">
+              <a:rPr sz="1000" b="0">
                 <a:solidFill>
                   <a:srgbClr val="4A4A4A"/>
                 </a:solidFill>
                 <a:latin typeface="Microsoft YaHei"/>
                 <a:ea typeface="Microsoft YaHei"/>
               </a:rPr>
-              <a:t>• 推理网关：公平调度 + 负载感知 + 缓存亲和路由</a:t>
+              <a:t>• InferenceKit：Webhook→Wrapper→插件；无静默、Summary 自证</a:t>
+            </a:r>
+          </a:p>
+          <a:p>
+            <a:pPr algn="l">
+              <a:spcAft>
+                <a:spcPts val="100"/>
+              </a:spcAft>
+            </a:pPr>
+            <a:r>
+              <a:rPr sz="1000" b="0">
+                <a:solidFill>
+                  <a:srgbClr val="4A4A4A"/>
+                </a:solidFill>
+                <a:latin typeface="Microsoft YaHei"/>
+                <a:ea typeface="Microsoft YaHei"/>
+              </a:rPr>
+              <a:t>• NUMA 错配吞吐约 -13%~-14%；ICN64 vs RDMA 吞吐 +40%~55%</a:t>
             </a:r>
           </a:p>
         </p:txBody>
@@ -3681,8 +3713,8 @@
         </p:nvSpPr>
         <p:spPr>
           <a:xfrm>
-            <a:off x="8101582" y="2029968"/>
-            <a:ext cx="3749039" cy="2331720"/>
+            <a:off x="8101582" y="1956816"/>
+            <a:ext cx="3749039" cy="2450592"/>
           </a:xfrm>
           <a:prstGeom prst="rect">
             <a:avLst/>
@@ -3726,8 +3758,8 @@
         </p:nvSpPr>
         <p:spPr>
           <a:xfrm>
-            <a:off x="8229598" y="2121408"/>
-            <a:ext cx="3493007" cy="292608"/>
+            <a:off x="8211310" y="2029968"/>
+            <a:ext cx="3529583" cy="274320"/>
           </a:xfrm>
           <a:prstGeom prst="rect">
             <a:avLst/>
@@ -3742,14 +3774,14 @@
           <a:p>
             <a:pPr algn="l"/>
             <a:r>
-              <a:rPr sz="1400" b="1">
+              <a:rPr sz="1300" b="1">
                 <a:solidFill>
                   <a:srgbClr val="8B1A2B"/>
                 </a:solidFill>
                 <a:latin typeface="Microsoft YaHei"/>
                 <a:ea typeface="Microsoft YaHei"/>
               </a:rPr>
-              <a:t>03  关键实测收益</a:t>
+              <a:t>03  静态 PD → 动态 RBG</a:t>
             </a:r>
           </a:p>
         </p:txBody>
@@ -3762,8 +3794,8 @@
         </p:nvSpPr>
         <p:spPr>
           <a:xfrm>
-            <a:off x="8229598" y="2432304"/>
-            <a:ext cx="3493007" cy="1828800"/>
+            <a:off x="8211310" y="2322576"/>
+            <a:ext cx="3529583" cy="1993392"/>
           </a:xfrm>
           <a:prstGeom prst="rect">
             <a:avLst/>
@@ -3778,69 +3810,86 @@
           <a:p>
             <a:pPr algn="l">
               <a:spcAft>
-                <a:spcPts val="200"/>
+                <a:spcPts val="100"/>
               </a:spcAft>
             </a:pPr>
             <a:r>
-              <a:rPr sz="1100" b="1">
+              <a:rPr sz="1000" b="1">
                 <a:solidFill>
                   <a:srgbClr val="1A1A1A"/>
                 </a:solidFill>
                 <a:latin typeface="Microsoft YaHei"/>
                 <a:ea typeface="Microsoft YaHei"/>
               </a:rPr>
-              <a:t>从加载、路由到场景吞吐全面兑现</a:t>
+              <a:t>技术启示：按性能压力分阶段演进编排，先稳态再弹性</a:t>
             </a:r>
           </a:p>
           <a:p>
             <a:pPr algn="l">
               <a:spcAft>
-                <a:spcPts val="200"/>
+                <a:spcPts val="100"/>
               </a:spcAft>
             </a:pPr>
             <a:r>
-              <a:rPr sz="1100" b="0">
+              <a:rPr sz="1000" b="0">
                 <a:solidFill>
                   <a:srgbClr val="4A4A4A"/>
                 </a:solidFill>
                 <a:latin typeface="Microsoft YaHei"/>
                 <a:ea typeface="Microsoft YaHei"/>
               </a:rPr>
-              <a:t>• 模型加载 120s → 20s（ModelScale + Mooncake）</a:t>
+              <a:t>• 静态 GroupSet：组内 P:D 固定，Gang 成组；原地升级+四级缓存</a:t>
             </a:r>
           </a:p>
           <a:p>
             <a:pPr algn="l">
               <a:spcAft>
-                <a:spcPts val="200"/>
+                <a:spcPts val="100"/>
               </a:spcAft>
             </a:pPr>
             <a:r>
-              <a:rPr sz="1100" b="0">
+              <a:rPr sz="1000" b="0">
                 <a:solidFill>
                   <a:srgbClr val="4A4A4A"/>
                 </a:solidFill>
                 <a:latin typeface="Microsoft YaHei"/>
                 <a:ea typeface="Microsoft YaHei"/>
               </a:rPr>
-              <a:t>• Agent Coding 2.69× / RAG 1.44× / 写作 1.80×</a:t>
+              <a:t>• 动态 RBG：Role 一等公民，独立扩缩/发布；KVCache-Aware 选路</a:t>
             </a:r>
           </a:p>
           <a:p>
             <a:pPr algn="l">
               <a:spcAft>
-                <a:spcPts val="200"/>
+                <a:spcPts val="100"/>
               </a:spcAft>
             </a:pPr>
             <a:r>
-              <a:rPr sz="1100" b="0">
+              <a:rPr sz="1000" b="0">
                 <a:solidFill>
                   <a:srgbClr val="4A4A4A"/>
                 </a:solidFill>
                 <a:latin typeface="Microsoft YaHei"/>
                 <a:ea typeface="Microsoft YaHei"/>
               </a:rPr>
-              <a:t>• Qwen3-32B P2P 加载相对 OSS 提速约 13.5×</a:t>
+              <a:t>• 生产：同 SLO 吞吐 2~3×，GPU 节省约 50%；开源 sgl-project/rbg</a:t>
+            </a:r>
+          </a:p>
+          <a:p>
+            <a:pPr algn="l">
+              <a:spcAft>
+                <a:spcPts val="100"/>
+              </a:spcAft>
+            </a:pPr>
+            <a:r>
+              <a:rPr sz="1000" b="0">
+                <a:solidFill>
+                  <a:srgbClr val="4A4A4A"/>
+                </a:solidFill>
+                <a:latin typeface="Microsoft YaHei"/>
+                <a:ea typeface="Microsoft YaHei"/>
+              </a:rPr>
+              <a:t>• 向上延伸：快照复用 + Rollout 托管，承接训推一体执行面</a:t>
             </a:r>
           </a:p>
         </p:txBody>
@@ -3853,8 +3902,8 @@
         </p:nvSpPr>
         <p:spPr>
           <a:xfrm>
-            <a:off x="274320" y="4498848"/>
-            <a:ext cx="9144000" cy="237744"/>
+            <a:off x="274320" y="4535424"/>
+            <a:ext cx="9144000" cy="219456"/>
           </a:xfrm>
           <a:prstGeom prst="rect">
             <a:avLst/>
@@ -3869,7 +3918,7 @@
           <a:p>
             <a:pPr algn="l"/>
             <a:r>
-              <a:rPr sz="1300" b="1">
+              <a:rPr sz="1200" b="1">
                 <a:solidFill>
                   <a:srgbClr val="1A1A1A"/>
                 </a:solidFill>
@@ -3889,8 +3938,8 @@
         </p:nvSpPr>
         <p:spPr>
           <a:xfrm>
-            <a:off x="274320" y="4754880"/>
-            <a:ext cx="1874519" cy="914400"/>
+            <a:off x="274320" y="4773168"/>
+            <a:ext cx="1874519" cy="841248"/>
           </a:xfrm>
           <a:prstGeom prst="rect">
             <a:avLst/>
@@ -3934,8 +3983,8 @@
         </p:nvSpPr>
         <p:spPr>
           <a:xfrm>
-            <a:off x="365760" y="4809744"/>
-            <a:ext cx="1709927" cy="201168"/>
+            <a:off x="347472" y="4809744"/>
+            <a:ext cx="1746503" cy="182880"/>
           </a:xfrm>
           <a:prstGeom prst="rect">
             <a:avLst/>
@@ -3950,7 +3999,7 @@
           <a:p>
             <a:pPr algn="l"/>
             <a:r>
-              <a:rPr sz="1000" b="0">
+              <a:rPr sz="900" b="0">
                 <a:solidFill>
                   <a:srgbClr val="6B6B6B"/>
                 </a:solidFill>
@@ -3970,8 +4019,8 @@
         </p:nvSpPr>
         <p:spPr>
           <a:xfrm>
-            <a:off x="365760" y="5010912"/>
-            <a:ext cx="1709927" cy="256032"/>
+            <a:off x="347472" y="4992624"/>
+            <a:ext cx="1746503" cy="219456"/>
           </a:xfrm>
           <a:prstGeom prst="rect">
             <a:avLst/>
@@ -3986,14 +4035,14 @@
           <a:p>
             <a:pPr algn="l"/>
             <a:r>
-              <a:rPr sz="1000" b="0">
+              <a:rPr sz="900" b="0">
                 <a:solidFill>
                   <a:srgbClr val="4A4A4A"/>
                 </a:solidFill>
                 <a:latin typeface="Microsoft YaHei"/>
                 <a:ea typeface="Microsoft YaHei"/>
               </a:rPr>
-              <a:t>典型测试场景</a:t>
+              <a:t>典型场景</a:t>
             </a:r>
           </a:p>
         </p:txBody>
@@ -4006,8 +4055,8 @@
         </p:nvSpPr>
         <p:spPr>
           <a:xfrm>
-            <a:off x="365760" y="5266944"/>
-            <a:ext cx="1709927" cy="329184"/>
+            <a:off x="347472" y="5212080"/>
+            <a:ext cx="1746503" cy="329184"/>
           </a:xfrm>
           <a:prstGeom prst="rect">
             <a:avLst/>
@@ -4022,7 +4071,7 @@
           <a:p>
             <a:pPr algn="l"/>
             <a:r>
-              <a:rPr sz="1400" b="1">
+              <a:rPr sz="1300" b="1">
                 <a:solidFill>
                   <a:srgbClr val="8B1A2B"/>
                 </a:solidFill>
@@ -4042,8 +4091,8 @@
         </p:nvSpPr>
         <p:spPr>
           <a:xfrm>
-            <a:off x="2240279" y="4754880"/>
-            <a:ext cx="1874519" cy="914400"/>
+            <a:off x="2240279" y="4773168"/>
+            <a:ext cx="1874519" cy="841248"/>
           </a:xfrm>
           <a:prstGeom prst="rect">
             <a:avLst/>
@@ -4087,8 +4136,8 @@
         </p:nvSpPr>
         <p:spPr>
           <a:xfrm>
-            <a:off x="2331719" y="4809744"/>
-            <a:ext cx="1709927" cy="201168"/>
+            <a:off x="2313431" y="4809744"/>
+            <a:ext cx="1746503" cy="182880"/>
           </a:xfrm>
           <a:prstGeom prst="rect">
             <a:avLst/>
@@ -4103,14 +4152,14 @@
           <a:p>
             <a:pPr algn="l"/>
             <a:r>
-              <a:rPr sz="1000" b="0">
+              <a:rPr sz="900" b="0">
                 <a:solidFill>
                   <a:srgbClr val="6B6B6B"/>
                 </a:solidFill>
                 <a:latin typeface="Microsoft YaHei"/>
                 <a:ea typeface="Microsoft YaHei"/>
               </a:rPr>
-              <a:t>网关 ITL</a:t>
+              <a:t>网关吞吐</a:t>
             </a:r>
           </a:p>
         </p:txBody>
@@ -4123,8 +4172,8 @@
         </p:nvSpPr>
         <p:spPr>
           <a:xfrm>
-            <a:off x="2331719" y="5010912"/>
-            <a:ext cx="1709927" cy="256032"/>
+            <a:off x="2313431" y="4992624"/>
+            <a:ext cx="1746503" cy="219456"/>
           </a:xfrm>
           <a:prstGeom prst="rect">
             <a:avLst/>
@@ -4139,14 +4188,14 @@
           <a:p>
             <a:pPr algn="l"/>
             <a:r>
-              <a:rPr sz="1000" b="0">
+              <a:rPr sz="900" b="0">
                 <a:solidFill>
                   <a:srgbClr val="4A4A4A"/>
                 </a:solidFill>
                 <a:latin typeface="Microsoft YaHei"/>
                 <a:ea typeface="Microsoft YaHei"/>
               </a:rPr>
-              <a:t>典型测试场景</a:t>
+              <a:t>典型场景</a:t>
             </a:r>
           </a:p>
         </p:txBody>
@@ -4159,8 +4208,8 @@
         </p:nvSpPr>
         <p:spPr>
           <a:xfrm>
-            <a:off x="2331719" y="5266944"/>
-            <a:ext cx="1709927" cy="329184"/>
+            <a:off x="2313431" y="5212080"/>
+            <a:ext cx="1746503" cy="329184"/>
           </a:xfrm>
           <a:prstGeom prst="rect">
             <a:avLst/>
@@ -4175,14 +4224,14 @@
           <a:p>
             <a:pPr algn="l"/>
             <a:r>
-              <a:rPr sz="1400" b="1">
+              <a:rPr sz="1300" b="1">
                 <a:solidFill>
                   <a:srgbClr val="8B1A2B"/>
                 </a:solidFill>
                 <a:latin typeface="Microsoft YaHei"/>
                 <a:ea typeface="Microsoft YaHei"/>
               </a:rPr>
-              <a:t>-40%</a:t>
+              <a:t>3×</a:t>
             </a:r>
           </a:p>
         </p:txBody>
@@ -4195,8 +4244,8 @@
         </p:nvSpPr>
         <p:spPr>
           <a:xfrm>
-            <a:off x="4206238" y="4754880"/>
-            <a:ext cx="1874519" cy="914400"/>
+            <a:off x="4206238" y="4773168"/>
+            <a:ext cx="1874519" cy="841248"/>
           </a:xfrm>
           <a:prstGeom prst="rect">
             <a:avLst/>
@@ -4240,8 +4289,8 @@
         </p:nvSpPr>
         <p:spPr>
           <a:xfrm>
-            <a:off x="4297678" y="4809744"/>
-            <a:ext cx="1709927" cy="201168"/>
+            <a:off x="4279390" y="4809744"/>
+            <a:ext cx="1746503" cy="182880"/>
           </a:xfrm>
           <a:prstGeom prst="rect">
             <a:avLst/>
@@ -4256,14 +4305,14 @@
           <a:p>
             <a:pPr algn="l"/>
             <a:r>
-              <a:rPr sz="1000" b="0">
+              <a:rPr sz="900" b="0">
                 <a:solidFill>
                   <a:srgbClr val="6B6B6B"/>
                 </a:solidFill>
                 <a:latin typeface="Microsoft YaHei"/>
                 <a:ea typeface="Microsoft YaHei"/>
               </a:rPr>
-              <a:t>网关吞吐</a:t>
+              <a:t>权重加载</a:t>
             </a:r>
           </a:p>
         </p:txBody>
@@ -4276,8 +4325,8 @@
         </p:nvSpPr>
         <p:spPr>
           <a:xfrm>
-            <a:off x="4297678" y="5010912"/>
-            <a:ext cx="1709927" cy="256032"/>
+            <a:off x="4279390" y="4992624"/>
+            <a:ext cx="1746503" cy="219456"/>
           </a:xfrm>
           <a:prstGeom prst="rect">
             <a:avLst/>
@@ -4292,14 +4341,14 @@
           <a:p>
             <a:pPr algn="l"/>
             <a:r>
-              <a:rPr sz="1000" b="0">
+              <a:rPr sz="900" b="0">
                 <a:solidFill>
                   <a:srgbClr val="4A4A4A"/>
                 </a:solidFill>
                 <a:latin typeface="Microsoft YaHei"/>
                 <a:ea typeface="Microsoft YaHei"/>
               </a:rPr>
-              <a:t>典型测试场景</a:t>
+              <a:t>120s → 20s</a:t>
             </a:r>
           </a:p>
         </p:txBody>
@@ -4312,8 +4361,8 @@
         </p:nvSpPr>
         <p:spPr>
           <a:xfrm>
-            <a:off x="4297678" y="5266944"/>
-            <a:ext cx="1709927" cy="329184"/>
+            <a:off x="4279390" y="5212080"/>
+            <a:ext cx="1746503" cy="329184"/>
           </a:xfrm>
           <a:prstGeom prst="rect">
             <a:avLst/>
@@ -4328,14 +4377,14 @@
           <a:p>
             <a:pPr algn="l"/>
             <a:r>
-              <a:rPr sz="1400" b="1">
+              <a:rPr sz="1300" b="1">
                 <a:solidFill>
                   <a:srgbClr val="8B1A2B"/>
                 </a:solidFill>
                 <a:latin typeface="Microsoft YaHei"/>
                 <a:ea typeface="Microsoft YaHei"/>
               </a:rPr>
-              <a:t>3×</a:t>
+              <a:t>约 6×</a:t>
             </a:r>
           </a:p>
         </p:txBody>
@@ -4348,8 +4397,8 @@
         </p:nvSpPr>
         <p:spPr>
           <a:xfrm>
-            <a:off x="6172197" y="4754880"/>
-            <a:ext cx="1874519" cy="914400"/>
+            <a:off x="6172197" y="4773168"/>
+            <a:ext cx="1874519" cy="841248"/>
           </a:xfrm>
           <a:prstGeom prst="rect">
             <a:avLst/>
@@ -4393,8 +4442,8 @@
         </p:nvSpPr>
         <p:spPr>
           <a:xfrm>
-            <a:off x="6263637" y="4809744"/>
-            <a:ext cx="1709927" cy="201168"/>
+            <a:off x="6245349" y="4809744"/>
+            <a:ext cx="1746503" cy="182880"/>
           </a:xfrm>
           <a:prstGeom prst="rect">
             <a:avLst/>
@@ -4409,14 +4458,14 @@
           <a:p>
             <a:pPr algn="l"/>
             <a:r>
-              <a:rPr sz="1000" b="0">
+              <a:rPr sz="900" b="0">
                 <a:solidFill>
                   <a:srgbClr val="6B6B6B"/>
                 </a:solidFill>
                 <a:latin typeface="Microsoft YaHei"/>
                 <a:ea typeface="Microsoft YaHei"/>
               </a:rPr>
-              <a:t>权重加载</a:t>
+              <a:t>P2P vs OSS</a:t>
             </a:r>
           </a:p>
         </p:txBody>
@@ -4429,8 +4478,8 @@
         </p:nvSpPr>
         <p:spPr>
           <a:xfrm>
-            <a:off x="6263637" y="5010912"/>
-            <a:ext cx="1709927" cy="256032"/>
+            <a:off x="6245349" y="4992624"/>
+            <a:ext cx="1746503" cy="219456"/>
           </a:xfrm>
           <a:prstGeom prst="rect">
             <a:avLst/>
@@ -4445,14 +4494,14 @@
           <a:p>
             <a:pPr algn="l"/>
             <a:r>
-              <a:rPr sz="1000" b="0">
+              <a:rPr sz="900" b="0">
                 <a:solidFill>
                   <a:srgbClr val="4A4A4A"/>
                 </a:solidFill>
                 <a:latin typeface="Microsoft YaHei"/>
                 <a:ea typeface="Microsoft YaHei"/>
               </a:rPr>
-              <a:t>120s → 20s</a:t>
+              <a:t>Qwen3-32B</a:t>
             </a:r>
           </a:p>
         </p:txBody>
@@ -4465,8 +4514,8 @@
         </p:nvSpPr>
         <p:spPr>
           <a:xfrm>
-            <a:off x="6263637" y="5266944"/>
-            <a:ext cx="1709927" cy="329184"/>
+            <a:off x="6245349" y="5212080"/>
+            <a:ext cx="1746503" cy="329184"/>
           </a:xfrm>
           <a:prstGeom prst="rect">
             <a:avLst/>
@@ -4481,14 +4530,14 @@
           <a:p>
             <a:pPr algn="l"/>
             <a:r>
-              <a:rPr sz="1400" b="1">
+              <a:rPr sz="1300" b="1">
                 <a:solidFill>
                   <a:srgbClr val="8B1A2B"/>
                 </a:solidFill>
                 <a:latin typeface="Microsoft YaHei"/>
                 <a:ea typeface="Microsoft YaHei"/>
               </a:rPr>
-              <a:t>约 6×</a:t>
+              <a:t>13.5×</a:t>
             </a:r>
           </a:p>
         </p:txBody>
@@ -4501,8 +4550,8 @@
         </p:nvSpPr>
         <p:spPr>
           <a:xfrm>
-            <a:off x="8138156" y="4754880"/>
-            <a:ext cx="1874519" cy="914400"/>
+            <a:off x="8138156" y="4773168"/>
+            <a:ext cx="1874519" cy="841248"/>
           </a:xfrm>
           <a:prstGeom prst="rect">
             <a:avLst/>
@@ -4546,8 +4595,8 @@
         </p:nvSpPr>
         <p:spPr>
           <a:xfrm>
-            <a:off x="8229596" y="4809744"/>
-            <a:ext cx="1709927" cy="201168"/>
+            <a:off x="8211308" y="4809744"/>
+            <a:ext cx="1746503" cy="182880"/>
           </a:xfrm>
           <a:prstGeom prst="rect">
             <a:avLst/>
@@ -4562,14 +4611,14 @@
           <a:p>
             <a:pPr algn="l"/>
             <a:r>
-              <a:rPr sz="1000" b="0">
+              <a:rPr sz="900" b="0">
                 <a:solidFill>
                   <a:srgbClr val="6B6B6B"/>
                 </a:solidFill>
                 <a:latin typeface="Microsoft YaHei"/>
                 <a:ea typeface="Microsoft YaHei"/>
               </a:rPr>
-              <a:t>P2P vs OSS</a:t>
+              <a:t>同 SLO 吞吐</a:t>
             </a:r>
           </a:p>
         </p:txBody>
@@ -4582,8 +4631,8 @@
         </p:nvSpPr>
         <p:spPr>
           <a:xfrm>
-            <a:off x="8229596" y="5010912"/>
-            <a:ext cx="1709927" cy="256032"/>
+            <a:off x="8211308" y="4992624"/>
+            <a:ext cx="1746503" cy="219456"/>
           </a:xfrm>
           <a:prstGeom prst="rect">
             <a:avLst/>
@@ -4598,14 +4647,14 @@
           <a:p>
             <a:pPr algn="l"/>
             <a:r>
-              <a:rPr sz="1000" b="0">
+              <a:rPr sz="900" b="0">
                 <a:solidFill>
                   <a:srgbClr val="4A4A4A"/>
                 </a:solidFill>
                 <a:latin typeface="Microsoft YaHei"/>
                 <a:ea typeface="Microsoft YaHei"/>
               </a:rPr>
-              <a:t>Qwen3-32B 65GB</a:t>
+              <a:t>小红书生产</a:t>
             </a:r>
           </a:p>
         </p:txBody>
@@ -4618,8 +4667,8 @@
         </p:nvSpPr>
         <p:spPr>
           <a:xfrm>
-            <a:off x="8229596" y="5266944"/>
-            <a:ext cx="1709927" cy="329184"/>
+            <a:off x="8211308" y="5212080"/>
+            <a:ext cx="1746503" cy="329184"/>
           </a:xfrm>
           <a:prstGeom prst="rect">
             <a:avLst/>
@@ -4634,14 +4683,14 @@
           <a:p>
             <a:pPr algn="l"/>
             <a:r>
-              <a:rPr sz="1400" b="1">
+              <a:rPr sz="1300" b="1">
                 <a:solidFill>
                   <a:srgbClr val="8B1A2B"/>
                 </a:solidFill>
                 <a:latin typeface="Microsoft YaHei"/>
                 <a:ea typeface="Microsoft YaHei"/>
               </a:rPr>
-              <a:t>13.5×</a:t>
+              <a:t>2~3×</a:t>
             </a:r>
           </a:p>
         </p:txBody>
@@ -4654,8 +4703,8 @@
         </p:nvSpPr>
         <p:spPr>
           <a:xfrm>
-            <a:off x="10104115" y="4754880"/>
-            <a:ext cx="1874519" cy="914400"/>
+            <a:off x="10104115" y="4773168"/>
+            <a:ext cx="1874519" cy="841248"/>
           </a:xfrm>
           <a:prstGeom prst="rect">
             <a:avLst/>
@@ -4699,8 +4748,8 @@
         </p:nvSpPr>
         <p:spPr>
           <a:xfrm>
-            <a:off x="10195555" y="4809744"/>
-            <a:ext cx="1709927" cy="201168"/>
+            <a:off x="10177267" y="4809744"/>
+            <a:ext cx="1746503" cy="182880"/>
           </a:xfrm>
           <a:prstGeom prst="rect">
             <a:avLst/>
@@ -4715,14 +4764,14 @@
           <a:p>
             <a:pPr algn="l"/>
             <a:r>
-              <a:rPr sz="1000" b="0">
+              <a:rPr sz="900" b="0">
                 <a:solidFill>
                   <a:srgbClr val="6B6B6B"/>
                 </a:solidFill>
                 <a:latin typeface="Microsoft YaHei"/>
                 <a:ea typeface="Microsoft YaHei"/>
               </a:rPr>
-              <a:t>跨 NUMA 代价</a:t>
+              <a:t>GPU 资源</a:t>
             </a:r>
           </a:p>
         </p:txBody>
@@ -4735,8 +4784,8 @@
         </p:nvSpPr>
         <p:spPr>
           <a:xfrm>
-            <a:off x="10195555" y="5010912"/>
-            <a:ext cx="1709927" cy="256032"/>
+            <a:off x="10177267" y="4992624"/>
+            <a:ext cx="1746503" cy="219456"/>
           </a:xfrm>
           <a:prstGeom prst="rect">
             <a:avLst/>
@@ -4751,14 +4800,14 @@
           <a:p>
             <a:pPr algn="l"/>
             <a:r>
-              <a:rPr sz="1000" b="0">
+              <a:rPr sz="900" b="0">
                 <a:solidFill>
                   <a:srgbClr val="4A4A4A"/>
                 </a:solidFill>
                 <a:latin typeface="Microsoft YaHei"/>
                 <a:ea typeface="Microsoft YaHei"/>
               </a:rPr>
-              <a:t>吞吐劣化</a:t>
+              <a:t>小红书生产</a:t>
             </a:r>
           </a:p>
         </p:txBody>
@@ -4771,8 +4820,8 @@
         </p:nvSpPr>
         <p:spPr>
           <a:xfrm>
-            <a:off x="10195555" y="5266944"/>
-            <a:ext cx="1709927" cy="329184"/>
+            <a:off x="10177267" y="5212080"/>
+            <a:ext cx="1746503" cy="329184"/>
           </a:xfrm>
           <a:prstGeom prst="rect">
             <a:avLst/>
@@ -4787,14 +4836,14 @@
           <a:p>
             <a:pPr algn="l"/>
             <a:r>
-              <a:rPr sz="1400" b="1">
+              <a:rPr sz="1300" b="1">
                 <a:solidFill>
                   <a:srgbClr val="8B1A2B"/>
                 </a:solidFill>
                 <a:latin typeface="Microsoft YaHei"/>
                 <a:ea typeface="Microsoft YaHei"/>
               </a:rPr>
-              <a:t>-13.4%</a:t>
+              <a:t>节省 50%</a:t>
             </a:r>
           </a:p>
         </p:txBody>
@@ -4807,8 +4856,8 @@
         </p:nvSpPr>
         <p:spPr>
           <a:xfrm>
-            <a:off x="0" y="5852160"/>
-            <a:ext cx="12191695" cy="1005840"/>
+            <a:off x="0" y="5760720"/>
+            <a:ext cx="12191695" cy="1097280"/>
           </a:xfrm>
           <a:prstGeom prst="rect">
             <a:avLst/>
@@ -4850,8 +4899,8 @@
         </p:nvSpPr>
         <p:spPr>
           <a:xfrm>
-            <a:off x="320040" y="5925312"/>
-            <a:ext cx="11521440" cy="457200"/>
+            <a:off x="320040" y="5815584"/>
+            <a:ext cx="11521440" cy="502920"/>
           </a:xfrm>
           <a:prstGeom prst="rect">
             <a:avLst/>
@@ -4873,7 +4922,7 @@
                 <a:latin typeface="Microsoft YaHei"/>
                 <a:ea typeface="Microsoft YaHei"/>
               </a:rPr>
-              <a:t>启示要点：先立 Cost/Token 公式再选型；Serving Stack 优先打通「权重秒级加载 + 拓扑无静默注入 + KV 感知路由」；NUMA/ICN64 等拓扑错误会静默吃掉吞吐，必须 Summary 自证生效。</a:t>
+              <a:t>技术启示：以 Cost/Token 统一经营与技术目标；把缓存亲和路由、分层权重分发、拓扑感知注入固化进 Serving Stack；按性能压力分阶段演进编排——静态 PD 做成组调度/原地升级/容量防护稳态基座，RBG 做角色解耦与策略协同弹性控制面，持续兑现吞吐提升、时延下降与 GPU 利用率改善。</a:t>
             </a:r>
           </a:p>
         </p:txBody>
@@ -4886,8 +4935,8 @@
         </p:nvSpPr>
         <p:spPr>
           <a:xfrm>
-            <a:off x="320040" y="6382512"/>
-            <a:ext cx="11521440" cy="256032"/>
+            <a:off x="320040" y="6309360"/>
+            <a:ext cx="11521440" cy="237744"/>
           </a:xfrm>
           <a:prstGeom prst="rect">
             <a:avLst/>
@@ -4909,2484 +4958,7 @@
                 <a:latin typeface="Microsoft YaHei"/>
                 <a:ea typeface="Microsoft YaHei"/>
               </a:rPr>
-              <a:t>来源：https://yunqi.aliyun.com/2026/session?agendaId=201 · Talk 08 车漾 / 熊峰 · 第 1/2 页</a:t>
-            </a:r>
-          </a:p>
-        </p:txBody>
-      </p:sp>
-    </p:spTree>
-  </p:cSld>
-  <p:clrMapOvr>
-    <a:masterClrMapping/>
-  </p:clrMapOvr>
-</p:sld>
-</file>
-
-<file path=ppt/slides/slide2.xml><?xml version="1.0" encoding="utf-8"?>
-<p:sld xmlns:a="http://schemas.openxmlformats.org/drawingml/2006/main" xmlns:p="http://schemas.openxmlformats.org/presentationml/2006/main" xmlns:r="http://schemas.openxmlformats.org/officeDocument/2006/relationships">
-  <p:cSld>
-    <p:spTree>
-      <p:nvGrpSpPr>
-        <p:cNvPr id="1" name=""/>
-        <p:cNvGrpSpPr/>
-        <p:nvPr/>
-      </p:nvGrpSpPr>
-      <p:grpSpPr/>
-      <p:sp>
-        <p:nvSpPr>
-          <p:cNvPr id="2" name="Rectangle 1"/>
-          <p:cNvSpPr/>
-          <p:nvPr/>
-        </p:nvSpPr>
-        <p:spPr>
-          <a:xfrm>
-            <a:off x="0" y="0"/>
-            <a:ext cx="12191695" cy="6858000"/>
-          </a:xfrm>
-          <a:prstGeom prst="rect">
-            <a:avLst/>
-          </a:prstGeom>
-          <a:solidFill>
-            <a:srgbClr val="F5F7F9"/>
-          </a:solidFill>
-          <a:ln>
-            <a:noFill/>
-          </a:ln>
-        </p:spPr>
-        <p:style>
-          <a:lnRef idx="1">
-            <a:schemeClr val="accent1"/>
-          </a:lnRef>
-          <a:fillRef idx="3">
-            <a:schemeClr val="accent1"/>
-          </a:fillRef>
-          <a:effectRef idx="2">
-            <a:schemeClr val="accent1"/>
-          </a:effectRef>
-          <a:fontRef idx="minor">
-            <a:schemeClr val="lt1"/>
-          </a:fontRef>
-        </p:style>
-        <p:txBody>
-          <a:bodyPr rtlCol="0" anchor="ctr"/>
-          <a:lstStyle/>
-          <a:p>
-            <a:pPr algn="ctr"/>
-          </a:p>
-        </p:txBody>
-      </p:sp>
-      <p:sp>
-        <p:nvSpPr>
-          <p:cNvPr id="3" name="Rectangle 2"/>
-          <p:cNvSpPr/>
-          <p:nvPr/>
-        </p:nvSpPr>
-        <p:spPr>
-          <a:xfrm>
-            <a:off x="0" y="0"/>
-            <a:ext cx="12191695" cy="1005840"/>
-          </a:xfrm>
-          <a:prstGeom prst="rect">
-            <a:avLst/>
-          </a:prstGeom>
-          <a:solidFill>
-            <a:srgbClr val="FFFFFF"/>
-          </a:solidFill>
-          <a:ln>
-            <a:noFill/>
-          </a:ln>
-        </p:spPr>
-        <p:style>
-          <a:lnRef idx="1">
-            <a:schemeClr val="accent1"/>
-          </a:lnRef>
-          <a:fillRef idx="3">
-            <a:schemeClr val="accent1"/>
-          </a:fillRef>
-          <a:effectRef idx="2">
-            <a:schemeClr val="accent1"/>
-          </a:effectRef>
-          <a:fontRef idx="minor">
-            <a:schemeClr val="lt1"/>
-          </a:fontRef>
-        </p:style>
-        <p:txBody>
-          <a:bodyPr rtlCol="0" anchor="ctr"/>
-          <a:lstStyle/>
-          <a:p>
-            <a:pPr algn="ctr"/>
-          </a:p>
-        </p:txBody>
-      </p:sp>
-      <p:sp>
-        <p:nvSpPr>
-          <p:cNvPr id="4" name="TextBox 3"/>
-          <p:cNvSpPr txBox="1"/>
-          <p:nvPr/>
-        </p:nvSpPr>
-        <p:spPr>
-          <a:xfrm>
-            <a:off x="320040" y="91440"/>
-            <a:ext cx="11521440" cy="237744"/>
-          </a:xfrm>
-          <a:prstGeom prst="rect">
-            <a:avLst/>
-          </a:prstGeom>
-          <a:noFill/>
-        </p:spPr>
-        <p:txBody>
-          <a:bodyPr wrap="square">
-            <a:spAutoFit/>
-          </a:bodyPr>
-          <a:lstStyle/>
-          <a:p>
-            <a:pPr algn="l"/>
-            <a:r>
-              <a:rPr sz="1200" b="0">
-                <a:solidFill>
-                  <a:srgbClr val="6B6B6B"/>
-                </a:solidFill>
-                <a:latin typeface="Microsoft YaHei"/>
-                <a:ea typeface="Microsoft YaHei"/>
-              </a:rPr>
-              <a:t>08 · 续 · 小红书推理编排演进与生产成果</a:t>
-            </a:r>
-          </a:p>
-        </p:txBody>
-      </p:sp>
-      <p:sp>
-        <p:nvSpPr>
-          <p:cNvPr id="5" name="TextBox 4"/>
-          <p:cNvSpPr txBox="1"/>
-          <p:nvPr/>
-        </p:nvSpPr>
-        <p:spPr>
-          <a:xfrm>
-            <a:off x="320040" y="347472"/>
-            <a:ext cx="11521440" cy="548640"/>
-          </a:xfrm>
-          <a:prstGeom prst="rect">
-            <a:avLst/>
-          </a:prstGeom>
-          <a:noFill/>
-        </p:spPr>
-        <p:txBody>
-          <a:bodyPr wrap="square">
-            <a:spAutoFit/>
-          </a:bodyPr>
-          <a:lstStyle/>
-          <a:p>
-            <a:pPr algn="l"/>
-            <a:r>
-              <a:rPr sz="1600" b="1">
-                <a:solidFill>
-                  <a:srgbClr val="1A1A1A"/>
-                </a:solidFill>
-                <a:latin typeface="Microsoft YaHei"/>
-                <a:ea typeface="Microsoft YaHei"/>
-              </a:rPr>
-              <a:t>洞察：性能驱动架构持续演进——从单 Pod 到静态 PD（GroupSet），再到动态 PD（RBG 角色化）；编排、调度与拓扑感知必须同步升级</a:t>
-            </a:r>
-          </a:p>
-        </p:txBody>
-      </p:sp>
-      <p:sp>
-        <p:nvSpPr>
-          <p:cNvPr id="6" name="Rectangle 5"/>
-          <p:cNvSpPr/>
-          <p:nvPr/>
-        </p:nvSpPr>
-        <p:spPr>
-          <a:xfrm>
-            <a:off x="274320" y="1097280"/>
-            <a:ext cx="11612880" cy="566928"/>
-          </a:xfrm>
-          <a:prstGeom prst="rect">
-            <a:avLst/>
-          </a:prstGeom>
-          <a:solidFill>
-            <a:srgbClr val="FFFFFF"/>
-          </a:solidFill>
-          <a:ln w="12700">
-            <a:solidFill>
-              <a:srgbClr val="D0D8DE"/>
-            </a:solidFill>
-          </a:ln>
-        </p:spPr>
-        <p:style>
-          <a:lnRef idx="1">
-            <a:schemeClr val="accent1"/>
-          </a:lnRef>
-          <a:fillRef idx="3">
-            <a:schemeClr val="accent1"/>
-          </a:fillRef>
-          <a:effectRef idx="2">
-            <a:schemeClr val="accent1"/>
-          </a:effectRef>
-          <a:fontRef idx="minor">
-            <a:schemeClr val="lt1"/>
-          </a:fontRef>
-        </p:style>
-        <p:txBody>
-          <a:bodyPr rtlCol="0" anchor="ctr"/>
-          <a:lstStyle/>
-          <a:p>
-            <a:pPr algn="ctr"/>
-          </a:p>
-        </p:txBody>
-      </p:sp>
-      <p:sp>
-        <p:nvSpPr>
-          <p:cNvPr id="7" name="TextBox 6"/>
-          <p:cNvSpPr txBox="1"/>
-          <p:nvPr/>
-        </p:nvSpPr>
-        <p:spPr>
-          <a:xfrm>
-            <a:off x="411480" y="1170432"/>
-            <a:ext cx="11338560" cy="438912"/>
-          </a:xfrm>
-          <a:prstGeom prst="rect">
-            <a:avLst/>
-          </a:prstGeom>
-          <a:noFill/>
-        </p:spPr>
-        <p:txBody>
-          <a:bodyPr wrap="square">
-            <a:spAutoFit/>
-          </a:bodyPr>
-          <a:lstStyle/>
-          <a:p>
-            <a:pPr algn="l"/>
-            <a:r>
-              <a:rPr sz="1200" b="1">
-                <a:solidFill>
-                  <a:srgbClr val="1A1A1A"/>
-                </a:solidFill>
-                <a:latin typeface="Microsoft YaHei"/>
-                <a:ea typeface="Microsoft YaHei"/>
-              </a:rPr>
-              <a:t>一句话判断：小红书 × 阿里云 ACK——同 SLO 下吞吐提升 2~3×、GPU 资源节省约 50%；生产能力沉淀为开源 RoleBasedGroup（github.com/sgl-project/rbg），适配 vLLM / SGLang。</a:t>
-            </a:r>
-          </a:p>
-        </p:txBody>
-      </p:sp>
-      <p:sp>
-        <p:nvSpPr>
-          <p:cNvPr id="8" name="Rectangle 7"/>
-          <p:cNvSpPr/>
-          <p:nvPr/>
-        </p:nvSpPr>
-        <p:spPr>
-          <a:xfrm>
-            <a:off x="274320" y="1810512"/>
-            <a:ext cx="3749039" cy="2468880"/>
-          </a:xfrm>
-          <a:prstGeom prst="rect">
-            <a:avLst/>
-          </a:prstGeom>
-          <a:solidFill>
-            <a:srgbClr val="FFFFFF"/>
-          </a:solidFill>
-          <a:ln w="12700">
-            <a:solidFill>
-              <a:srgbClr val="D0D8DE"/>
-            </a:solidFill>
-          </a:ln>
-        </p:spPr>
-        <p:style>
-          <a:lnRef idx="1">
-            <a:schemeClr val="accent1"/>
-          </a:lnRef>
-          <a:fillRef idx="3">
-            <a:schemeClr val="accent1"/>
-          </a:fillRef>
-          <a:effectRef idx="2">
-            <a:schemeClr val="accent1"/>
-          </a:effectRef>
-          <a:fontRef idx="minor">
-            <a:schemeClr val="lt1"/>
-          </a:fontRef>
-        </p:style>
-        <p:txBody>
-          <a:bodyPr rtlCol="0" anchor="ctr"/>
-          <a:lstStyle/>
-          <a:p>
-            <a:pPr algn="ctr"/>
-          </a:p>
-        </p:txBody>
-      </p:sp>
-      <p:sp>
-        <p:nvSpPr>
-          <p:cNvPr id="9" name="TextBox 8"/>
-          <p:cNvSpPr txBox="1"/>
-          <p:nvPr/>
-        </p:nvSpPr>
-        <p:spPr>
-          <a:xfrm>
-            <a:off x="402336" y="1901952"/>
-            <a:ext cx="3493007" cy="292608"/>
-          </a:xfrm>
-          <a:prstGeom prst="rect">
-            <a:avLst/>
-          </a:prstGeom>
-          <a:noFill/>
-        </p:spPr>
-        <p:txBody>
-          <a:bodyPr wrap="square">
-            <a:spAutoFit/>
-          </a:bodyPr>
-          <a:lstStyle/>
-          <a:p>
-            <a:pPr algn="l"/>
-            <a:r>
-              <a:rPr sz="1400" b="1">
-                <a:solidFill>
-                  <a:srgbClr val="8B1A2B"/>
-                </a:solidFill>
-                <a:latin typeface="Microsoft YaHei"/>
-                <a:ea typeface="Microsoft YaHei"/>
-              </a:rPr>
-              <a:t>01  静态 PD：GroupSet</a:t>
-            </a:r>
-          </a:p>
-        </p:txBody>
-      </p:sp>
-      <p:sp>
-        <p:nvSpPr>
-          <p:cNvPr id="10" name="TextBox 9"/>
-          <p:cNvSpPr txBox="1"/>
-          <p:nvPr/>
-        </p:nvSpPr>
-        <p:spPr>
-          <a:xfrm>
-            <a:off x="402336" y="2212848"/>
-            <a:ext cx="3493007" cy="1965960"/>
-          </a:xfrm>
-          <a:prstGeom prst="rect">
-            <a:avLst/>
-          </a:prstGeom>
-          <a:noFill/>
-        </p:spPr>
-        <p:txBody>
-          <a:bodyPr wrap="square">
-            <a:spAutoFit/>
-          </a:bodyPr>
-          <a:lstStyle/>
-          <a:p>
-            <a:pPr algn="l">
-              <a:spcAft>
-                <a:spcPts val="300"/>
-              </a:spcAft>
-            </a:pPr>
-            <a:r>
-              <a:rPr sz="1100" b="1">
-                <a:solidFill>
-                  <a:srgbClr val="1A1A1A"/>
-                </a:solidFill>
-                <a:latin typeface="Microsoft YaHei"/>
-                <a:ea typeface="Microsoft YaHei"/>
-              </a:rPr>
-              <a:t>组内配比固定，弹性靠组副本数</a:t>
-            </a:r>
-          </a:p>
-          <a:p>
-            <a:pPr algn="l">
-              <a:spcAft>
-                <a:spcPts val="300"/>
-              </a:spcAft>
-            </a:pPr>
-            <a:r>
-              <a:rPr sz="1100" b="0">
-                <a:solidFill>
-                  <a:srgbClr val="4A4A4A"/>
-                </a:solidFill>
-                <a:latin typeface="Microsoft YaHei"/>
-                <a:ea typeface="Microsoft YaHei"/>
-              </a:rPr>
-              <a:t>• PodGroup 固定 P:D（如 2P:1D），Gang 成组调度</a:t>
-            </a:r>
-          </a:p>
-          <a:p>
-            <a:pPr algn="l">
-              <a:spcAft>
-                <a:spcPts val="300"/>
-              </a:spcAft>
-            </a:pPr>
-            <a:r>
-              <a:rPr sz="1100" b="0">
-                <a:solidFill>
-                  <a:srgbClr val="4A4A4A"/>
-                </a:solidFill>
-                <a:latin typeface="Microsoft YaHei"/>
-                <a:ea typeface="Microsoft YaHei"/>
-              </a:rPr>
-              <a:t>• 原地升级 + 四级缓存：镜像/权重/Kernel/KV</a:t>
-            </a:r>
-          </a:p>
-          <a:p>
-            <a:pPr algn="l">
-              <a:spcAft>
-                <a:spcPts val="300"/>
-              </a:spcAft>
-            </a:pPr>
-            <a:r>
-              <a:rPr sz="1100" b="0">
-                <a:solidFill>
-                  <a:srgbClr val="4A4A4A"/>
-                </a:solidFill>
-                <a:latin typeface="Microsoft YaHei"/>
-                <a:ea typeface="Microsoft YaHei"/>
-              </a:rPr>
-              <a:t>• 升级耗时从数十分钟 → 数分钟；分批暂停与容量底线防护</a:t>
-            </a:r>
-          </a:p>
-        </p:txBody>
-      </p:sp>
-      <p:sp>
-        <p:nvSpPr>
-          <p:cNvPr id="11" name="Rectangle 10"/>
-          <p:cNvSpPr/>
-          <p:nvPr/>
-        </p:nvSpPr>
-        <p:spPr>
-          <a:xfrm>
-            <a:off x="4187951" y="1810512"/>
-            <a:ext cx="3749039" cy="2468880"/>
-          </a:xfrm>
-          <a:prstGeom prst="rect">
-            <a:avLst/>
-          </a:prstGeom>
-          <a:solidFill>
-            <a:srgbClr val="FFFFFF"/>
-          </a:solidFill>
-          <a:ln w="12700">
-            <a:solidFill>
-              <a:srgbClr val="D0D8DE"/>
-            </a:solidFill>
-          </a:ln>
-        </p:spPr>
-        <p:style>
-          <a:lnRef idx="1">
-            <a:schemeClr val="accent1"/>
-          </a:lnRef>
-          <a:fillRef idx="3">
-            <a:schemeClr val="accent1"/>
-          </a:fillRef>
-          <a:effectRef idx="2">
-            <a:schemeClr val="accent1"/>
-          </a:effectRef>
-          <a:fontRef idx="minor">
-            <a:schemeClr val="lt1"/>
-          </a:fontRef>
-        </p:style>
-        <p:txBody>
-          <a:bodyPr rtlCol="0" anchor="ctr"/>
-          <a:lstStyle/>
-          <a:p>
-            <a:pPr algn="ctr"/>
-          </a:p>
-        </p:txBody>
-      </p:sp>
-      <p:sp>
-        <p:nvSpPr>
-          <p:cNvPr id="12" name="TextBox 11"/>
-          <p:cNvSpPr txBox="1"/>
-          <p:nvPr/>
-        </p:nvSpPr>
-        <p:spPr>
-          <a:xfrm>
-            <a:off x="4315967" y="1901952"/>
-            <a:ext cx="3493007" cy="292608"/>
-          </a:xfrm>
-          <a:prstGeom prst="rect">
-            <a:avLst/>
-          </a:prstGeom>
-          <a:noFill/>
-        </p:spPr>
-        <p:txBody>
-          <a:bodyPr wrap="square">
-            <a:spAutoFit/>
-          </a:bodyPr>
-          <a:lstStyle/>
-          <a:p>
-            <a:pPr algn="l"/>
-            <a:r>
-              <a:rPr sz="1400" b="1">
-                <a:solidFill>
-                  <a:srgbClr val="8B1A2B"/>
-                </a:solidFill>
-                <a:latin typeface="Microsoft YaHei"/>
-                <a:ea typeface="Microsoft YaHei"/>
-              </a:rPr>
-              <a:t>02  动态 PD：RBG</a:t>
-            </a:r>
-          </a:p>
-        </p:txBody>
-      </p:sp>
-      <p:sp>
-        <p:nvSpPr>
-          <p:cNvPr id="13" name="TextBox 12"/>
-          <p:cNvSpPr txBox="1"/>
-          <p:nvPr/>
-        </p:nvSpPr>
-        <p:spPr>
-          <a:xfrm>
-            <a:off x="4315967" y="2212848"/>
-            <a:ext cx="3493007" cy="1965960"/>
-          </a:xfrm>
-          <a:prstGeom prst="rect">
-            <a:avLst/>
-          </a:prstGeom>
-          <a:noFill/>
-        </p:spPr>
-        <p:txBody>
-          <a:bodyPr wrap="square">
-            <a:spAutoFit/>
-          </a:bodyPr>
-          <a:lstStyle/>
-          <a:p>
-            <a:pPr algn="l">
-              <a:spcAft>
-                <a:spcPts val="300"/>
-              </a:spcAft>
-            </a:pPr>
-            <a:r>
-              <a:rPr sz="1100" b="1">
-                <a:solidFill>
-                  <a:srgbClr val="1A1A1A"/>
-                </a:solidFill>
-                <a:latin typeface="Microsoft YaHei"/>
-                <a:ea typeface="Microsoft YaHei"/>
-              </a:rPr>
-              <a:t>Role 为一等编排单元，策略表达协同</a:t>
-            </a:r>
-          </a:p>
-          <a:p>
-            <a:pPr algn="l">
-              <a:spcAft>
-                <a:spcPts val="300"/>
-              </a:spcAft>
-            </a:pPr>
-            <a:r>
-              <a:rPr sz="1100" b="0">
-                <a:solidFill>
-                  <a:srgbClr val="4A4A4A"/>
-                </a:solidFill>
-                <a:latin typeface="Microsoft YaHei"/>
-                <a:ea typeface="Microsoft YaHei"/>
-              </a:rPr>
-              <a:t>• Router/Prefill/Decode/KV 各自扩缩与发布</a:t>
-            </a:r>
-          </a:p>
-          <a:p>
-            <a:pPr algn="l">
-              <a:spcAft>
-                <a:spcPts val="300"/>
-              </a:spcAft>
-            </a:pPr>
-            <a:r>
-              <a:rPr sz="1100" b="0">
-                <a:solidFill>
-                  <a:srgbClr val="4A4A4A"/>
-                </a:solidFill>
-                <a:latin typeface="Microsoft YaHei"/>
-                <a:ea typeface="Microsoft YaHei"/>
-              </a:rPr>
-              <a:t>• 双层 Gang + CoordinatedPolicy（maxSkew）</a:t>
-            </a:r>
-          </a:p>
-          <a:p>
-            <a:pPr algn="l">
-              <a:spcAft>
-                <a:spcPts val="300"/>
-              </a:spcAft>
-            </a:pPr>
-            <a:r>
-              <a:rPr sz="1100" b="0">
-                <a:solidFill>
-                  <a:srgbClr val="4A4A4A"/>
-                </a:solidFill>
-                <a:latin typeface="Microsoft YaHei"/>
-                <a:ea typeface="Microsoft YaHei"/>
-              </a:rPr>
-              <a:t>• KVCache-Aware 全局选路：命中率 + 负载健康</a:t>
-            </a:r>
-          </a:p>
-        </p:txBody>
-      </p:sp>
-      <p:sp>
-        <p:nvSpPr>
-          <p:cNvPr id="14" name="Rectangle 13"/>
-          <p:cNvSpPr/>
-          <p:nvPr/>
-        </p:nvSpPr>
-        <p:spPr>
-          <a:xfrm>
-            <a:off x="8101582" y="1810512"/>
-            <a:ext cx="3749039" cy="2468880"/>
-          </a:xfrm>
-          <a:prstGeom prst="rect">
-            <a:avLst/>
-          </a:prstGeom>
-          <a:solidFill>
-            <a:srgbClr val="FFFFFF"/>
-          </a:solidFill>
-          <a:ln w="12700">
-            <a:solidFill>
-              <a:srgbClr val="D0D8DE"/>
-            </a:solidFill>
-          </a:ln>
-        </p:spPr>
-        <p:style>
-          <a:lnRef idx="1">
-            <a:schemeClr val="accent1"/>
-          </a:lnRef>
-          <a:fillRef idx="3">
-            <a:schemeClr val="accent1"/>
-          </a:fillRef>
-          <a:effectRef idx="2">
-            <a:schemeClr val="accent1"/>
-          </a:effectRef>
-          <a:fontRef idx="minor">
-            <a:schemeClr val="lt1"/>
-          </a:fontRef>
-        </p:style>
-        <p:txBody>
-          <a:bodyPr rtlCol="0" anchor="ctr"/>
-          <a:lstStyle/>
-          <a:p>
-            <a:pPr algn="ctr"/>
-          </a:p>
-        </p:txBody>
-      </p:sp>
-      <p:sp>
-        <p:nvSpPr>
-          <p:cNvPr id="15" name="TextBox 14"/>
-          <p:cNvSpPr txBox="1"/>
-          <p:nvPr/>
-        </p:nvSpPr>
-        <p:spPr>
-          <a:xfrm>
-            <a:off x="8229598" y="1901952"/>
-            <a:ext cx="3493007" cy="292608"/>
-          </a:xfrm>
-          <a:prstGeom prst="rect">
-            <a:avLst/>
-          </a:prstGeom>
-          <a:noFill/>
-        </p:spPr>
-        <p:txBody>
-          <a:bodyPr wrap="square">
-            <a:spAutoFit/>
-          </a:bodyPr>
-          <a:lstStyle/>
-          <a:p>
-            <a:pPr algn="l"/>
-            <a:r>
-              <a:rPr sz="1400" b="1">
-                <a:solidFill>
-                  <a:srgbClr val="8B1A2B"/>
-                </a:solidFill>
-                <a:latin typeface="Microsoft YaHei"/>
-                <a:ea typeface="Microsoft YaHei"/>
-              </a:rPr>
-              <a:t>03  RL 与工具链延伸</a:t>
-            </a:r>
-          </a:p>
-        </p:txBody>
-      </p:sp>
-      <p:sp>
-        <p:nvSpPr>
-          <p:cNvPr id="16" name="TextBox 15"/>
-          <p:cNvSpPr txBox="1"/>
-          <p:nvPr/>
-        </p:nvSpPr>
-        <p:spPr>
-          <a:xfrm>
-            <a:off x="8229598" y="2212848"/>
-            <a:ext cx="3493007" cy="1965960"/>
-          </a:xfrm>
-          <a:prstGeom prst="rect">
-            <a:avLst/>
-          </a:prstGeom>
-          <a:noFill/>
-        </p:spPr>
-        <p:txBody>
-          <a:bodyPr wrap="square">
-            <a:spAutoFit/>
-          </a:bodyPr>
-          <a:lstStyle/>
-          <a:p>
-            <a:pPr algn="l">
-              <a:spcAft>
-                <a:spcPts val="300"/>
-              </a:spcAft>
-            </a:pPr>
-            <a:r>
-              <a:rPr sz="1100" b="1">
-                <a:solidFill>
-                  <a:srgbClr val="1A1A1A"/>
-                </a:solidFill>
-                <a:latin typeface="Microsoft YaHei"/>
-                <a:ea typeface="Microsoft YaHei"/>
-              </a:rPr>
-              <a:t>状态复用贯通训练与评测</a:t>
-            </a:r>
-          </a:p>
-          <a:p>
-            <a:pPr algn="l">
-              <a:spcAft>
-                <a:spcPts val="300"/>
-              </a:spcAft>
-            </a:pPr>
-            <a:r>
-              <a:rPr sz="1100" b="0">
-                <a:solidFill>
-                  <a:srgbClr val="4A4A4A"/>
-                </a:solidFill>
-                <a:latin typeface="Microsoft YaHei"/>
-                <a:ea typeface="Microsoft YaHei"/>
-              </a:rPr>
-              <a:t>• 快照四要素：rootfs / 存储 / 内存 / 轨迹 WAL</a:t>
-            </a:r>
-          </a:p>
-          <a:p>
-            <a:pPr algn="l">
-              <a:spcAft>
-                <a:spcPts val="300"/>
-              </a:spcAft>
-            </a:pPr>
-            <a:r>
-              <a:rPr sz="1100" b="0">
-                <a:solidFill>
-                  <a:srgbClr val="4A4A4A"/>
-                </a:solidFill>
-                <a:latin typeface="Microsoft YaHei"/>
-                <a:ea typeface="Microsoft YaHei"/>
-              </a:rPr>
-              <a:t>• Rollout 托管：Env 接入 + Agent Harness 管线</a:t>
-            </a:r>
-          </a:p>
-          <a:p>
-            <a:pPr algn="l">
-              <a:spcAft>
-                <a:spcPts val="300"/>
-              </a:spcAft>
-            </a:pPr>
-            <a:r>
-              <a:rPr sz="1100" b="0">
-                <a:solidFill>
-                  <a:srgbClr val="4A4A4A"/>
-                </a:solidFill>
-                <a:latin typeface="Microsoft YaHei"/>
-                <a:ea typeface="Microsoft YaHei"/>
-              </a:rPr>
-              <a:t>• arena llm：配比生成 / 自动寻优 / 一键部署</a:t>
-            </a:r>
-          </a:p>
-        </p:txBody>
-      </p:sp>
-      <p:sp>
-        <p:nvSpPr>
-          <p:cNvPr id="17" name="TextBox 16"/>
-          <p:cNvSpPr txBox="1"/>
-          <p:nvPr/>
-        </p:nvSpPr>
-        <p:spPr>
-          <a:xfrm>
-            <a:off x="274320" y="4434840"/>
-            <a:ext cx="9144000" cy="237744"/>
-          </a:xfrm>
-          <a:prstGeom prst="rect">
-            <a:avLst/>
-          </a:prstGeom>
-          <a:noFill/>
-        </p:spPr>
-        <p:txBody>
-          <a:bodyPr wrap="square">
-            <a:spAutoFit/>
-          </a:bodyPr>
-          <a:lstStyle/>
-          <a:p>
-            <a:pPr algn="l"/>
-            <a:r>
-              <a:rPr sz="1300" b="1">
-                <a:solidFill>
-                  <a:srgbClr val="1A1A1A"/>
-                </a:solidFill>
-                <a:latin typeface="Microsoft YaHei"/>
-                <a:ea typeface="Microsoft YaHei"/>
-              </a:rPr>
-              <a:t>生产成果与关键能力指标</a:t>
-            </a:r>
-          </a:p>
-        </p:txBody>
-      </p:sp>
-      <p:sp>
-        <p:nvSpPr>
-          <p:cNvPr id="18" name="Rectangle 17"/>
-          <p:cNvSpPr/>
-          <p:nvPr/>
-        </p:nvSpPr>
-        <p:spPr>
-          <a:xfrm>
-            <a:off x="274320" y="4690872"/>
-            <a:ext cx="1874519" cy="914400"/>
-          </a:xfrm>
-          <a:prstGeom prst="rect">
-            <a:avLst/>
-          </a:prstGeom>
-          <a:solidFill>
-            <a:srgbClr val="FFFFFF"/>
-          </a:solidFill>
-          <a:ln w="12700">
-            <a:solidFill>
-              <a:srgbClr val="D0D8DE"/>
-            </a:solidFill>
-          </a:ln>
-        </p:spPr>
-        <p:style>
-          <a:lnRef idx="1">
-            <a:schemeClr val="accent1"/>
-          </a:lnRef>
-          <a:fillRef idx="3">
-            <a:schemeClr val="accent1"/>
-          </a:fillRef>
-          <a:effectRef idx="2">
-            <a:schemeClr val="accent1"/>
-          </a:effectRef>
-          <a:fontRef idx="minor">
-            <a:schemeClr val="lt1"/>
-          </a:fontRef>
-        </p:style>
-        <p:txBody>
-          <a:bodyPr rtlCol="0" anchor="ctr"/>
-          <a:lstStyle/>
-          <a:p>
-            <a:pPr algn="ctr"/>
-          </a:p>
-        </p:txBody>
-      </p:sp>
-      <p:sp>
-        <p:nvSpPr>
-          <p:cNvPr id="19" name="TextBox 18"/>
-          <p:cNvSpPr txBox="1"/>
-          <p:nvPr/>
-        </p:nvSpPr>
-        <p:spPr>
-          <a:xfrm>
-            <a:off x="365760" y="4745736"/>
-            <a:ext cx="1709927" cy="201168"/>
-          </a:xfrm>
-          <a:prstGeom prst="rect">
-            <a:avLst/>
-          </a:prstGeom>
-          <a:noFill/>
-        </p:spPr>
-        <p:txBody>
-          <a:bodyPr wrap="square">
-            <a:spAutoFit/>
-          </a:bodyPr>
-          <a:lstStyle/>
-          <a:p>
-            <a:pPr algn="l"/>
-            <a:r>
-              <a:rPr sz="1000" b="0">
-                <a:solidFill>
-                  <a:srgbClr val="6B6B6B"/>
-                </a:solidFill>
-                <a:latin typeface="Microsoft YaHei"/>
-                <a:ea typeface="Microsoft YaHei"/>
-              </a:rPr>
-              <a:t>同 SLO 吞吐</a:t>
-            </a:r>
-          </a:p>
-        </p:txBody>
-      </p:sp>
-      <p:sp>
-        <p:nvSpPr>
-          <p:cNvPr id="20" name="TextBox 19"/>
-          <p:cNvSpPr txBox="1"/>
-          <p:nvPr/>
-        </p:nvSpPr>
-        <p:spPr>
-          <a:xfrm>
-            <a:off x="365760" y="4946904"/>
-            <a:ext cx="1709927" cy="256032"/>
-          </a:xfrm>
-          <a:prstGeom prst="rect">
-            <a:avLst/>
-          </a:prstGeom>
-          <a:noFill/>
-        </p:spPr>
-        <p:txBody>
-          <a:bodyPr wrap="square">
-            <a:spAutoFit/>
-          </a:bodyPr>
-          <a:lstStyle/>
-          <a:p>
-            <a:pPr algn="l"/>
-            <a:r>
-              <a:rPr sz="1000" b="0">
-                <a:solidFill>
-                  <a:srgbClr val="4A4A4A"/>
-                </a:solidFill>
-                <a:latin typeface="Microsoft YaHei"/>
-                <a:ea typeface="Microsoft YaHei"/>
-              </a:rPr>
-              <a:t>生产验证</a:t>
-            </a:r>
-          </a:p>
-        </p:txBody>
-      </p:sp>
-      <p:sp>
-        <p:nvSpPr>
-          <p:cNvPr id="21" name="TextBox 20"/>
-          <p:cNvSpPr txBox="1"/>
-          <p:nvPr/>
-        </p:nvSpPr>
-        <p:spPr>
-          <a:xfrm>
-            <a:off x="365760" y="5202936"/>
-            <a:ext cx="1709927" cy="329184"/>
-          </a:xfrm>
-          <a:prstGeom prst="rect">
-            <a:avLst/>
-          </a:prstGeom>
-          <a:noFill/>
-        </p:spPr>
-        <p:txBody>
-          <a:bodyPr wrap="square">
-            <a:spAutoFit/>
-          </a:bodyPr>
-          <a:lstStyle/>
-          <a:p>
-            <a:pPr algn="l"/>
-            <a:r>
-              <a:rPr sz="1300" b="1">
-                <a:solidFill>
-                  <a:srgbClr val="8B1A2B"/>
-                </a:solidFill>
-                <a:latin typeface="Microsoft YaHei"/>
-                <a:ea typeface="Microsoft YaHei"/>
-              </a:rPr>
-              <a:t>2~3×</a:t>
-            </a:r>
-          </a:p>
-        </p:txBody>
-      </p:sp>
-      <p:sp>
-        <p:nvSpPr>
-          <p:cNvPr id="22" name="Rectangle 21"/>
-          <p:cNvSpPr/>
-          <p:nvPr/>
-        </p:nvSpPr>
-        <p:spPr>
-          <a:xfrm>
-            <a:off x="2240279" y="4690872"/>
-            <a:ext cx="1874519" cy="914400"/>
-          </a:xfrm>
-          <a:prstGeom prst="rect">
-            <a:avLst/>
-          </a:prstGeom>
-          <a:solidFill>
-            <a:srgbClr val="FFFFFF"/>
-          </a:solidFill>
-          <a:ln w="12700">
-            <a:solidFill>
-              <a:srgbClr val="D0D8DE"/>
-            </a:solidFill>
-          </a:ln>
-        </p:spPr>
-        <p:style>
-          <a:lnRef idx="1">
-            <a:schemeClr val="accent1"/>
-          </a:lnRef>
-          <a:fillRef idx="3">
-            <a:schemeClr val="accent1"/>
-          </a:fillRef>
-          <a:effectRef idx="2">
-            <a:schemeClr val="accent1"/>
-          </a:effectRef>
-          <a:fontRef idx="minor">
-            <a:schemeClr val="lt1"/>
-          </a:fontRef>
-        </p:style>
-        <p:txBody>
-          <a:bodyPr rtlCol="0" anchor="ctr"/>
-          <a:lstStyle/>
-          <a:p>
-            <a:pPr algn="ctr"/>
-          </a:p>
-        </p:txBody>
-      </p:sp>
-      <p:sp>
-        <p:nvSpPr>
-          <p:cNvPr id="23" name="TextBox 22"/>
-          <p:cNvSpPr txBox="1"/>
-          <p:nvPr/>
-        </p:nvSpPr>
-        <p:spPr>
-          <a:xfrm>
-            <a:off x="2331719" y="4745736"/>
-            <a:ext cx="1709927" cy="201168"/>
-          </a:xfrm>
-          <a:prstGeom prst="rect">
-            <a:avLst/>
-          </a:prstGeom>
-          <a:noFill/>
-        </p:spPr>
-        <p:txBody>
-          <a:bodyPr wrap="square">
-            <a:spAutoFit/>
-          </a:bodyPr>
-          <a:lstStyle/>
-          <a:p>
-            <a:pPr algn="l"/>
-            <a:r>
-              <a:rPr sz="1000" b="0">
-                <a:solidFill>
-                  <a:srgbClr val="6B6B6B"/>
-                </a:solidFill>
-                <a:latin typeface="Microsoft YaHei"/>
-                <a:ea typeface="Microsoft YaHei"/>
-              </a:rPr>
-              <a:t>GPU 资源</a:t>
-            </a:r>
-          </a:p>
-        </p:txBody>
-      </p:sp>
-      <p:sp>
-        <p:nvSpPr>
-          <p:cNvPr id="24" name="TextBox 23"/>
-          <p:cNvSpPr txBox="1"/>
-          <p:nvPr/>
-        </p:nvSpPr>
-        <p:spPr>
-          <a:xfrm>
-            <a:off x="2331719" y="4946904"/>
-            <a:ext cx="1709927" cy="256032"/>
-          </a:xfrm>
-          <a:prstGeom prst="rect">
-            <a:avLst/>
-          </a:prstGeom>
-          <a:noFill/>
-        </p:spPr>
-        <p:txBody>
-          <a:bodyPr wrap="square">
-            <a:spAutoFit/>
-          </a:bodyPr>
-          <a:lstStyle/>
-          <a:p>
-            <a:pPr algn="l"/>
-            <a:r>
-              <a:rPr sz="1000" b="0">
-                <a:solidFill>
-                  <a:srgbClr val="4A4A4A"/>
-                </a:solidFill>
-                <a:latin typeface="Microsoft YaHei"/>
-                <a:ea typeface="Microsoft YaHei"/>
-              </a:rPr>
-              <a:t>生产验证</a:t>
-            </a:r>
-          </a:p>
-        </p:txBody>
-      </p:sp>
-      <p:sp>
-        <p:nvSpPr>
-          <p:cNvPr id="25" name="TextBox 24"/>
-          <p:cNvSpPr txBox="1"/>
-          <p:nvPr/>
-        </p:nvSpPr>
-        <p:spPr>
-          <a:xfrm>
-            <a:off x="2331719" y="5202936"/>
-            <a:ext cx="1709927" cy="329184"/>
-          </a:xfrm>
-          <a:prstGeom prst="rect">
-            <a:avLst/>
-          </a:prstGeom>
-          <a:noFill/>
-        </p:spPr>
-        <p:txBody>
-          <a:bodyPr wrap="square">
-            <a:spAutoFit/>
-          </a:bodyPr>
-          <a:lstStyle/>
-          <a:p>
-            <a:pPr algn="l"/>
-            <a:r>
-              <a:rPr sz="1300" b="1">
-                <a:solidFill>
-                  <a:srgbClr val="8B1A2B"/>
-                </a:solidFill>
-                <a:latin typeface="Microsoft YaHei"/>
-                <a:ea typeface="Microsoft YaHei"/>
-              </a:rPr>
-              <a:t>节省 50%</a:t>
-            </a:r>
-          </a:p>
-        </p:txBody>
-      </p:sp>
-      <p:sp>
-        <p:nvSpPr>
-          <p:cNvPr id="26" name="Rectangle 25"/>
-          <p:cNvSpPr/>
-          <p:nvPr/>
-        </p:nvSpPr>
-        <p:spPr>
-          <a:xfrm>
-            <a:off x="4206238" y="4690872"/>
-            <a:ext cx="1874519" cy="914400"/>
-          </a:xfrm>
-          <a:prstGeom prst="rect">
-            <a:avLst/>
-          </a:prstGeom>
-          <a:solidFill>
-            <a:srgbClr val="FFFFFF"/>
-          </a:solidFill>
-          <a:ln w="12700">
-            <a:solidFill>
-              <a:srgbClr val="D0D8DE"/>
-            </a:solidFill>
-          </a:ln>
-        </p:spPr>
-        <p:style>
-          <a:lnRef idx="1">
-            <a:schemeClr val="accent1"/>
-          </a:lnRef>
-          <a:fillRef idx="3">
-            <a:schemeClr val="accent1"/>
-          </a:fillRef>
-          <a:effectRef idx="2">
-            <a:schemeClr val="accent1"/>
-          </a:effectRef>
-          <a:fontRef idx="minor">
-            <a:schemeClr val="lt1"/>
-          </a:fontRef>
-        </p:style>
-        <p:txBody>
-          <a:bodyPr rtlCol="0" anchor="ctr"/>
-          <a:lstStyle/>
-          <a:p>
-            <a:pPr algn="ctr"/>
-          </a:p>
-        </p:txBody>
-      </p:sp>
-      <p:sp>
-        <p:nvSpPr>
-          <p:cNvPr id="27" name="TextBox 26"/>
-          <p:cNvSpPr txBox="1"/>
-          <p:nvPr/>
-        </p:nvSpPr>
-        <p:spPr>
-          <a:xfrm>
-            <a:off x="4297678" y="4745736"/>
-            <a:ext cx="1709927" cy="201168"/>
-          </a:xfrm>
-          <a:prstGeom prst="rect">
-            <a:avLst/>
-          </a:prstGeom>
-          <a:noFill/>
-        </p:spPr>
-        <p:txBody>
-          <a:bodyPr wrap="square">
-            <a:spAutoFit/>
-          </a:bodyPr>
-          <a:lstStyle/>
-          <a:p>
-            <a:pPr algn="l"/>
-            <a:r>
-              <a:rPr sz="1000" b="0">
-                <a:solidFill>
-                  <a:srgbClr val="6B6B6B"/>
-                </a:solidFill>
-                <a:latin typeface="Microsoft YaHei"/>
-                <a:ea typeface="Microsoft YaHei"/>
-              </a:rPr>
-              <a:t>FlashGPU 驻留</a:t>
-            </a:r>
-          </a:p>
-        </p:txBody>
-      </p:sp>
-      <p:sp>
-        <p:nvSpPr>
-          <p:cNvPr id="28" name="TextBox 27"/>
-          <p:cNvSpPr txBox="1"/>
-          <p:nvPr/>
-        </p:nvSpPr>
-        <p:spPr>
-          <a:xfrm>
-            <a:off x="4297678" y="4946904"/>
-            <a:ext cx="1709927" cy="256032"/>
-          </a:xfrm>
-          <a:prstGeom prst="rect">
-            <a:avLst/>
-          </a:prstGeom>
-          <a:noFill/>
-        </p:spPr>
-        <p:txBody>
-          <a:bodyPr wrap="square">
-            <a:spAutoFit/>
-          </a:bodyPr>
-          <a:lstStyle/>
-          <a:p>
-            <a:pPr algn="l"/>
-            <a:r>
-              <a:rPr sz="1000" b="0">
-                <a:solidFill>
-                  <a:srgbClr val="4A4A4A"/>
-                </a:solidFill>
-                <a:latin typeface="Microsoft YaHei"/>
-                <a:ea typeface="Microsoft YaHei"/>
-              </a:rPr>
-              <a:t>权重切换</a:t>
-            </a:r>
-          </a:p>
-        </p:txBody>
-      </p:sp>
-      <p:sp>
-        <p:nvSpPr>
-          <p:cNvPr id="29" name="TextBox 28"/>
-          <p:cNvSpPr txBox="1"/>
-          <p:nvPr/>
-        </p:nvSpPr>
-        <p:spPr>
-          <a:xfrm>
-            <a:off x="4297678" y="5202936"/>
-            <a:ext cx="1709927" cy="329184"/>
-          </a:xfrm>
-          <a:prstGeom prst="rect">
-            <a:avLst/>
-          </a:prstGeom>
-          <a:noFill/>
-        </p:spPr>
-        <p:txBody>
-          <a:bodyPr wrap="square">
-            <a:spAutoFit/>
-          </a:bodyPr>
-          <a:lstStyle/>
-          <a:p>
-            <a:pPr algn="l"/>
-            <a:r>
-              <a:rPr sz="1300" b="1">
-                <a:solidFill>
-                  <a:srgbClr val="8B1A2B"/>
-                </a:solidFill>
-                <a:latin typeface="Microsoft YaHei"/>
-                <a:ea typeface="Microsoft YaHei"/>
-              </a:rPr>
-              <a:t>0.6–1.5s</a:t>
-            </a:r>
-          </a:p>
-        </p:txBody>
-      </p:sp>
-      <p:sp>
-        <p:nvSpPr>
-          <p:cNvPr id="30" name="Rectangle 29"/>
-          <p:cNvSpPr/>
-          <p:nvPr/>
-        </p:nvSpPr>
-        <p:spPr>
-          <a:xfrm>
-            <a:off x="6172197" y="4690872"/>
-            <a:ext cx="1874519" cy="914400"/>
-          </a:xfrm>
-          <a:prstGeom prst="rect">
-            <a:avLst/>
-          </a:prstGeom>
-          <a:solidFill>
-            <a:srgbClr val="FFFFFF"/>
-          </a:solidFill>
-          <a:ln w="12700">
-            <a:solidFill>
-              <a:srgbClr val="D0D8DE"/>
-            </a:solidFill>
-          </a:ln>
-        </p:spPr>
-        <p:style>
-          <a:lnRef idx="1">
-            <a:schemeClr val="accent1"/>
-          </a:lnRef>
-          <a:fillRef idx="3">
-            <a:schemeClr val="accent1"/>
-          </a:fillRef>
-          <a:effectRef idx="2">
-            <a:schemeClr val="accent1"/>
-          </a:effectRef>
-          <a:fontRef idx="minor">
-            <a:schemeClr val="lt1"/>
-          </a:fontRef>
-        </p:style>
-        <p:txBody>
-          <a:bodyPr rtlCol="0" anchor="ctr"/>
-          <a:lstStyle/>
-          <a:p>
-            <a:pPr algn="ctr"/>
-          </a:p>
-        </p:txBody>
-      </p:sp>
-      <p:sp>
-        <p:nvSpPr>
-          <p:cNvPr id="31" name="TextBox 30"/>
-          <p:cNvSpPr txBox="1"/>
-          <p:nvPr/>
-        </p:nvSpPr>
-        <p:spPr>
-          <a:xfrm>
-            <a:off x="6263637" y="4745736"/>
-            <a:ext cx="1709927" cy="201168"/>
-          </a:xfrm>
-          <a:prstGeom prst="rect">
-            <a:avLst/>
-          </a:prstGeom>
-          <a:noFill/>
-        </p:spPr>
-        <p:txBody>
-          <a:bodyPr wrap="square">
-            <a:spAutoFit/>
-          </a:bodyPr>
-          <a:lstStyle/>
-          <a:p>
-            <a:pPr algn="l"/>
-            <a:r>
-              <a:rPr sz="1000" b="0">
-                <a:solidFill>
-                  <a:srgbClr val="6B6B6B"/>
-                </a:solidFill>
-                <a:latin typeface="Microsoft YaHei"/>
-                <a:ea typeface="Microsoft YaHei"/>
-              </a:rPr>
-              <a:t>ICN64 vs RDMA</a:t>
-            </a:r>
-          </a:p>
-        </p:txBody>
-      </p:sp>
-      <p:sp>
-        <p:nvSpPr>
-          <p:cNvPr id="32" name="TextBox 31"/>
-          <p:cNvSpPr txBox="1"/>
-          <p:nvPr/>
-        </p:nvSpPr>
-        <p:spPr>
-          <a:xfrm>
-            <a:off x="6263637" y="4946904"/>
-            <a:ext cx="1709927" cy="256032"/>
-          </a:xfrm>
-          <a:prstGeom prst="rect">
-            <a:avLst/>
-          </a:prstGeom>
-          <a:noFill/>
-        </p:spPr>
-        <p:txBody>
-          <a:bodyPr wrap="square">
-            <a:spAutoFit/>
-          </a:bodyPr>
-          <a:lstStyle/>
-          <a:p>
-            <a:pPr algn="l"/>
-            <a:r>
-              <a:rPr sz="1000" b="0">
-                <a:solidFill>
-                  <a:srgbClr val="4A4A4A"/>
-                </a:solidFill>
-                <a:latin typeface="Microsoft YaHei"/>
-                <a:ea typeface="Microsoft YaHei"/>
-              </a:rPr>
-              <a:t>吞吐提升</a:t>
-            </a:r>
-          </a:p>
-        </p:txBody>
-      </p:sp>
-      <p:sp>
-        <p:nvSpPr>
-          <p:cNvPr id="33" name="TextBox 32"/>
-          <p:cNvSpPr txBox="1"/>
-          <p:nvPr/>
-        </p:nvSpPr>
-        <p:spPr>
-          <a:xfrm>
-            <a:off x="6263637" y="5202936"/>
-            <a:ext cx="1709927" cy="329184"/>
-          </a:xfrm>
-          <a:prstGeom prst="rect">
-            <a:avLst/>
-          </a:prstGeom>
-          <a:noFill/>
-        </p:spPr>
-        <p:txBody>
-          <a:bodyPr wrap="square">
-            <a:spAutoFit/>
-          </a:bodyPr>
-          <a:lstStyle/>
-          <a:p>
-            <a:pPr algn="l"/>
-            <a:r>
-              <a:rPr sz="1300" b="1">
-                <a:solidFill>
-                  <a:srgbClr val="8B1A2B"/>
-                </a:solidFill>
-                <a:latin typeface="Microsoft YaHei"/>
-                <a:ea typeface="Microsoft YaHei"/>
-              </a:rPr>
-              <a:t>+40%~55%</a:t>
-            </a:r>
-          </a:p>
-        </p:txBody>
-      </p:sp>
-      <p:sp>
-        <p:nvSpPr>
-          <p:cNvPr id="34" name="Rectangle 33"/>
-          <p:cNvSpPr/>
-          <p:nvPr/>
-        </p:nvSpPr>
-        <p:spPr>
-          <a:xfrm>
-            <a:off x="8138156" y="4690872"/>
-            <a:ext cx="1874519" cy="914400"/>
-          </a:xfrm>
-          <a:prstGeom prst="rect">
-            <a:avLst/>
-          </a:prstGeom>
-          <a:solidFill>
-            <a:srgbClr val="FFFFFF"/>
-          </a:solidFill>
-          <a:ln w="12700">
-            <a:solidFill>
-              <a:srgbClr val="D0D8DE"/>
-            </a:solidFill>
-          </a:ln>
-        </p:spPr>
-        <p:style>
-          <a:lnRef idx="1">
-            <a:schemeClr val="accent1"/>
-          </a:lnRef>
-          <a:fillRef idx="3">
-            <a:schemeClr val="accent1"/>
-          </a:fillRef>
-          <a:effectRef idx="2">
-            <a:schemeClr val="accent1"/>
-          </a:effectRef>
-          <a:fontRef idx="minor">
-            <a:schemeClr val="lt1"/>
-          </a:fontRef>
-        </p:style>
-        <p:txBody>
-          <a:bodyPr rtlCol="0" anchor="ctr"/>
-          <a:lstStyle/>
-          <a:p>
-            <a:pPr algn="ctr"/>
-          </a:p>
-        </p:txBody>
-      </p:sp>
-      <p:sp>
-        <p:nvSpPr>
-          <p:cNvPr id="35" name="TextBox 34"/>
-          <p:cNvSpPr txBox="1"/>
-          <p:nvPr/>
-        </p:nvSpPr>
-        <p:spPr>
-          <a:xfrm>
-            <a:off x="8229596" y="4745736"/>
-            <a:ext cx="1709927" cy="201168"/>
-          </a:xfrm>
-          <a:prstGeom prst="rect">
-            <a:avLst/>
-          </a:prstGeom>
-          <a:noFill/>
-        </p:spPr>
-        <p:txBody>
-          <a:bodyPr wrap="square">
-            <a:spAutoFit/>
-          </a:bodyPr>
-          <a:lstStyle/>
-          <a:p>
-            <a:pPr algn="l"/>
-            <a:r>
-              <a:rPr sz="1000" b="0">
-                <a:solidFill>
-                  <a:srgbClr val="6B6B6B"/>
-                </a:solidFill>
-                <a:latin typeface="Microsoft YaHei"/>
-                <a:ea typeface="Microsoft YaHei"/>
-              </a:rPr>
-              <a:t>ICN64 TTFT</a:t>
-            </a:r>
-          </a:p>
-        </p:txBody>
-      </p:sp>
-      <p:sp>
-        <p:nvSpPr>
-          <p:cNvPr id="36" name="TextBox 35"/>
-          <p:cNvSpPr txBox="1"/>
-          <p:nvPr/>
-        </p:nvSpPr>
-        <p:spPr>
-          <a:xfrm>
-            <a:off x="8229596" y="4946904"/>
-            <a:ext cx="1709927" cy="256032"/>
-          </a:xfrm>
-          <a:prstGeom prst="rect">
-            <a:avLst/>
-          </a:prstGeom>
-          <a:noFill/>
-        </p:spPr>
-        <p:txBody>
-          <a:bodyPr wrap="square">
-            <a:spAutoFit/>
-          </a:bodyPr>
-          <a:lstStyle/>
-          <a:p>
-            <a:pPr algn="l"/>
-            <a:r>
-              <a:rPr sz="1000" b="0">
-                <a:solidFill>
-                  <a:srgbClr val="4A4A4A"/>
-                </a:solidFill>
-                <a:latin typeface="Microsoft YaHei"/>
-                <a:ea typeface="Microsoft YaHei"/>
-              </a:rPr>
-              <a:t>长输入更明显</a:t>
-            </a:r>
-          </a:p>
-        </p:txBody>
-      </p:sp>
-      <p:sp>
-        <p:nvSpPr>
-          <p:cNvPr id="37" name="TextBox 36"/>
-          <p:cNvSpPr txBox="1"/>
-          <p:nvPr/>
-        </p:nvSpPr>
-        <p:spPr>
-          <a:xfrm>
-            <a:off x="8229596" y="5202936"/>
-            <a:ext cx="1709927" cy="329184"/>
-          </a:xfrm>
-          <a:prstGeom prst="rect">
-            <a:avLst/>
-          </a:prstGeom>
-          <a:noFill/>
-        </p:spPr>
-        <p:txBody>
-          <a:bodyPr wrap="square">
-            <a:spAutoFit/>
-          </a:bodyPr>
-          <a:lstStyle/>
-          <a:p>
-            <a:pPr algn="l"/>
-            <a:r>
-              <a:rPr sz="1300" b="1">
-                <a:solidFill>
-                  <a:srgbClr val="8B1A2B"/>
-                </a:solidFill>
-                <a:latin typeface="Microsoft YaHei"/>
-                <a:ea typeface="Microsoft YaHei"/>
-              </a:rPr>
-              <a:t>-28%~-35%</a:t>
-            </a:r>
-          </a:p>
-        </p:txBody>
-      </p:sp>
-      <p:sp>
-        <p:nvSpPr>
-          <p:cNvPr id="38" name="Rectangle 37"/>
-          <p:cNvSpPr/>
-          <p:nvPr/>
-        </p:nvSpPr>
-        <p:spPr>
-          <a:xfrm>
-            <a:off x="10104115" y="4690872"/>
-            <a:ext cx="1874519" cy="914400"/>
-          </a:xfrm>
-          <a:prstGeom prst="rect">
-            <a:avLst/>
-          </a:prstGeom>
-          <a:solidFill>
-            <a:srgbClr val="FFFFFF"/>
-          </a:solidFill>
-          <a:ln w="12700">
-            <a:solidFill>
-              <a:srgbClr val="D0D8DE"/>
-            </a:solidFill>
-          </a:ln>
-        </p:spPr>
-        <p:style>
-          <a:lnRef idx="1">
-            <a:schemeClr val="accent1"/>
-          </a:lnRef>
-          <a:fillRef idx="3">
-            <a:schemeClr val="accent1"/>
-          </a:fillRef>
-          <a:effectRef idx="2">
-            <a:schemeClr val="accent1"/>
-          </a:effectRef>
-          <a:fontRef idx="minor">
-            <a:schemeClr val="lt1"/>
-          </a:fontRef>
-        </p:style>
-        <p:txBody>
-          <a:bodyPr rtlCol="0" anchor="ctr"/>
-          <a:lstStyle/>
-          <a:p>
-            <a:pPr algn="ctr"/>
-          </a:p>
-        </p:txBody>
-      </p:sp>
-      <p:sp>
-        <p:nvSpPr>
-          <p:cNvPr id="39" name="TextBox 38"/>
-          <p:cNvSpPr txBox="1"/>
-          <p:nvPr/>
-        </p:nvSpPr>
-        <p:spPr>
-          <a:xfrm>
-            <a:off x="10195555" y="4745736"/>
-            <a:ext cx="1709927" cy="201168"/>
-          </a:xfrm>
-          <a:prstGeom prst="rect">
-            <a:avLst/>
-          </a:prstGeom>
-          <a:noFill/>
-        </p:spPr>
-        <p:txBody>
-          <a:bodyPr wrap="square">
-            <a:spAutoFit/>
-          </a:bodyPr>
-          <a:lstStyle/>
-          <a:p>
-            <a:pPr algn="l"/>
-            <a:r>
-              <a:rPr sz="1000" b="0">
-                <a:solidFill>
-                  <a:srgbClr val="6B6B6B"/>
-                </a:solidFill>
-                <a:latin typeface="Microsoft YaHei"/>
-                <a:ea typeface="Microsoft YaHei"/>
-              </a:rPr>
-              <a:t>开源 RBG</a:t>
-            </a:r>
-          </a:p>
-        </p:txBody>
-      </p:sp>
-      <p:sp>
-        <p:nvSpPr>
-          <p:cNvPr id="40" name="TextBox 39"/>
-          <p:cNvSpPr txBox="1"/>
-          <p:nvPr/>
-        </p:nvSpPr>
-        <p:spPr>
-          <a:xfrm>
-            <a:off x="10195555" y="4946904"/>
-            <a:ext cx="1709927" cy="256032"/>
-          </a:xfrm>
-          <a:prstGeom prst="rect">
-            <a:avLst/>
-          </a:prstGeom>
-          <a:noFill/>
-        </p:spPr>
-        <p:txBody>
-          <a:bodyPr wrap="square">
-            <a:spAutoFit/>
-          </a:bodyPr>
-          <a:lstStyle/>
-          <a:p>
-            <a:pPr algn="l"/>
-            <a:r>
-              <a:rPr sz="1000" b="0">
-                <a:solidFill>
-                  <a:srgbClr val="4A4A4A"/>
-                </a:solidFill>
-                <a:latin typeface="Microsoft YaHei"/>
-                <a:ea typeface="Microsoft YaHei"/>
-              </a:rPr>
-              <a:t>小红书×ACK</a:t>
-            </a:r>
-          </a:p>
-        </p:txBody>
-      </p:sp>
-      <p:sp>
-        <p:nvSpPr>
-          <p:cNvPr id="41" name="TextBox 40"/>
-          <p:cNvSpPr txBox="1"/>
-          <p:nvPr/>
-        </p:nvSpPr>
-        <p:spPr>
-          <a:xfrm>
-            <a:off x="10195555" y="5202936"/>
-            <a:ext cx="1709927" cy="329184"/>
-          </a:xfrm>
-          <a:prstGeom prst="rect">
-            <a:avLst/>
-          </a:prstGeom>
-          <a:noFill/>
-        </p:spPr>
-        <p:txBody>
-          <a:bodyPr wrap="square">
-            <a:spAutoFit/>
-          </a:bodyPr>
-          <a:lstStyle/>
-          <a:p>
-            <a:pPr algn="l"/>
-            <a:r>
-              <a:rPr sz="1300" b="1">
-                <a:solidFill>
-                  <a:srgbClr val="8B1A2B"/>
-                </a:solidFill>
-                <a:latin typeface="Microsoft YaHei"/>
-                <a:ea typeface="Microsoft YaHei"/>
-              </a:rPr>
-              <a:t>sgl-project/rbg</a:t>
-            </a:r>
-          </a:p>
-        </p:txBody>
-      </p:sp>
-      <p:sp>
-        <p:nvSpPr>
-          <p:cNvPr id="42" name="Rectangle 41"/>
-          <p:cNvSpPr/>
-          <p:nvPr/>
-        </p:nvSpPr>
-        <p:spPr>
-          <a:xfrm>
-            <a:off x="0" y="5806440"/>
-            <a:ext cx="12191695" cy="1051560"/>
-          </a:xfrm>
-          <a:prstGeom prst="rect">
-            <a:avLst/>
-          </a:prstGeom>
-          <a:solidFill>
-            <a:srgbClr val="FFFFFF"/>
-          </a:solidFill>
-          <a:ln>
-            <a:noFill/>
-          </a:ln>
-        </p:spPr>
-        <p:style>
-          <a:lnRef idx="1">
-            <a:schemeClr val="accent1"/>
-          </a:lnRef>
-          <a:fillRef idx="3">
-            <a:schemeClr val="accent1"/>
-          </a:fillRef>
-          <a:effectRef idx="2">
-            <a:schemeClr val="accent1"/>
-          </a:effectRef>
-          <a:fontRef idx="minor">
-            <a:schemeClr val="lt1"/>
-          </a:fontRef>
-        </p:style>
-        <p:txBody>
-          <a:bodyPr rtlCol="0" anchor="ctr"/>
-          <a:lstStyle/>
-          <a:p>
-            <a:pPr algn="ctr"/>
-          </a:p>
-        </p:txBody>
-      </p:sp>
-      <p:sp>
-        <p:nvSpPr>
-          <p:cNvPr id="43" name="TextBox 42"/>
-          <p:cNvSpPr txBox="1"/>
-          <p:nvPr/>
-        </p:nvSpPr>
-        <p:spPr>
-          <a:xfrm>
-            <a:off x="320040" y="5879592"/>
-            <a:ext cx="11521440" cy="475488"/>
-          </a:xfrm>
-          <a:prstGeom prst="rect">
-            <a:avLst/>
-          </a:prstGeom>
-          <a:noFill/>
-        </p:spPr>
-        <p:txBody>
-          <a:bodyPr wrap="square">
-            <a:spAutoFit/>
-          </a:bodyPr>
-          <a:lstStyle/>
-          <a:p>
-            <a:pPr algn="l"/>
-            <a:r>
-              <a:rPr sz="1100" b="1">
-                <a:solidFill>
-                  <a:srgbClr val="1A1A1A"/>
-                </a:solidFill>
-                <a:latin typeface="Microsoft YaHei"/>
-                <a:ea typeface="Microsoft YaHei"/>
-              </a:rPr>
-              <a:t>启示要点：静态 PD 先把「成组调度 + 原地升级 + 容量防护」跑稳；动态 PD 再把 Role 拆开，用策略协同替代固定配比；最终把快照复用与 Rollout 托管接到训推一体，并用开源 RBG 回馈社区。</a:t>
-            </a:r>
-          </a:p>
-        </p:txBody>
-      </p:sp>
-      <p:sp>
-        <p:nvSpPr>
-          <p:cNvPr id="44" name="TextBox 43"/>
-          <p:cNvSpPr txBox="1"/>
-          <p:nvPr/>
-        </p:nvSpPr>
-        <p:spPr>
-          <a:xfrm>
-            <a:off x="320040" y="6336792"/>
-            <a:ext cx="11521440" cy="256032"/>
-          </a:xfrm>
-          <a:prstGeom prst="rect">
-            <a:avLst/>
-          </a:prstGeom>
-          <a:noFill/>
-        </p:spPr>
-        <p:txBody>
-          <a:bodyPr wrap="square">
-            <a:spAutoFit/>
-          </a:bodyPr>
-          <a:lstStyle/>
-          <a:p>
-            <a:pPr algn="l"/>
-            <a:r>
-              <a:rPr sz="900" b="0">
-                <a:solidFill>
-                  <a:srgbClr val="6B6B6B"/>
-                </a:solidFill>
-                <a:latin typeface="Microsoft YaHei"/>
-                <a:ea typeface="Microsoft YaHei"/>
-              </a:rPr>
-              <a:t>来源：https://yunqi.aliyun.com/2026/session?agendaId=201 · Talk 08 车漾 / 熊峰 · 第 2/2 页</a:t>
-            </a:r>
-          </a:p>
-        </p:txBody>
-      </p:sp>
-    </p:spTree>
-  </p:cSld>
-  <p:clrMapOvr>
-    <a:masterClrMapping/>
-  </p:clrMapOvr>
-</p:sld>
-</file>
-
-<file path=ppt/slides/slide3.xml><?xml version="1.0" encoding="utf-8"?>
-<p:sld xmlns:a="http://schemas.openxmlformats.org/drawingml/2006/main" xmlns:p="http://schemas.openxmlformats.org/presentationml/2006/main" xmlns:r="http://schemas.openxmlformats.org/officeDocument/2006/relationships">
-  <p:cSld>
-    <p:spTree>
-      <p:nvGrpSpPr>
-        <p:cNvPr id="1" name=""/>
-        <p:cNvGrpSpPr/>
-        <p:nvPr/>
-      </p:nvGrpSpPr>
-      <p:grpSpPr/>
-      <p:sp>
-        <p:nvSpPr>
-          <p:cNvPr id="2" name="Rectangle 1"/>
-          <p:cNvSpPr/>
-          <p:nvPr/>
-        </p:nvSpPr>
-        <p:spPr>
-          <a:xfrm>
-            <a:off x="0" y="0"/>
-            <a:ext cx="12191695" cy="6858000"/>
-          </a:xfrm>
-          <a:prstGeom prst="rect">
-            <a:avLst/>
-          </a:prstGeom>
-          <a:solidFill>
-            <a:srgbClr val="F5F7F9"/>
-          </a:solidFill>
-          <a:ln>
-            <a:noFill/>
-          </a:ln>
-        </p:spPr>
-        <p:style>
-          <a:lnRef idx="1">
-            <a:schemeClr val="accent1"/>
-          </a:lnRef>
-          <a:fillRef idx="3">
-            <a:schemeClr val="accent1"/>
-          </a:fillRef>
-          <a:effectRef idx="2">
-            <a:schemeClr val="accent1"/>
-          </a:effectRef>
-          <a:fontRef idx="minor">
-            <a:schemeClr val="lt1"/>
-          </a:fontRef>
-        </p:style>
-        <p:txBody>
-          <a:bodyPr rtlCol="0" anchor="ctr"/>
-          <a:lstStyle/>
-          <a:p>
-            <a:pPr algn="ctr"/>
-          </a:p>
-        </p:txBody>
-      </p:sp>
-      <p:sp>
-        <p:nvSpPr>
-          <p:cNvPr id="3" name="Rectangle 2"/>
-          <p:cNvSpPr/>
-          <p:nvPr/>
-        </p:nvSpPr>
-        <p:spPr>
-          <a:xfrm>
-            <a:off x="0" y="0"/>
-            <a:ext cx="12191695" cy="868680"/>
-          </a:xfrm>
-          <a:prstGeom prst="rect">
-            <a:avLst/>
-          </a:prstGeom>
-          <a:solidFill>
-            <a:srgbClr val="FFFFFF"/>
-          </a:solidFill>
-          <a:ln>
-            <a:noFill/>
-          </a:ln>
-        </p:spPr>
-        <p:style>
-          <a:lnRef idx="1">
-            <a:schemeClr val="accent1"/>
-          </a:lnRef>
-          <a:fillRef idx="3">
-            <a:schemeClr val="accent1"/>
-          </a:fillRef>
-          <a:effectRef idx="2">
-            <a:schemeClr val="accent1"/>
-          </a:effectRef>
-          <a:fontRef idx="minor">
-            <a:schemeClr val="lt1"/>
-          </a:fontRef>
-        </p:style>
-        <p:txBody>
-          <a:bodyPr rtlCol="0" anchor="ctr"/>
-          <a:lstStyle/>
-          <a:p>
-            <a:pPr algn="ctr"/>
-          </a:p>
-        </p:txBody>
-      </p:sp>
-      <p:sp>
-        <p:nvSpPr>
-          <p:cNvPr id="4" name="TextBox 3"/>
-          <p:cNvSpPr txBox="1"/>
-          <p:nvPr/>
-        </p:nvSpPr>
-        <p:spPr>
-          <a:xfrm>
-            <a:off x="365760" y="146304"/>
-            <a:ext cx="11430000" cy="256032"/>
-          </a:xfrm>
-          <a:prstGeom prst="rect">
-            <a:avLst/>
-          </a:prstGeom>
-          <a:noFill/>
-        </p:spPr>
-        <p:txBody>
-          <a:bodyPr wrap="square">
-            <a:spAutoFit/>
-          </a:bodyPr>
-          <a:lstStyle/>
-          <a:p>
-            <a:pPr algn="l"/>
-            <a:r>
-              <a:rPr sz="1200" b="0">
-                <a:solidFill>
-                  <a:srgbClr val="6B6B6B"/>
-                </a:solidFill>
-                <a:latin typeface="Microsoft YaHei"/>
-                <a:ea typeface="Microsoft YaHei"/>
-              </a:rPr>
-              <a:t>08 · 车漾 / 熊峰 · 阿里云容器服务 ACK × 小红书</a:t>
-            </a:r>
-          </a:p>
-        </p:txBody>
-      </p:sp>
-      <p:sp>
-        <p:nvSpPr>
-          <p:cNvPr id="5" name="TextBox 4"/>
-          <p:cNvSpPr txBox="1"/>
-          <p:nvPr/>
-        </p:nvSpPr>
-        <p:spPr>
-          <a:xfrm>
-            <a:off x="365760" y="384048"/>
-            <a:ext cx="11430000" cy="365760"/>
-          </a:xfrm>
-          <a:prstGeom prst="rect">
-            <a:avLst/>
-          </a:prstGeom>
-          <a:noFill/>
-        </p:spPr>
-        <p:txBody>
-          <a:bodyPr wrap="square">
-            <a:spAutoFit/>
-          </a:bodyPr>
-          <a:lstStyle/>
-          <a:p>
-            <a:pPr algn="l"/>
-            <a:r>
-              <a:rPr sz="2200" b="1">
-                <a:solidFill>
-                  <a:srgbClr val="1A1A1A"/>
-                </a:solidFill>
-                <a:latin typeface="Microsoft YaHei"/>
-                <a:ea typeface="Microsoft YaHei"/>
-              </a:rPr>
-              <a:t>数据佐证｜官方回放截图</a:t>
-            </a:r>
-          </a:p>
-        </p:txBody>
-      </p:sp>
-      <p:sp>
-        <p:nvSpPr>
-          <p:cNvPr id="6" name="Rectangle 5"/>
-          <p:cNvSpPr/>
-          <p:nvPr/>
-        </p:nvSpPr>
-        <p:spPr>
-          <a:xfrm>
-            <a:off x="320040" y="1051560"/>
-            <a:ext cx="3716426" cy="5074920"/>
-          </a:xfrm>
-          <a:prstGeom prst="rect">
-            <a:avLst/>
-          </a:prstGeom>
-          <a:solidFill>
-            <a:srgbClr val="FFFFFF"/>
-          </a:solidFill>
-          <a:ln w="12700">
-            <a:solidFill>
-              <a:srgbClr val="D0D8DE"/>
-            </a:solidFill>
-          </a:ln>
-        </p:spPr>
-        <p:style>
-          <a:lnRef idx="1">
-            <a:schemeClr val="accent1"/>
-          </a:lnRef>
-          <a:fillRef idx="3">
-            <a:schemeClr val="accent1"/>
-          </a:fillRef>
-          <a:effectRef idx="2">
-            <a:schemeClr val="accent1"/>
-          </a:effectRef>
-          <a:fontRef idx="minor">
-            <a:schemeClr val="lt1"/>
-          </a:fontRef>
-        </p:style>
-        <p:txBody>
-          <a:bodyPr rtlCol="0" anchor="ctr"/>
-          <a:lstStyle/>
-          <a:p>
-            <a:pPr algn="ctr"/>
-          </a:p>
-        </p:txBody>
-      </p:sp>
-      <p:sp>
-        <p:nvSpPr>
-          <p:cNvPr id="7" name="TextBox 6"/>
-          <p:cNvSpPr txBox="1"/>
-          <p:nvPr/>
-        </p:nvSpPr>
-        <p:spPr>
-          <a:xfrm>
-            <a:off x="429768" y="1143000"/>
-            <a:ext cx="3496970" cy="365760"/>
-          </a:xfrm>
-          <a:prstGeom prst="rect">
-            <a:avLst/>
-          </a:prstGeom>
-          <a:noFill/>
-        </p:spPr>
-        <p:txBody>
-          <a:bodyPr wrap="square">
-            <a:spAutoFit/>
-          </a:bodyPr>
-          <a:lstStyle/>
-          <a:p>
-            <a:pPr algn="l"/>
-            <a:r>
-              <a:rPr sz="1200" b="1">
-                <a:solidFill>
-                  <a:srgbClr val="8B1A2B"/>
-                </a:solidFill>
-                <a:latin typeface="Microsoft YaHei"/>
-                <a:ea typeface="Microsoft YaHei"/>
-              </a:rPr>
-              <a:t>Cost/Token 公式与三杠杆</a:t>
-            </a:r>
-          </a:p>
-        </p:txBody>
-      </p:sp>
-      <p:pic>
-        <p:nvPicPr>
-          <p:cNvPr id="8" name="Picture 7" descr="t02-52-00-crop.png"/>
-          <p:cNvPicPr>
-            <a:picLocks noChangeAspect="1"/>
-          </p:cNvPicPr>
-          <p:nvPr/>
-        </p:nvPicPr>
-        <p:blipFill>
-          <a:blip r:embed="rId2"/>
-          <a:stretch>
-            <a:fillRect/>
-          </a:stretch>
-        </p:blipFill>
-        <p:spPr>
-          <a:xfrm>
-            <a:off x="429768" y="1946380"/>
-            <a:ext cx="3496970" cy="2965239"/>
-          </a:xfrm>
-          <a:prstGeom prst="rect">
-            <a:avLst/>
-          </a:prstGeom>
-        </p:spPr>
-      </p:pic>
-      <p:sp>
-        <p:nvSpPr>
-          <p:cNvPr id="9" name="TextBox 8"/>
-          <p:cNvSpPr txBox="1"/>
-          <p:nvPr/>
-        </p:nvSpPr>
-        <p:spPr>
-          <a:xfrm>
-            <a:off x="429768" y="5486400"/>
-            <a:ext cx="3496970" cy="502920"/>
-          </a:xfrm>
-          <a:prstGeom prst="rect">
-            <a:avLst/>
-          </a:prstGeom>
-          <a:noFill/>
-        </p:spPr>
-        <p:txBody>
-          <a:bodyPr wrap="square">
-            <a:spAutoFit/>
-          </a:bodyPr>
-          <a:lstStyle/>
-          <a:p>
-            <a:pPr algn="l"/>
-            <a:r>
-              <a:rPr sz="1100" b="0">
-                <a:solidFill>
-                  <a:srgbClr val="4A4A4A"/>
-                </a:solidFill>
-                <a:latin typeface="Microsoft YaHei"/>
-                <a:ea typeface="Microsoft YaHei"/>
-              </a:rPr>
-              <a:t>Cost per Token 北极星</a:t>
-            </a:r>
-          </a:p>
-        </p:txBody>
-      </p:sp>
-      <p:sp>
-        <p:nvSpPr>
-          <p:cNvPr id="10" name="Rectangle 9"/>
-          <p:cNvSpPr/>
-          <p:nvPr/>
-        </p:nvSpPr>
-        <p:spPr>
-          <a:xfrm>
-            <a:off x="4237634" y="1051560"/>
-            <a:ext cx="3716426" cy="5074920"/>
-          </a:xfrm>
-          <a:prstGeom prst="rect">
-            <a:avLst/>
-          </a:prstGeom>
-          <a:solidFill>
-            <a:srgbClr val="FFFFFF"/>
-          </a:solidFill>
-          <a:ln w="12700">
-            <a:solidFill>
-              <a:srgbClr val="D0D8DE"/>
-            </a:solidFill>
-          </a:ln>
-        </p:spPr>
-        <p:style>
-          <a:lnRef idx="1">
-            <a:schemeClr val="accent1"/>
-          </a:lnRef>
-          <a:fillRef idx="3">
-            <a:schemeClr val="accent1"/>
-          </a:fillRef>
-          <a:effectRef idx="2">
-            <a:schemeClr val="accent1"/>
-          </a:effectRef>
-          <a:fontRef idx="minor">
-            <a:schemeClr val="lt1"/>
-          </a:fontRef>
-        </p:style>
-        <p:txBody>
-          <a:bodyPr rtlCol="0" anchor="ctr"/>
-          <a:lstStyle/>
-          <a:p>
-            <a:pPr algn="ctr"/>
-          </a:p>
-        </p:txBody>
-      </p:sp>
-      <p:sp>
-        <p:nvSpPr>
-          <p:cNvPr id="11" name="TextBox 10"/>
-          <p:cNvSpPr txBox="1"/>
-          <p:nvPr/>
-        </p:nvSpPr>
-        <p:spPr>
-          <a:xfrm>
-            <a:off x="4347362" y="1143000"/>
-            <a:ext cx="3496970" cy="365760"/>
-          </a:xfrm>
-          <a:prstGeom prst="rect">
-            <a:avLst/>
-          </a:prstGeom>
-          <a:noFill/>
-        </p:spPr>
-        <p:txBody>
-          <a:bodyPr wrap="square">
-            <a:spAutoFit/>
-          </a:bodyPr>
-          <a:lstStyle/>
-          <a:p>
-            <a:pPr algn="l"/>
-            <a:r>
-              <a:rPr sz="1200" b="1">
-                <a:solidFill>
-                  <a:srgbClr val="8B1A2B"/>
-                </a:solidFill>
-                <a:latin typeface="Microsoft YaHei"/>
-                <a:ea typeface="Microsoft YaHei"/>
-              </a:rPr>
-              <a:t>ACK AI Serving Stack 分层</a:t>
-            </a:r>
-          </a:p>
-        </p:txBody>
-      </p:sp>
-      <p:pic>
-        <p:nvPicPr>
-          <p:cNvPr id="12" name="Picture 11" descr="t02-54-00-crop.png"/>
-          <p:cNvPicPr>
-            <a:picLocks noChangeAspect="1"/>
-          </p:cNvPicPr>
-          <p:nvPr/>
-        </p:nvPicPr>
-        <p:blipFill>
-          <a:blip r:embed="rId3"/>
-          <a:stretch>
-            <a:fillRect/>
-          </a:stretch>
-        </p:blipFill>
-        <p:spPr>
-          <a:xfrm>
-            <a:off x="4347362" y="1946380"/>
-            <a:ext cx="3496970" cy="2965239"/>
-          </a:xfrm>
-          <a:prstGeom prst="rect">
-            <a:avLst/>
-          </a:prstGeom>
-        </p:spPr>
-      </p:pic>
-      <p:sp>
-        <p:nvSpPr>
-          <p:cNvPr id="13" name="TextBox 12"/>
-          <p:cNvSpPr txBox="1"/>
-          <p:nvPr/>
-        </p:nvSpPr>
-        <p:spPr>
-          <a:xfrm>
-            <a:off x="4347362" y="5486400"/>
-            <a:ext cx="3496970" cy="502920"/>
-          </a:xfrm>
-          <a:prstGeom prst="rect">
-            <a:avLst/>
-          </a:prstGeom>
-          <a:noFill/>
-        </p:spPr>
-        <p:txBody>
-          <a:bodyPr wrap="square">
-            <a:spAutoFit/>
-          </a:bodyPr>
-          <a:lstStyle/>
-          <a:p>
-            <a:pPr algn="l"/>
-            <a:r>
-              <a:rPr sz="1100" b="0">
-                <a:solidFill>
-                  <a:srgbClr val="4A4A4A"/>
-                </a:solidFill>
-                <a:latin typeface="Microsoft YaHei"/>
-                <a:ea typeface="Microsoft YaHei"/>
-              </a:rPr>
-              <a:t>网关 / InferenceKit / 存储</a:t>
-            </a:r>
-          </a:p>
-        </p:txBody>
-      </p:sp>
-      <p:sp>
-        <p:nvSpPr>
-          <p:cNvPr id="14" name="Rectangle 13"/>
-          <p:cNvSpPr/>
-          <p:nvPr/>
-        </p:nvSpPr>
-        <p:spPr>
-          <a:xfrm>
-            <a:off x="8155228" y="1051560"/>
-            <a:ext cx="3716426" cy="5074920"/>
-          </a:xfrm>
-          <a:prstGeom prst="rect">
-            <a:avLst/>
-          </a:prstGeom>
-          <a:solidFill>
-            <a:srgbClr val="FFFFFF"/>
-          </a:solidFill>
-          <a:ln w="12700">
-            <a:solidFill>
-              <a:srgbClr val="D0D8DE"/>
-            </a:solidFill>
-          </a:ln>
-        </p:spPr>
-        <p:style>
-          <a:lnRef idx="1">
-            <a:schemeClr val="accent1"/>
-          </a:lnRef>
-          <a:fillRef idx="3">
-            <a:schemeClr val="accent1"/>
-          </a:fillRef>
-          <a:effectRef idx="2">
-            <a:schemeClr val="accent1"/>
-          </a:effectRef>
-          <a:fontRef idx="minor">
-            <a:schemeClr val="lt1"/>
-          </a:fontRef>
-        </p:style>
-        <p:txBody>
-          <a:bodyPr rtlCol="0" anchor="ctr"/>
-          <a:lstStyle/>
-          <a:p>
-            <a:pPr algn="ctr"/>
-          </a:p>
-        </p:txBody>
-      </p:sp>
-      <p:sp>
-        <p:nvSpPr>
-          <p:cNvPr id="15" name="TextBox 14"/>
-          <p:cNvSpPr txBox="1"/>
-          <p:nvPr/>
-        </p:nvSpPr>
-        <p:spPr>
-          <a:xfrm>
-            <a:off x="8264956" y="1143000"/>
-            <a:ext cx="3496970" cy="365760"/>
-          </a:xfrm>
-          <a:prstGeom prst="rect">
-            <a:avLst/>
-          </a:prstGeom>
-          <a:noFill/>
-        </p:spPr>
-        <p:txBody>
-          <a:bodyPr wrap="square">
-            <a:spAutoFit/>
-          </a:bodyPr>
-          <a:lstStyle/>
-          <a:p>
-            <a:pPr algn="l"/>
-            <a:r>
-              <a:rPr sz="1200" b="1">
-                <a:solidFill>
-                  <a:srgbClr val="8B1A2B"/>
-                </a:solidFill>
-                <a:latin typeface="Microsoft YaHei"/>
-                <a:ea typeface="Microsoft YaHei"/>
-              </a:rPr>
-              <a:t>静态 PD → 动态 RBG 演进</a:t>
-            </a:r>
-          </a:p>
-        </p:txBody>
-      </p:sp>
-      <p:pic>
-        <p:nvPicPr>
-          <p:cNvPr id="16" name="Picture 15" descr="t03-07-00-crop.png"/>
-          <p:cNvPicPr>
-            <a:picLocks noChangeAspect="1"/>
-          </p:cNvPicPr>
-          <p:nvPr/>
-        </p:nvPicPr>
-        <p:blipFill>
-          <a:blip r:embed="rId4"/>
-          <a:stretch>
-            <a:fillRect/>
-          </a:stretch>
-        </p:blipFill>
-        <p:spPr>
-          <a:xfrm>
-            <a:off x="8264956" y="1946380"/>
-            <a:ext cx="3496970" cy="2965239"/>
-          </a:xfrm>
-          <a:prstGeom prst="rect">
-            <a:avLst/>
-          </a:prstGeom>
-        </p:spPr>
-      </p:pic>
-      <p:sp>
-        <p:nvSpPr>
-          <p:cNvPr id="17" name="TextBox 16"/>
-          <p:cNvSpPr txBox="1"/>
-          <p:nvPr/>
-        </p:nvSpPr>
-        <p:spPr>
-          <a:xfrm>
-            <a:off x="8264956" y="5486400"/>
-            <a:ext cx="3496970" cy="502920"/>
-          </a:xfrm>
-          <a:prstGeom prst="rect">
-            <a:avLst/>
-          </a:prstGeom>
-          <a:noFill/>
-        </p:spPr>
-        <p:txBody>
-          <a:bodyPr wrap="square">
-            <a:spAutoFit/>
-          </a:bodyPr>
-          <a:lstStyle/>
-          <a:p>
-            <a:pPr algn="l"/>
-            <a:r>
-              <a:rPr sz="1100" b="0">
-                <a:solidFill>
-                  <a:srgbClr val="4A4A4A"/>
-                </a:solidFill>
-                <a:latin typeface="Microsoft YaHei"/>
-                <a:ea typeface="Microsoft YaHei"/>
-              </a:rPr>
-              <a:t>小红书编排两阶段</a:t>
-            </a:r>
-          </a:p>
-        </p:txBody>
-      </p:sp>
-      <p:sp>
-        <p:nvSpPr>
-          <p:cNvPr id="18" name="TextBox 17"/>
-          <p:cNvSpPr txBox="1"/>
-          <p:nvPr/>
-        </p:nvSpPr>
-        <p:spPr>
-          <a:xfrm>
-            <a:off x="365760" y="6355080"/>
-            <a:ext cx="11430000" cy="274320"/>
-          </a:xfrm>
-          <a:prstGeom prst="rect">
-            <a:avLst/>
-          </a:prstGeom>
-          <a:noFill/>
-        </p:spPr>
-        <p:txBody>
-          <a:bodyPr wrap="square">
-            <a:spAutoFit/>
-          </a:bodyPr>
-          <a:lstStyle/>
-          <a:p>
-            <a:pPr algn="l"/>
-            <a:r>
-              <a:rPr sz="1000" b="0">
-                <a:solidFill>
-                  <a:srgbClr val="6B6B6B"/>
-                </a:solidFill>
-                <a:latin typeface="Microsoft YaHei"/>
-                <a:ea typeface="Microsoft YaHei"/>
-              </a:rPr>
-              <a:t>截图裁自云栖大会官方回放幻灯主体，作指标与结论佐证。</a:t>
+              <a:t>来源：云栖大会 agendaId=201｜容器服务 × 小红书：大模型推理与 Agent RL · 车漾 / 熊峰</a:t>
             </a:r>
           </a:p>
         </p:txBody>

</xml_diff>

<commit_message>
Remove Cost/Token三杠杆 card from ACK×小红书 one-pager
Co-authored-by: Annie <Annie-Summer@users.noreply.github.com>
</commit_message>
<xml_diff>
--- a/yunqi-2026-agenda-201/docs/洞察一页-08-容器服务 × 小红书：大模型推理与 Agent RL.pptx
+++ b/yunqi-2026-agenda-201/docs/洞察一页-08-容器服务 × 小红书：大模型推理与 Agent RL.pptx
@@ -3336,7 +3336,7 @@
         <p:spPr>
           <a:xfrm>
             <a:off x="274320" y="1956816"/>
-            <a:ext cx="3749039" cy="2450592"/>
+            <a:ext cx="5705856" cy="2450592"/>
           </a:xfrm>
           <a:prstGeom prst="rect">
             <a:avLst/>
@@ -3380,8 +3380,8 @@
         </p:nvSpPr>
         <p:spPr>
           <a:xfrm>
-            <a:off x="384048" y="2029968"/>
-            <a:ext cx="3529583" cy="274320"/>
+            <a:off x="420624" y="2048256"/>
+            <a:ext cx="5413248" cy="292608"/>
           </a:xfrm>
           <a:prstGeom prst="rect">
             <a:avLst/>
@@ -3396,14 +3396,14 @@
           <a:p>
             <a:pPr algn="l"/>
             <a:r>
-              <a:rPr sz="1300" b="1">
+              <a:rPr sz="1400" b="1">
                 <a:solidFill>
                   <a:srgbClr val="8B1A2B"/>
                 </a:solidFill>
                 <a:latin typeface="Microsoft YaHei"/>
                 <a:ea typeface="Microsoft YaHei"/>
               </a:rPr>
-              <a:t>01  Cost/Token 三杠杆</a:t>
+              <a:t>01  Serving Stack 三件套</a:t>
             </a:r>
           </a:p>
         </p:txBody>
@@ -3416,8 +3416,8 @@
         </p:nvSpPr>
         <p:spPr>
           <a:xfrm>
-            <a:off x="384048" y="2322576"/>
-            <a:ext cx="3529583" cy="1993392"/>
+            <a:off x="420624" y="2377440"/>
+            <a:ext cx="5413248" cy="1938528"/>
           </a:xfrm>
           <a:prstGeom prst="rect">
             <a:avLst/>
@@ -3432,86 +3432,86 @@
           <a:p>
             <a:pPr algn="l">
               <a:spcAft>
-                <a:spcPts val="100"/>
+                <a:spcPts val="200"/>
               </a:spcAft>
             </a:pPr>
             <a:r>
-              <a:rPr sz="1000" b="1">
+              <a:rPr sz="1100" b="1">
                 <a:solidFill>
                   <a:srgbClr val="1A1A1A"/>
                 </a:solidFill>
                 <a:latin typeface="Microsoft YaHei"/>
                 <a:ea typeface="Microsoft YaHei"/>
               </a:rPr>
-              <a:t>技术启示：先立经营目标函数，再选型与调参</a:t>
+              <a:t>技术启示：路由+权重分发+拓扑注入做成平台默认能力</a:t>
             </a:r>
           </a:p>
           <a:p>
             <a:pPr algn="l">
               <a:spcAft>
-                <a:spcPts val="100"/>
+                <a:spcPts val="200"/>
               </a:spcAft>
             </a:pPr>
             <a:r>
-              <a:rPr sz="1000" b="0">
+              <a:rPr sz="1100" b="0">
                 <a:solidFill>
                   <a:srgbClr val="4A4A4A"/>
                 </a:solidFill>
                 <a:latin typeface="Microsoft YaHei"/>
                 <a:ea typeface="Microsoft YaHei"/>
               </a:rPr>
-              <a:t>• 分子：GPU 选型、潮汐混部、Spot 降单位成本</a:t>
+              <a:t>• 网关：公平调度+负载/缓存亲和；TTFT -75%、ITL -40%、吞吐 3×</a:t>
             </a:r>
           </a:p>
           <a:p>
             <a:pPr algn="l">
               <a:spcAft>
-                <a:spcPts val="100"/>
+                <a:spcPts val="200"/>
               </a:spcAft>
             </a:pPr>
             <a:r>
-              <a:rPr sz="1000" b="0">
+              <a:rPr sz="1100" b="0">
                 <a:solidFill>
                   <a:srgbClr val="4A4A4A"/>
                 </a:solidFill>
                 <a:latin typeface="Microsoft YaHei"/>
                 <a:ea typeface="Microsoft YaHei"/>
               </a:rPr>
-              <a:t>• 分母吞吐：PD 分离、EP/DP、KVCache Offload/Reuse</a:t>
+              <a:t>• ModelScale：RDMA+GDR+P2P 分层权重；加载 120s→20s</a:t>
             </a:r>
           </a:p>
           <a:p>
             <a:pPr algn="l">
               <a:spcAft>
-                <a:spcPts val="100"/>
+                <a:spcPts val="200"/>
               </a:spcAft>
             </a:pPr>
             <a:r>
-              <a:rPr sz="1000" b="0">
+              <a:rPr sz="1100" b="0">
                 <a:solidFill>
                   <a:srgbClr val="4A4A4A"/>
                 </a:solidFill>
                 <a:latin typeface="Microsoft YaHei"/>
                 <a:ea typeface="Microsoft YaHei"/>
               </a:rPr>
-              <a:t>• 分母利用率：弹性伸缩、KV 感知路由、数据缓存加速</a:t>
+              <a:t>• InferenceKit：Webhook→Wrapper→插件；无静默、Summary 自证</a:t>
             </a:r>
           </a:p>
           <a:p>
             <a:pPr algn="l">
               <a:spcAft>
-                <a:spcPts val="100"/>
+                <a:spcPts val="200"/>
               </a:spcAft>
             </a:pPr>
             <a:r>
-              <a:rPr sz="1000" b="0">
+              <a:rPr sz="1100" b="0">
                 <a:solidFill>
                   <a:srgbClr val="4A4A4A"/>
                 </a:solidFill>
                 <a:latin typeface="Microsoft YaHei"/>
                 <a:ea typeface="Microsoft YaHei"/>
               </a:rPr>
-              <a:t>• NVIDIA：Cost per token 定义推理 TCO，非单看算力/FLOP</a:t>
+              <a:t>• NUMA 错配吞吐约 -13%~-14%；ICN64 vs RDMA 吞吐 +40%~55%</a:t>
             </a:r>
           </a:p>
         </p:txBody>
@@ -3524,8 +3524,8 @@
         </p:nvSpPr>
         <p:spPr>
           <a:xfrm>
-            <a:off x="4187951" y="1956816"/>
-            <a:ext cx="3749039" cy="2450592"/>
+            <a:off x="6181344" y="1956816"/>
+            <a:ext cx="5705856" cy="2450592"/>
           </a:xfrm>
           <a:prstGeom prst="rect">
             <a:avLst/>
@@ -3569,8 +3569,8 @@
         </p:nvSpPr>
         <p:spPr>
           <a:xfrm>
-            <a:off x="4297679" y="2029968"/>
-            <a:ext cx="3529583" cy="274320"/>
+            <a:off x="6327648" y="2048256"/>
+            <a:ext cx="5413248" cy="292608"/>
           </a:xfrm>
           <a:prstGeom prst="rect">
             <a:avLst/>
@@ -3585,14 +3585,14 @@
           <a:p>
             <a:pPr algn="l"/>
             <a:r>
-              <a:rPr sz="1300" b="1">
+              <a:rPr sz="1400" b="1">
                 <a:solidFill>
                   <a:srgbClr val="8B1A2B"/>
                 </a:solidFill>
                 <a:latin typeface="Microsoft YaHei"/>
                 <a:ea typeface="Microsoft YaHei"/>
               </a:rPr>
-              <a:t>02  Serving Stack 三件套</a:t>
+              <a:t>02  静态 PD → 动态 RBG</a:t>
             </a:r>
           </a:p>
         </p:txBody>
@@ -3605,8 +3605,8 @@
         </p:nvSpPr>
         <p:spPr>
           <a:xfrm>
-            <a:off x="4297679" y="2322576"/>
-            <a:ext cx="3529583" cy="1993392"/>
+            <a:off x="6327648" y="2377440"/>
+            <a:ext cx="5413248" cy="1938528"/>
           </a:xfrm>
           <a:prstGeom prst="rect">
             <a:avLst/>
@@ -3621,100 +3621,136 @@
           <a:p>
             <a:pPr algn="l">
               <a:spcAft>
-                <a:spcPts val="100"/>
+                <a:spcPts val="200"/>
               </a:spcAft>
             </a:pPr>
             <a:r>
-              <a:rPr sz="1000" b="1">
+              <a:rPr sz="1100" b="1">
                 <a:solidFill>
                   <a:srgbClr val="1A1A1A"/>
                 </a:solidFill>
                 <a:latin typeface="Microsoft YaHei"/>
                 <a:ea typeface="Microsoft YaHei"/>
               </a:rPr>
-              <a:t>技术启示：路由+权重分发+拓扑注入做成平台默认能力</a:t>
+              <a:t>技术启示：按性能压力分阶段演进编排，先稳态再弹性</a:t>
             </a:r>
           </a:p>
           <a:p>
             <a:pPr algn="l">
               <a:spcAft>
-                <a:spcPts val="100"/>
+                <a:spcPts val="200"/>
               </a:spcAft>
             </a:pPr>
             <a:r>
-              <a:rPr sz="1000" b="0">
+              <a:rPr sz="1100" b="0">
                 <a:solidFill>
                   <a:srgbClr val="4A4A4A"/>
                 </a:solidFill>
                 <a:latin typeface="Microsoft YaHei"/>
                 <a:ea typeface="Microsoft YaHei"/>
               </a:rPr>
-              <a:t>• 网关：公平调度+负载/缓存亲和；TTFT -75%、ITL -40%、吞吐 3×</a:t>
+              <a:t>• 静态 GroupSet：组内 P:D 固定，Gang 成组；原地升级+四级缓存</a:t>
             </a:r>
           </a:p>
           <a:p>
             <a:pPr algn="l">
               <a:spcAft>
-                <a:spcPts val="100"/>
+                <a:spcPts val="200"/>
               </a:spcAft>
             </a:pPr>
             <a:r>
-              <a:rPr sz="1000" b="0">
+              <a:rPr sz="1100" b="0">
                 <a:solidFill>
                   <a:srgbClr val="4A4A4A"/>
                 </a:solidFill>
                 <a:latin typeface="Microsoft YaHei"/>
                 <a:ea typeface="Microsoft YaHei"/>
               </a:rPr>
-              <a:t>• ModelScale：RDMA+GDR+P2P 分层权重；加载 120s→20s</a:t>
+              <a:t>• 动态 RBG：Role 一等公民，独立扩缩/发布；KVCache-Aware 选路</a:t>
             </a:r>
           </a:p>
           <a:p>
             <a:pPr algn="l">
               <a:spcAft>
-                <a:spcPts val="100"/>
+                <a:spcPts val="200"/>
               </a:spcAft>
             </a:pPr>
             <a:r>
-              <a:rPr sz="1000" b="0">
+              <a:rPr sz="1100" b="0">
                 <a:solidFill>
                   <a:srgbClr val="4A4A4A"/>
                 </a:solidFill>
                 <a:latin typeface="Microsoft YaHei"/>
                 <a:ea typeface="Microsoft YaHei"/>
               </a:rPr>
-              <a:t>• InferenceKit：Webhook→Wrapper→插件；无静默、Summary 自证</a:t>
+              <a:t>• 生产：同 SLO 吞吐 2~3×，GPU 节省约 50%；开源 sgl-project/rbg</a:t>
             </a:r>
           </a:p>
           <a:p>
             <a:pPr algn="l">
               <a:spcAft>
-                <a:spcPts val="100"/>
+                <a:spcPts val="200"/>
               </a:spcAft>
             </a:pPr>
             <a:r>
-              <a:rPr sz="1000" b="0">
+              <a:rPr sz="1100" b="0">
                 <a:solidFill>
                   <a:srgbClr val="4A4A4A"/>
                 </a:solidFill>
                 <a:latin typeface="Microsoft YaHei"/>
                 <a:ea typeface="Microsoft YaHei"/>
               </a:rPr>
-              <a:t>• NUMA 错配吞吐约 -13%~-14%；ICN64 vs RDMA 吞吐 +40%~55%</a:t>
-            </a:r>
-          </a:p>
-        </p:txBody>
-      </p:sp>
-      <p:sp>
-        <p:nvSpPr>
-          <p:cNvPr id="14" name="Rectangle 13"/>
+              <a:t>• 向上延伸：快照复用 + Rollout 托管，承接训推一体执行面</a:t>
+            </a:r>
+          </a:p>
+        </p:txBody>
+      </p:sp>
+      <p:sp>
+        <p:nvSpPr>
+          <p:cNvPr id="14" name="TextBox 13"/>
+          <p:cNvSpPr txBox="1"/>
+          <p:nvPr/>
+        </p:nvSpPr>
+        <p:spPr>
+          <a:xfrm>
+            <a:off x="274320" y="4535424"/>
+            <a:ext cx="9144000" cy="219456"/>
+          </a:xfrm>
+          <a:prstGeom prst="rect">
+            <a:avLst/>
+          </a:prstGeom>
+          <a:noFill/>
+        </p:spPr>
+        <p:txBody>
+          <a:bodyPr wrap="square">
+            <a:spAutoFit/>
+          </a:bodyPr>
+          <a:lstStyle/>
+          <a:p>
+            <a:pPr algn="l"/>
+            <a:r>
+              <a:rPr sz="1200" b="1">
+                <a:solidFill>
+                  <a:srgbClr val="1A1A1A"/>
+                </a:solidFill>
+                <a:latin typeface="Microsoft YaHei"/>
+                <a:ea typeface="Microsoft YaHei"/>
+              </a:rPr>
+              <a:t>关键指标对比与提升</a:t>
+            </a:r>
+          </a:p>
+        </p:txBody>
+      </p:sp>
+      <p:sp>
+        <p:nvSpPr>
+          <p:cNvPr id="15" name="Rectangle 14"/>
           <p:cNvSpPr/>
           <p:nvPr/>
         </p:nvSpPr>
         <p:spPr>
           <a:xfrm>
-            <a:off x="8101582" y="1956816"/>
-            <a:ext cx="3749039" cy="2450592"/>
+            <a:off x="274320" y="4773168"/>
+            <a:ext cx="1874519" cy="841248"/>
           </a:xfrm>
           <a:prstGeom prst="rect">
             <a:avLst/>
@@ -3752,14 +3788,14 @@
       </p:sp>
       <p:sp>
         <p:nvSpPr>
-          <p:cNvPr id="15" name="TextBox 14"/>
+          <p:cNvPr id="16" name="TextBox 15"/>
           <p:cNvSpPr txBox="1"/>
           <p:nvPr/>
         </p:nvSpPr>
         <p:spPr>
           <a:xfrm>
-            <a:off x="8211310" y="2029968"/>
-            <a:ext cx="3529583" cy="274320"/>
+            <a:off x="347472" y="4809744"/>
+            <a:ext cx="1746503" cy="182880"/>
           </a:xfrm>
           <a:prstGeom prst="rect">
             <a:avLst/>
@@ -3774,28 +3810,28 @@
           <a:p>
             <a:pPr algn="l"/>
             <a:r>
-              <a:rPr sz="1300" b="1">
-                <a:solidFill>
-                  <a:srgbClr val="8B1A2B"/>
+              <a:rPr sz="900" b="0">
+                <a:solidFill>
+                  <a:srgbClr val="6B6B6B"/>
                 </a:solidFill>
                 <a:latin typeface="Microsoft YaHei"/>
                 <a:ea typeface="Microsoft YaHei"/>
               </a:rPr>
-              <a:t>03  静态 PD → 动态 RBG</a:t>
-            </a:r>
-          </a:p>
-        </p:txBody>
-      </p:sp>
-      <p:sp>
-        <p:nvSpPr>
-          <p:cNvPr id="16" name="TextBox 15"/>
+              <a:t>网关 TTFT</a:t>
+            </a:r>
+          </a:p>
+        </p:txBody>
+      </p:sp>
+      <p:sp>
+        <p:nvSpPr>
+          <p:cNvPr id="17" name="TextBox 16"/>
           <p:cNvSpPr txBox="1"/>
           <p:nvPr/>
         </p:nvSpPr>
         <p:spPr>
           <a:xfrm>
-            <a:off x="8211310" y="2322576"/>
-            <a:ext cx="3529583" cy="1993392"/>
+            <a:off x="347472" y="4992624"/>
+            <a:ext cx="1746503" cy="219456"/>
           </a:xfrm>
           <a:prstGeom prst="rect">
             <a:avLst/>
@@ -3808,102 +3844,30 @@
           </a:bodyPr>
           <a:lstStyle/>
           <a:p>
-            <a:pPr algn="l">
-              <a:spcAft>
-                <a:spcPts val="100"/>
-              </a:spcAft>
-            </a:pPr>
-            <a:r>
-              <a:rPr sz="1000" b="1">
-                <a:solidFill>
-                  <a:srgbClr val="1A1A1A"/>
+            <a:pPr algn="l"/>
+            <a:r>
+              <a:rPr sz="900" b="0">
+                <a:solidFill>
+                  <a:srgbClr val="4A4A4A"/>
                 </a:solidFill>
                 <a:latin typeface="Microsoft YaHei"/>
                 <a:ea typeface="Microsoft YaHei"/>
               </a:rPr>
-              <a:t>技术启示：按性能压力分阶段演进编排，先稳态再弹性</a:t>
-            </a:r>
-          </a:p>
-          <a:p>
-            <a:pPr algn="l">
-              <a:spcAft>
-                <a:spcPts val="100"/>
-              </a:spcAft>
-            </a:pPr>
-            <a:r>
-              <a:rPr sz="1000" b="0">
-                <a:solidFill>
-                  <a:srgbClr val="4A4A4A"/>
-                </a:solidFill>
-                <a:latin typeface="Microsoft YaHei"/>
-                <a:ea typeface="Microsoft YaHei"/>
-              </a:rPr>
-              <a:t>• 静态 GroupSet：组内 P:D 固定，Gang 成组；原地升级+四级缓存</a:t>
-            </a:r>
-          </a:p>
-          <a:p>
-            <a:pPr algn="l">
-              <a:spcAft>
-                <a:spcPts val="100"/>
-              </a:spcAft>
-            </a:pPr>
-            <a:r>
-              <a:rPr sz="1000" b="0">
-                <a:solidFill>
-                  <a:srgbClr val="4A4A4A"/>
-                </a:solidFill>
-                <a:latin typeface="Microsoft YaHei"/>
-                <a:ea typeface="Microsoft YaHei"/>
-              </a:rPr>
-              <a:t>• 动态 RBG：Role 一等公民，独立扩缩/发布；KVCache-Aware 选路</a:t>
-            </a:r>
-          </a:p>
-          <a:p>
-            <a:pPr algn="l">
-              <a:spcAft>
-                <a:spcPts val="100"/>
-              </a:spcAft>
-            </a:pPr>
-            <a:r>
-              <a:rPr sz="1000" b="0">
-                <a:solidFill>
-                  <a:srgbClr val="4A4A4A"/>
-                </a:solidFill>
-                <a:latin typeface="Microsoft YaHei"/>
-                <a:ea typeface="Microsoft YaHei"/>
-              </a:rPr>
-              <a:t>• 生产：同 SLO 吞吐 2~3×，GPU 节省约 50%；开源 sgl-project/rbg</a:t>
-            </a:r>
-          </a:p>
-          <a:p>
-            <a:pPr algn="l">
-              <a:spcAft>
-                <a:spcPts val="100"/>
-              </a:spcAft>
-            </a:pPr>
-            <a:r>
-              <a:rPr sz="1000" b="0">
-                <a:solidFill>
-                  <a:srgbClr val="4A4A4A"/>
-                </a:solidFill>
-                <a:latin typeface="Microsoft YaHei"/>
-                <a:ea typeface="Microsoft YaHei"/>
-              </a:rPr>
-              <a:t>• 向上延伸：快照复用 + Rollout 托管，承接训推一体执行面</a:t>
-            </a:r>
-          </a:p>
-        </p:txBody>
-      </p:sp>
-      <p:sp>
-        <p:nvSpPr>
-          <p:cNvPr id="17" name="TextBox 16"/>
+              <a:t>典型场景</a:t>
+            </a:r>
+          </a:p>
+        </p:txBody>
+      </p:sp>
+      <p:sp>
+        <p:nvSpPr>
+          <p:cNvPr id="18" name="TextBox 17"/>
           <p:cNvSpPr txBox="1"/>
           <p:nvPr/>
         </p:nvSpPr>
         <p:spPr>
           <a:xfrm>
-            <a:off x="274320" y="4535424"/>
-            <a:ext cx="9144000" cy="219456"/>
+            <a:off x="347472" y="5212080"/>
+            <a:ext cx="1746503" cy="329184"/>
           </a:xfrm>
           <a:prstGeom prst="rect">
             <a:avLst/>
@@ -3918,27 +3882,27 @@
           <a:p>
             <a:pPr algn="l"/>
             <a:r>
-              <a:rPr sz="1200" b="1">
-                <a:solidFill>
-                  <a:srgbClr val="1A1A1A"/>
+              <a:rPr sz="1300" b="1">
+                <a:solidFill>
+                  <a:srgbClr val="8B1A2B"/>
                 </a:solidFill>
                 <a:latin typeface="Microsoft YaHei"/>
                 <a:ea typeface="Microsoft YaHei"/>
               </a:rPr>
-              <a:t>关键指标对比与提升</a:t>
-            </a:r>
-          </a:p>
-        </p:txBody>
-      </p:sp>
-      <p:sp>
-        <p:nvSpPr>
-          <p:cNvPr id="18" name="Rectangle 17"/>
+              <a:t>-75%</a:t>
+            </a:r>
+          </a:p>
+        </p:txBody>
+      </p:sp>
+      <p:sp>
+        <p:nvSpPr>
+          <p:cNvPr id="19" name="Rectangle 18"/>
           <p:cNvSpPr/>
           <p:nvPr/>
         </p:nvSpPr>
         <p:spPr>
           <a:xfrm>
-            <a:off x="274320" y="4773168"/>
+            <a:off x="2240279" y="4773168"/>
             <a:ext cx="1874519" cy="841248"/>
           </a:xfrm>
           <a:prstGeom prst="rect">
@@ -3977,13 +3941,13 @@
       </p:sp>
       <p:sp>
         <p:nvSpPr>
-          <p:cNvPr id="19" name="TextBox 18"/>
+          <p:cNvPr id="20" name="TextBox 19"/>
           <p:cNvSpPr txBox="1"/>
           <p:nvPr/>
         </p:nvSpPr>
         <p:spPr>
           <a:xfrm>
-            <a:off x="347472" y="4809744"/>
+            <a:off x="2313431" y="4809744"/>
             <a:ext cx="1746503" cy="182880"/>
           </a:xfrm>
           <a:prstGeom prst="rect">
@@ -4006,20 +3970,20 @@
                 <a:latin typeface="Microsoft YaHei"/>
                 <a:ea typeface="Microsoft YaHei"/>
               </a:rPr>
-              <a:t>网关 TTFT</a:t>
-            </a:r>
-          </a:p>
-        </p:txBody>
-      </p:sp>
-      <p:sp>
-        <p:nvSpPr>
-          <p:cNvPr id="20" name="TextBox 19"/>
+              <a:t>网关吞吐</a:t>
+            </a:r>
+          </a:p>
+        </p:txBody>
+      </p:sp>
+      <p:sp>
+        <p:nvSpPr>
+          <p:cNvPr id="21" name="TextBox 20"/>
           <p:cNvSpPr txBox="1"/>
           <p:nvPr/>
         </p:nvSpPr>
         <p:spPr>
           <a:xfrm>
-            <a:off x="347472" y="4992624"/>
+            <a:off x="2313431" y="4992624"/>
             <a:ext cx="1746503" cy="219456"/>
           </a:xfrm>
           <a:prstGeom prst="rect">
@@ -4049,13 +4013,13 @@
       </p:sp>
       <p:sp>
         <p:nvSpPr>
-          <p:cNvPr id="21" name="TextBox 20"/>
+          <p:cNvPr id="22" name="TextBox 21"/>
           <p:cNvSpPr txBox="1"/>
           <p:nvPr/>
         </p:nvSpPr>
         <p:spPr>
           <a:xfrm>
-            <a:off x="347472" y="5212080"/>
+            <a:off x="2313431" y="5212080"/>
             <a:ext cx="1746503" cy="329184"/>
           </a:xfrm>
           <a:prstGeom prst="rect">
@@ -4078,20 +4042,20 @@
                 <a:latin typeface="Microsoft YaHei"/>
                 <a:ea typeface="Microsoft YaHei"/>
               </a:rPr>
-              <a:t>-75%</a:t>
-            </a:r>
-          </a:p>
-        </p:txBody>
-      </p:sp>
-      <p:sp>
-        <p:nvSpPr>
-          <p:cNvPr id="22" name="Rectangle 21"/>
+              <a:t>3×</a:t>
+            </a:r>
+          </a:p>
+        </p:txBody>
+      </p:sp>
+      <p:sp>
+        <p:nvSpPr>
+          <p:cNvPr id="23" name="Rectangle 22"/>
           <p:cNvSpPr/>
           <p:nvPr/>
         </p:nvSpPr>
         <p:spPr>
           <a:xfrm>
-            <a:off x="2240279" y="4773168"/>
+            <a:off x="4206238" y="4773168"/>
             <a:ext cx="1874519" cy="841248"/>
           </a:xfrm>
           <a:prstGeom prst="rect">
@@ -4130,13 +4094,13 @@
       </p:sp>
       <p:sp>
         <p:nvSpPr>
-          <p:cNvPr id="23" name="TextBox 22"/>
+          <p:cNvPr id="24" name="TextBox 23"/>
           <p:cNvSpPr txBox="1"/>
           <p:nvPr/>
         </p:nvSpPr>
         <p:spPr>
           <a:xfrm>
-            <a:off x="2313431" y="4809744"/>
+            <a:off x="4279390" y="4809744"/>
             <a:ext cx="1746503" cy="182880"/>
           </a:xfrm>
           <a:prstGeom prst="rect">
@@ -4159,20 +4123,20 @@
                 <a:latin typeface="Microsoft YaHei"/>
                 <a:ea typeface="Microsoft YaHei"/>
               </a:rPr>
-              <a:t>网关吞吐</a:t>
-            </a:r>
-          </a:p>
-        </p:txBody>
-      </p:sp>
-      <p:sp>
-        <p:nvSpPr>
-          <p:cNvPr id="24" name="TextBox 23"/>
+              <a:t>权重加载</a:t>
+            </a:r>
+          </a:p>
+        </p:txBody>
+      </p:sp>
+      <p:sp>
+        <p:nvSpPr>
+          <p:cNvPr id="25" name="TextBox 24"/>
           <p:cNvSpPr txBox="1"/>
           <p:nvPr/>
         </p:nvSpPr>
         <p:spPr>
           <a:xfrm>
-            <a:off x="2313431" y="4992624"/>
+            <a:off x="4279390" y="4992624"/>
             <a:ext cx="1746503" cy="219456"/>
           </a:xfrm>
           <a:prstGeom prst="rect">
@@ -4195,20 +4159,20 @@
                 <a:latin typeface="Microsoft YaHei"/>
                 <a:ea typeface="Microsoft YaHei"/>
               </a:rPr>
-              <a:t>典型场景</a:t>
-            </a:r>
-          </a:p>
-        </p:txBody>
-      </p:sp>
-      <p:sp>
-        <p:nvSpPr>
-          <p:cNvPr id="25" name="TextBox 24"/>
+              <a:t>120s → 20s</a:t>
+            </a:r>
+          </a:p>
+        </p:txBody>
+      </p:sp>
+      <p:sp>
+        <p:nvSpPr>
+          <p:cNvPr id="26" name="TextBox 25"/>
           <p:cNvSpPr txBox="1"/>
           <p:nvPr/>
         </p:nvSpPr>
         <p:spPr>
           <a:xfrm>
-            <a:off x="2313431" y="5212080"/>
+            <a:off x="4279390" y="5212080"/>
             <a:ext cx="1746503" cy="329184"/>
           </a:xfrm>
           <a:prstGeom prst="rect">
@@ -4231,20 +4195,20 @@
                 <a:latin typeface="Microsoft YaHei"/>
                 <a:ea typeface="Microsoft YaHei"/>
               </a:rPr>
-              <a:t>3×</a:t>
-            </a:r>
-          </a:p>
-        </p:txBody>
-      </p:sp>
-      <p:sp>
-        <p:nvSpPr>
-          <p:cNvPr id="26" name="Rectangle 25"/>
+              <a:t>约 6×</a:t>
+            </a:r>
+          </a:p>
+        </p:txBody>
+      </p:sp>
+      <p:sp>
+        <p:nvSpPr>
+          <p:cNvPr id="27" name="Rectangle 26"/>
           <p:cNvSpPr/>
           <p:nvPr/>
         </p:nvSpPr>
         <p:spPr>
           <a:xfrm>
-            <a:off x="4206238" y="4773168"/>
+            <a:off x="6172197" y="4773168"/>
             <a:ext cx="1874519" cy="841248"/>
           </a:xfrm>
           <a:prstGeom prst="rect">
@@ -4283,13 +4247,13 @@
       </p:sp>
       <p:sp>
         <p:nvSpPr>
-          <p:cNvPr id="27" name="TextBox 26"/>
+          <p:cNvPr id="28" name="TextBox 27"/>
           <p:cNvSpPr txBox="1"/>
           <p:nvPr/>
         </p:nvSpPr>
         <p:spPr>
           <a:xfrm>
-            <a:off x="4279390" y="4809744"/>
+            <a:off x="6245349" y="4809744"/>
             <a:ext cx="1746503" cy="182880"/>
           </a:xfrm>
           <a:prstGeom prst="rect">
@@ -4312,20 +4276,20 @@
                 <a:latin typeface="Microsoft YaHei"/>
                 <a:ea typeface="Microsoft YaHei"/>
               </a:rPr>
-              <a:t>权重加载</a:t>
-            </a:r>
-          </a:p>
-        </p:txBody>
-      </p:sp>
-      <p:sp>
-        <p:nvSpPr>
-          <p:cNvPr id="28" name="TextBox 27"/>
+              <a:t>P2P vs OSS</a:t>
+            </a:r>
+          </a:p>
+        </p:txBody>
+      </p:sp>
+      <p:sp>
+        <p:nvSpPr>
+          <p:cNvPr id="29" name="TextBox 28"/>
           <p:cNvSpPr txBox="1"/>
           <p:nvPr/>
         </p:nvSpPr>
         <p:spPr>
           <a:xfrm>
-            <a:off x="4279390" y="4992624"/>
+            <a:off x="6245349" y="4992624"/>
             <a:ext cx="1746503" cy="219456"/>
           </a:xfrm>
           <a:prstGeom prst="rect">
@@ -4348,20 +4312,20 @@
                 <a:latin typeface="Microsoft YaHei"/>
                 <a:ea typeface="Microsoft YaHei"/>
               </a:rPr>
-              <a:t>120s → 20s</a:t>
-            </a:r>
-          </a:p>
-        </p:txBody>
-      </p:sp>
-      <p:sp>
-        <p:nvSpPr>
-          <p:cNvPr id="29" name="TextBox 28"/>
+              <a:t>Qwen3-32B</a:t>
+            </a:r>
+          </a:p>
+        </p:txBody>
+      </p:sp>
+      <p:sp>
+        <p:nvSpPr>
+          <p:cNvPr id="30" name="TextBox 29"/>
           <p:cNvSpPr txBox="1"/>
           <p:nvPr/>
         </p:nvSpPr>
         <p:spPr>
           <a:xfrm>
-            <a:off x="4279390" y="5212080"/>
+            <a:off x="6245349" y="5212080"/>
             <a:ext cx="1746503" cy="329184"/>
           </a:xfrm>
           <a:prstGeom prst="rect">
@@ -4384,20 +4348,20 @@
                 <a:latin typeface="Microsoft YaHei"/>
                 <a:ea typeface="Microsoft YaHei"/>
               </a:rPr>
-              <a:t>约 6×</a:t>
-            </a:r>
-          </a:p>
-        </p:txBody>
-      </p:sp>
-      <p:sp>
-        <p:nvSpPr>
-          <p:cNvPr id="30" name="Rectangle 29"/>
+              <a:t>13.5×</a:t>
+            </a:r>
+          </a:p>
+        </p:txBody>
+      </p:sp>
+      <p:sp>
+        <p:nvSpPr>
+          <p:cNvPr id="31" name="Rectangle 30"/>
           <p:cNvSpPr/>
           <p:nvPr/>
         </p:nvSpPr>
         <p:spPr>
           <a:xfrm>
-            <a:off x="6172197" y="4773168"/>
+            <a:off x="8138156" y="4773168"/>
             <a:ext cx="1874519" cy="841248"/>
           </a:xfrm>
           <a:prstGeom prst="rect">
@@ -4436,13 +4400,13 @@
       </p:sp>
       <p:sp>
         <p:nvSpPr>
-          <p:cNvPr id="31" name="TextBox 30"/>
+          <p:cNvPr id="32" name="TextBox 31"/>
           <p:cNvSpPr txBox="1"/>
           <p:nvPr/>
         </p:nvSpPr>
         <p:spPr>
           <a:xfrm>
-            <a:off x="6245349" y="4809744"/>
+            <a:off x="8211308" y="4809744"/>
             <a:ext cx="1746503" cy="182880"/>
           </a:xfrm>
           <a:prstGeom prst="rect">
@@ -4465,20 +4429,20 @@
                 <a:latin typeface="Microsoft YaHei"/>
                 <a:ea typeface="Microsoft YaHei"/>
               </a:rPr>
-              <a:t>P2P vs OSS</a:t>
-            </a:r>
-          </a:p>
-        </p:txBody>
-      </p:sp>
-      <p:sp>
-        <p:nvSpPr>
-          <p:cNvPr id="32" name="TextBox 31"/>
+              <a:t>同 SLO 吞吐</a:t>
+            </a:r>
+          </a:p>
+        </p:txBody>
+      </p:sp>
+      <p:sp>
+        <p:nvSpPr>
+          <p:cNvPr id="33" name="TextBox 32"/>
           <p:cNvSpPr txBox="1"/>
           <p:nvPr/>
         </p:nvSpPr>
         <p:spPr>
           <a:xfrm>
-            <a:off x="6245349" y="4992624"/>
+            <a:off x="8211308" y="4992624"/>
             <a:ext cx="1746503" cy="219456"/>
           </a:xfrm>
           <a:prstGeom prst="rect">
@@ -4501,20 +4465,20 @@
                 <a:latin typeface="Microsoft YaHei"/>
                 <a:ea typeface="Microsoft YaHei"/>
               </a:rPr>
-              <a:t>Qwen3-32B</a:t>
-            </a:r>
-          </a:p>
-        </p:txBody>
-      </p:sp>
-      <p:sp>
-        <p:nvSpPr>
-          <p:cNvPr id="33" name="TextBox 32"/>
+              <a:t>小红书生产</a:t>
+            </a:r>
+          </a:p>
+        </p:txBody>
+      </p:sp>
+      <p:sp>
+        <p:nvSpPr>
+          <p:cNvPr id="34" name="TextBox 33"/>
           <p:cNvSpPr txBox="1"/>
           <p:nvPr/>
         </p:nvSpPr>
         <p:spPr>
           <a:xfrm>
-            <a:off x="6245349" y="5212080"/>
+            <a:off x="8211308" y="5212080"/>
             <a:ext cx="1746503" cy="329184"/>
           </a:xfrm>
           <a:prstGeom prst="rect">
@@ -4537,20 +4501,20 @@
                 <a:latin typeface="Microsoft YaHei"/>
                 <a:ea typeface="Microsoft YaHei"/>
               </a:rPr>
-              <a:t>13.5×</a:t>
-            </a:r>
-          </a:p>
-        </p:txBody>
-      </p:sp>
-      <p:sp>
-        <p:nvSpPr>
-          <p:cNvPr id="34" name="Rectangle 33"/>
+              <a:t>2~3×</a:t>
+            </a:r>
+          </a:p>
+        </p:txBody>
+      </p:sp>
+      <p:sp>
+        <p:nvSpPr>
+          <p:cNvPr id="35" name="Rectangle 34"/>
           <p:cNvSpPr/>
           <p:nvPr/>
         </p:nvSpPr>
         <p:spPr>
           <a:xfrm>
-            <a:off x="8138156" y="4773168"/>
+            <a:off x="10104115" y="4773168"/>
             <a:ext cx="1874519" cy="841248"/>
           </a:xfrm>
           <a:prstGeom prst="rect">
@@ -4589,13 +4553,13 @@
       </p:sp>
       <p:sp>
         <p:nvSpPr>
-          <p:cNvPr id="35" name="TextBox 34"/>
+          <p:cNvPr id="36" name="TextBox 35"/>
           <p:cNvSpPr txBox="1"/>
           <p:nvPr/>
         </p:nvSpPr>
         <p:spPr>
           <a:xfrm>
-            <a:off x="8211308" y="4809744"/>
+            <a:off x="10177267" y="4809744"/>
             <a:ext cx="1746503" cy="182880"/>
           </a:xfrm>
           <a:prstGeom prst="rect">
@@ -4618,20 +4582,20 @@
                 <a:latin typeface="Microsoft YaHei"/>
                 <a:ea typeface="Microsoft YaHei"/>
               </a:rPr>
-              <a:t>同 SLO 吞吐</a:t>
-            </a:r>
-          </a:p>
-        </p:txBody>
-      </p:sp>
-      <p:sp>
-        <p:nvSpPr>
-          <p:cNvPr id="36" name="TextBox 35"/>
+              <a:t>GPU 资源</a:t>
+            </a:r>
+          </a:p>
+        </p:txBody>
+      </p:sp>
+      <p:sp>
+        <p:nvSpPr>
+          <p:cNvPr id="37" name="TextBox 36"/>
           <p:cNvSpPr txBox="1"/>
           <p:nvPr/>
         </p:nvSpPr>
         <p:spPr>
           <a:xfrm>
-            <a:off x="8211308" y="4992624"/>
+            <a:off x="10177267" y="4992624"/>
             <a:ext cx="1746503" cy="219456"/>
           </a:xfrm>
           <a:prstGeom prst="rect">
@@ -4661,13 +4625,13 @@
       </p:sp>
       <p:sp>
         <p:nvSpPr>
-          <p:cNvPr id="37" name="TextBox 36"/>
+          <p:cNvPr id="38" name="TextBox 37"/>
           <p:cNvSpPr txBox="1"/>
           <p:nvPr/>
         </p:nvSpPr>
         <p:spPr>
           <a:xfrm>
-            <a:off x="8211308" y="5212080"/>
+            <a:off x="10177267" y="5212080"/>
             <a:ext cx="1746503" cy="329184"/>
           </a:xfrm>
           <a:prstGeom prst="rect">
@@ -4690,21 +4654,21 @@
                 <a:latin typeface="Microsoft YaHei"/>
                 <a:ea typeface="Microsoft YaHei"/>
               </a:rPr>
-              <a:t>2~3×</a:t>
-            </a:r>
-          </a:p>
-        </p:txBody>
-      </p:sp>
-      <p:sp>
-        <p:nvSpPr>
-          <p:cNvPr id="38" name="Rectangle 37"/>
+              <a:t>节省 50%</a:t>
+            </a:r>
+          </a:p>
+        </p:txBody>
+      </p:sp>
+      <p:sp>
+        <p:nvSpPr>
+          <p:cNvPr id="39" name="Rectangle 38"/>
           <p:cNvSpPr/>
           <p:nvPr/>
         </p:nvSpPr>
         <p:spPr>
           <a:xfrm>
-            <a:off x="10104115" y="4773168"/>
-            <a:ext cx="1874519" cy="841248"/>
+            <a:off x="0" y="5760720"/>
+            <a:ext cx="12191695" cy="1097280"/>
           </a:xfrm>
           <a:prstGeom prst="rect">
             <a:avLst/>
@@ -4712,10 +4676,8 @@
           <a:solidFill>
             <a:srgbClr val="FFFFFF"/>
           </a:solidFill>
-          <a:ln w="12700">
-            <a:solidFill>
-              <a:srgbClr val="D0D8DE"/>
-            </a:solidFill>
+          <a:ln>
+            <a:noFill/>
           </a:ln>
         </p:spPr>
         <p:style>
@@ -4742,14 +4704,14 @@
       </p:sp>
       <p:sp>
         <p:nvSpPr>
-          <p:cNvPr id="39" name="TextBox 38"/>
+          <p:cNvPr id="40" name="TextBox 39"/>
           <p:cNvSpPr txBox="1"/>
           <p:nvPr/>
         </p:nvSpPr>
         <p:spPr>
           <a:xfrm>
-            <a:off x="10177267" y="4809744"/>
-            <a:ext cx="1746503" cy="182880"/>
+            <a:off x="320040" y="5815584"/>
+            <a:ext cx="11521440" cy="502920"/>
           </a:xfrm>
           <a:prstGeom prst="rect">
             <a:avLst/>
@@ -4764,157 +4726,6 @@
           <a:p>
             <a:pPr algn="l"/>
             <a:r>
-              <a:rPr sz="900" b="0">
-                <a:solidFill>
-                  <a:srgbClr val="6B6B6B"/>
-                </a:solidFill>
-                <a:latin typeface="Microsoft YaHei"/>
-                <a:ea typeface="Microsoft YaHei"/>
-              </a:rPr>
-              <a:t>GPU 资源</a:t>
-            </a:r>
-          </a:p>
-        </p:txBody>
-      </p:sp>
-      <p:sp>
-        <p:nvSpPr>
-          <p:cNvPr id="40" name="TextBox 39"/>
-          <p:cNvSpPr txBox="1"/>
-          <p:nvPr/>
-        </p:nvSpPr>
-        <p:spPr>
-          <a:xfrm>
-            <a:off x="10177267" y="4992624"/>
-            <a:ext cx="1746503" cy="219456"/>
-          </a:xfrm>
-          <a:prstGeom prst="rect">
-            <a:avLst/>
-          </a:prstGeom>
-          <a:noFill/>
-        </p:spPr>
-        <p:txBody>
-          <a:bodyPr wrap="square">
-            <a:spAutoFit/>
-          </a:bodyPr>
-          <a:lstStyle/>
-          <a:p>
-            <a:pPr algn="l"/>
-            <a:r>
-              <a:rPr sz="900" b="0">
-                <a:solidFill>
-                  <a:srgbClr val="4A4A4A"/>
-                </a:solidFill>
-                <a:latin typeface="Microsoft YaHei"/>
-                <a:ea typeface="Microsoft YaHei"/>
-              </a:rPr>
-              <a:t>小红书生产</a:t>
-            </a:r>
-          </a:p>
-        </p:txBody>
-      </p:sp>
-      <p:sp>
-        <p:nvSpPr>
-          <p:cNvPr id="41" name="TextBox 40"/>
-          <p:cNvSpPr txBox="1"/>
-          <p:nvPr/>
-        </p:nvSpPr>
-        <p:spPr>
-          <a:xfrm>
-            <a:off x="10177267" y="5212080"/>
-            <a:ext cx="1746503" cy="329184"/>
-          </a:xfrm>
-          <a:prstGeom prst="rect">
-            <a:avLst/>
-          </a:prstGeom>
-          <a:noFill/>
-        </p:spPr>
-        <p:txBody>
-          <a:bodyPr wrap="square">
-            <a:spAutoFit/>
-          </a:bodyPr>
-          <a:lstStyle/>
-          <a:p>
-            <a:pPr algn="l"/>
-            <a:r>
-              <a:rPr sz="1300" b="1">
-                <a:solidFill>
-                  <a:srgbClr val="8B1A2B"/>
-                </a:solidFill>
-                <a:latin typeface="Microsoft YaHei"/>
-                <a:ea typeface="Microsoft YaHei"/>
-              </a:rPr>
-              <a:t>节省 50%</a:t>
-            </a:r>
-          </a:p>
-        </p:txBody>
-      </p:sp>
-      <p:sp>
-        <p:nvSpPr>
-          <p:cNvPr id="42" name="Rectangle 41"/>
-          <p:cNvSpPr/>
-          <p:nvPr/>
-        </p:nvSpPr>
-        <p:spPr>
-          <a:xfrm>
-            <a:off x="0" y="5760720"/>
-            <a:ext cx="12191695" cy="1097280"/>
-          </a:xfrm>
-          <a:prstGeom prst="rect">
-            <a:avLst/>
-          </a:prstGeom>
-          <a:solidFill>
-            <a:srgbClr val="FFFFFF"/>
-          </a:solidFill>
-          <a:ln>
-            <a:noFill/>
-          </a:ln>
-        </p:spPr>
-        <p:style>
-          <a:lnRef idx="1">
-            <a:schemeClr val="accent1"/>
-          </a:lnRef>
-          <a:fillRef idx="3">
-            <a:schemeClr val="accent1"/>
-          </a:fillRef>
-          <a:effectRef idx="2">
-            <a:schemeClr val="accent1"/>
-          </a:effectRef>
-          <a:fontRef idx="minor">
-            <a:schemeClr val="lt1"/>
-          </a:fontRef>
-        </p:style>
-        <p:txBody>
-          <a:bodyPr rtlCol="0" anchor="ctr"/>
-          <a:lstStyle/>
-          <a:p>
-            <a:pPr algn="ctr"/>
-          </a:p>
-        </p:txBody>
-      </p:sp>
-      <p:sp>
-        <p:nvSpPr>
-          <p:cNvPr id="43" name="TextBox 42"/>
-          <p:cNvSpPr txBox="1"/>
-          <p:nvPr/>
-        </p:nvSpPr>
-        <p:spPr>
-          <a:xfrm>
-            <a:off x="320040" y="5815584"/>
-            <a:ext cx="11521440" cy="502920"/>
-          </a:xfrm>
-          <a:prstGeom prst="rect">
-            <a:avLst/>
-          </a:prstGeom>
-          <a:noFill/>
-        </p:spPr>
-        <p:txBody>
-          <a:bodyPr wrap="square">
-            <a:spAutoFit/>
-          </a:bodyPr>
-          <a:lstStyle/>
-          <a:p>
-            <a:pPr algn="l"/>
-            <a:r>
               <a:rPr sz="1100" b="1">
                 <a:solidFill>
                   <a:srgbClr val="1A1A1A"/>
@@ -4929,7 +4740,7 @@
       </p:sp>
       <p:sp>
         <p:nvSpPr>
-          <p:cNvPr id="44" name="TextBox 43"/>
+          <p:cNvPr id="41" name="TextBox 40"/>
           <p:cNvSpPr txBox="1"/>
           <p:nvPr/>
         </p:nvSpPr>

</xml_diff>

<commit_message>
Rewrite ACK×小红书 footer 技术启示 with concrete Cost/Token and stack detail
Replace the vague one-liner with three actionable takeaways covering formula levers, Serving Stack defaults, and GroupSet→RBG staging.

Co-authored-by: Annie <Annie-Summer@users.noreply.github.com>
</commit_message>
<xml_diff>
--- a/yunqi-2026-agenda-201/docs/洞察一页-08-容器服务 × 小红书：大模型推理与 Agent RL.pptx
+++ b/yunqi-2026-agenda-201/docs/洞察一页-08-容器服务 × 小红书：大模型推理与 Agent RL.pptx
@@ -3336,7 +3336,7 @@
         <p:spPr>
           <a:xfrm>
             <a:off x="274320" y="1956816"/>
-            <a:ext cx="5705856" cy="2450592"/>
+            <a:ext cx="5705856" cy="2267712"/>
           </a:xfrm>
           <a:prstGeom prst="rect">
             <a:avLst/>
@@ -3380,8 +3380,8 @@
         </p:nvSpPr>
         <p:spPr>
           <a:xfrm>
-            <a:off x="420624" y="2048256"/>
-            <a:ext cx="5413248" cy="292608"/>
+            <a:off x="420624" y="2029968"/>
+            <a:ext cx="5413248" cy="274320"/>
           </a:xfrm>
           <a:prstGeom prst="rect">
             <a:avLst/>
@@ -3416,8 +3416,8 @@
         </p:nvSpPr>
         <p:spPr>
           <a:xfrm>
-            <a:off x="420624" y="2377440"/>
-            <a:ext cx="5413248" cy="1938528"/>
+            <a:off x="420624" y="2322576"/>
+            <a:ext cx="5413248" cy="1828800"/>
           </a:xfrm>
           <a:prstGeom prst="rect">
             <a:avLst/>
@@ -3432,11 +3432,11 @@
           <a:p>
             <a:pPr algn="l">
               <a:spcAft>
-                <a:spcPts val="200"/>
+                <a:spcPts val="100"/>
               </a:spcAft>
             </a:pPr>
             <a:r>
-              <a:rPr sz="1100" b="1">
+              <a:rPr sz="1000" b="1">
                 <a:solidFill>
                   <a:srgbClr val="1A1A1A"/>
                 </a:solidFill>
@@ -3449,11 +3449,11 @@
           <a:p>
             <a:pPr algn="l">
               <a:spcAft>
-                <a:spcPts val="200"/>
+                <a:spcPts val="100"/>
               </a:spcAft>
             </a:pPr>
             <a:r>
-              <a:rPr sz="1100" b="0">
+              <a:rPr sz="1000" b="0">
                 <a:solidFill>
                   <a:srgbClr val="4A4A4A"/>
                 </a:solidFill>
@@ -3466,11 +3466,11 @@
           <a:p>
             <a:pPr algn="l">
               <a:spcAft>
-                <a:spcPts val="200"/>
+                <a:spcPts val="100"/>
               </a:spcAft>
             </a:pPr>
             <a:r>
-              <a:rPr sz="1100" b="0">
+              <a:rPr sz="1000" b="0">
                 <a:solidFill>
                   <a:srgbClr val="4A4A4A"/>
                 </a:solidFill>
@@ -3483,11 +3483,11 @@
           <a:p>
             <a:pPr algn="l">
               <a:spcAft>
-                <a:spcPts val="200"/>
+                <a:spcPts val="100"/>
               </a:spcAft>
             </a:pPr>
             <a:r>
-              <a:rPr sz="1100" b="0">
+              <a:rPr sz="1000" b="0">
                 <a:solidFill>
                   <a:srgbClr val="4A4A4A"/>
                 </a:solidFill>
@@ -3500,11 +3500,11 @@
           <a:p>
             <a:pPr algn="l">
               <a:spcAft>
-                <a:spcPts val="200"/>
+                <a:spcPts val="100"/>
               </a:spcAft>
             </a:pPr>
             <a:r>
-              <a:rPr sz="1100" b="0">
+              <a:rPr sz="1000" b="0">
                 <a:solidFill>
                   <a:srgbClr val="4A4A4A"/>
                 </a:solidFill>
@@ -3525,7 +3525,7 @@
         <p:spPr>
           <a:xfrm>
             <a:off x="6181344" y="1956816"/>
-            <a:ext cx="5705856" cy="2450592"/>
+            <a:ext cx="5705856" cy="2267712"/>
           </a:xfrm>
           <a:prstGeom prst="rect">
             <a:avLst/>
@@ -3569,8 +3569,8 @@
         </p:nvSpPr>
         <p:spPr>
           <a:xfrm>
-            <a:off x="6327648" y="2048256"/>
-            <a:ext cx="5413248" cy="292608"/>
+            <a:off x="6327648" y="2029968"/>
+            <a:ext cx="5413248" cy="274320"/>
           </a:xfrm>
           <a:prstGeom prst="rect">
             <a:avLst/>
@@ -3605,8 +3605,8 @@
         </p:nvSpPr>
         <p:spPr>
           <a:xfrm>
-            <a:off x="6327648" y="2377440"/>
-            <a:ext cx="5413248" cy="1938528"/>
+            <a:off x="6327648" y="2322576"/>
+            <a:ext cx="5413248" cy="1828800"/>
           </a:xfrm>
           <a:prstGeom prst="rect">
             <a:avLst/>
@@ -3621,11 +3621,11 @@
           <a:p>
             <a:pPr algn="l">
               <a:spcAft>
-                <a:spcPts val="200"/>
+                <a:spcPts val="100"/>
               </a:spcAft>
             </a:pPr>
             <a:r>
-              <a:rPr sz="1100" b="1">
+              <a:rPr sz="1000" b="1">
                 <a:solidFill>
                   <a:srgbClr val="1A1A1A"/>
                 </a:solidFill>
@@ -3638,11 +3638,11 @@
           <a:p>
             <a:pPr algn="l">
               <a:spcAft>
-                <a:spcPts val="200"/>
+                <a:spcPts val="100"/>
               </a:spcAft>
             </a:pPr>
             <a:r>
-              <a:rPr sz="1100" b="0">
+              <a:rPr sz="1000" b="0">
                 <a:solidFill>
                   <a:srgbClr val="4A4A4A"/>
                 </a:solidFill>
@@ -3655,11 +3655,11 @@
           <a:p>
             <a:pPr algn="l">
               <a:spcAft>
-                <a:spcPts val="200"/>
+                <a:spcPts val="100"/>
               </a:spcAft>
             </a:pPr>
             <a:r>
-              <a:rPr sz="1100" b="0">
+              <a:rPr sz="1000" b="0">
                 <a:solidFill>
                   <a:srgbClr val="4A4A4A"/>
                 </a:solidFill>
@@ -3672,11 +3672,11 @@
           <a:p>
             <a:pPr algn="l">
               <a:spcAft>
-                <a:spcPts val="200"/>
+                <a:spcPts val="100"/>
               </a:spcAft>
             </a:pPr>
             <a:r>
-              <a:rPr sz="1100" b="0">
+              <a:rPr sz="1000" b="0">
                 <a:solidFill>
                   <a:srgbClr val="4A4A4A"/>
                 </a:solidFill>
@@ -3689,11 +3689,11 @@
           <a:p>
             <a:pPr algn="l">
               <a:spcAft>
-                <a:spcPts val="200"/>
+                <a:spcPts val="100"/>
               </a:spcAft>
             </a:pPr>
             <a:r>
-              <a:rPr sz="1100" b="0">
+              <a:rPr sz="1000" b="0">
                 <a:solidFill>
                   <a:srgbClr val="4A4A4A"/>
                 </a:solidFill>
@@ -3713,8 +3713,8 @@
         </p:nvSpPr>
         <p:spPr>
           <a:xfrm>
-            <a:off x="274320" y="4535424"/>
-            <a:ext cx="9144000" cy="219456"/>
+            <a:off x="274320" y="4315968"/>
+            <a:ext cx="9144000" cy="201168"/>
           </a:xfrm>
           <a:prstGeom prst="rect">
             <a:avLst/>
@@ -3729,7 +3729,7 @@
           <a:p>
             <a:pPr algn="l"/>
             <a:r>
-              <a:rPr sz="1200" b="1">
+              <a:rPr sz="1100" b="1">
                 <a:solidFill>
                   <a:srgbClr val="1A1A1A"/>
                 </a:solidFill>
@@ -3749,8 +3749,8 @@
         </p:nvSpPr>
         <p:spPr>
           <a:xfrm>
-            <a:off x="274320" y="4773168"/>
-            <a:ext cx="1874519" cy="841248"/>
+            <a:off x="274320" y="4517136"/>
+            <a:ext cx="1874519" cy="713232"/>
           </a:xfrm>
           <a:prstGeom prst="rect">
             <a:avLst/>
@@ -3794,8 +3794,8 @@
         </p:nvSpPr>
         <p:spPr>
           <a:xfrm>
-            <a:off x="347472" y="4809744"/>
-            <a:ext cx="1746503" cy="182880"/>
+            <a:off x="347472" y="4535424"/>
+            <a:ext cx="1746503" cy="164592"/>
           </a:xfrm>
           <a:prstGeom prst="rect">
             <a:avLst/>
@@ -3830,8 +3830,8 @@
         </p:nvSpPr>
         <p:spPr>
           <a:xfrm>
-            <a:off x="347472" y="4992624"/>
-            <a:ext cx="1746503" cy="219456"/>
+            <a:off x="347472" y="4700016"/>
+            <a:ext cx="1746503" cy="182880"/>
           </a:xfrm>
           <a:prstGeom prst="rect">
             <a:avLst/>
@@ -3866,8 +3866,8 @@
         </p:nvSpPr>
         <p:spPr>
           <a:xfrm>
-            <a:off x="347472" y="5212080"/>
-            <a:ext cx="1746503" cy="329184"/>
+            <a:off x="347472" y="4882896"/>
+            <a:ext cx="1746503" cy="292608"/>
           </a:xfrm>
           <a:prstGeom prst="rect">
             <a:avLst/>
@@ -3882,7 +3882,7 @@
           <a:p>
             <a:pPr algn="l"/>
             <a:r>
-              <a:rPr sz="1300" b="1">
+              <a:rPr sz="1200" b="1">
                 <a:solidFill>
                   <a:srgbClr val="8B1A2B"/>
                 </a:solidFill>
@@ -3902,8 +3902,8 @@
         </p:nvSpPr>
         <p:spPr>
           <a:xfrm>
-            <a:off x="2240279" y="4773168"/>
-            <a:ext cx="1874519" cy="841248"/>
+            <a:off x="2240279" y="4517136"/>
+            <a:ext cx="1874519" cy="713232"/>
           </a:xfrm>
           <a:prstGeom prst="rect">
             <a:avLst/>
@@ -3947,8 +3947,8 @@
         </p:nvSpPr>
         <p:spPr>
           <a:xfrm>
-            <a:off x="2313431" y="4809744"/>
-            <a:ext cx="1746503" cy="182880"/>
+            <a:off x="2313431" y="4535424"/>
+            <a:ext cx="1746503" cy="164592"/>
           </a:xfrm>
           <a:prstGeom prst="rect">
             <a:avLst/>
@@ -3983,8 +3983,8 @@
         </p:nvSpPr>
         <p:spPr>
           <a:xfrm>
-            <a:off x="2313431" y="4992624"/>
-            <a:ext cx="1746503" cy="219456"/>
+            <a:off x="2313431" y="4700016"/>
+            <a:ext cx="1746503" cy="182880"/>
           </a:xfrm>
           <a:prstGeom prst="rect">
             <a:avLst/>
@@ -4019,8 +4019,8 @@
         </p:nvSpPr>
         <p:spPr>
           <a:xfrm>
-            <a:off x="2313431" y="5212080"/>
-            <a:ext cx="1746503" cy="329184"/>
+            <a:off x="2313431" y="4882896"/>
+            <a:ext cx="1746503" cy="292608"/>
           </a:xfrm>
           <a:prstGeom prst="rect">
             <a:avLst/>
@@ -4035,7 +4035,7 @@
           <a:p>
             <a:pPr algn="l"/>
             <a:r>
-              <a:rPr sz="1300" b="1">
+              <a:rPr sz="1200" b="1">
                 <a:solidFill>
                   <a:srgbClr val="8B1A2B"/>
                 </a:solidFill>
@@ -4055,8 +4055,8 @@
         </p:nvSpPr>
         <p:spPr>
           <a:xfrm>
-            <a:off x="4206238" y="4773168"/>
-            <a:ext cx="1874519" cy="841248"/>
+            <a:off x="4206238" y="4517136"/>
+            <a:ext cx="1874519" cy="713232"/>
           </a:xfrm>
           <a:prstGeom prst="rect">
             <a:avLst/>
@@ -4100,8 +4100,8 @@
         </p:nvSpPr>
         <p:spPr>
           <a:xfrm>
-            <a:off x="4279390" y="4809744"/>
-            <a:ext cx="1746503" cy="182880"/>
+            <a:off x="4279390" y="4535424"/>
+            <a:ext cx="1746503" cy="164592"/>
           </a:xfrm>
           <a:prstGeom prst="rect">
             <a:avLst/>
@@ -4136,8 +4136,8 @@
         </p:nvSpPr>
         <p:spPr>
           <a:xfrm>
-            <a:off x="4279390" y="4992624"/>
-            <a:ext cx="1746503" cy="219456"/>
+            <a:off x="4279390" y="4700016"/>
+            <a:ext cx="1746503" cy="182880"/>
           </a:xfrm>
           <a:prstGeom prst="rect">
             <a:avLst/>
@@ -4172,8 +4172,8 @@
         </p:nvSpPr>
         <p:spPr>
           <a:xfrm>
-            <a:off x="4279390" y="5212080"/>
-            <a:ext cx="1746503" cy="329184"/>
+            <a:off x="4279390" y="4882896"/>
+            <a:ext cx="1746503" cy="292608"/>
           </a:xfrm>
           <a:prstGeom prst="rect">
             <a:avLst/>
@@ -4188,7 +4188,7 @@
           <a:p>
             <a:pPr algn="l"/>
             <a:r>
-              <a:rPr sz="1300" b="1">
+              <a:rPr sz="1200" b="1">
                 <a:solidFill>
                   <a:srgbClr val="8B1A2B"/>
                 </a:solidFill>
@@ -4208,8 +4208,8 @@
         </p:nvSpPr>
         <p:spPr>
           <a:xfrm>
-            <a:off x="6172197" y="4773168"/>
-            <a:ext cx="1874519" cy="841248"/>
+            <a:off x="6172197" y="4517136"/>
+            <a:ext cx="1874519" cy="713232"/>
           </a:xfrm>
           <a:prstGeom prst="rect">
             <a:avLst/>
@@ -4253,8 +4253,8 @@
         </p:nvSpPr>
         <p:spPr>
           <a:xfrm>
-            <a:off x="6245349" y="4809744"/>
-            <a:ext cx="1746503" cy="182880"/>
+            <a:off x="6245349" y="4535424"/>
+            <a:ext cx="1746503" cy="164592"/>
           </a:xfrm>
           <a:prstGeom prst="rect">
             <a:avLst/>
@@ -4289,8 +4289,8 @@
         </p:nvSpPr>
         <p:spPr>
           <a:xfrm>
-            <a:off x="6245349" y="4992624"/>
-            <a:ext cx="1746503" cy="219456"/>
+            <a:off x="6245349" y="4700016"/>
+            <a:ext cx="1746503" cy="182880"/>
           </a:xfrm>
           <a:prstGeom prst="rect">
             <a:avLst/>
@@ -4325,8 +4325,8 @@
         </p:nvSpPr>
         <p:spPr>
           <a:xfrm>
-            <a:off x="6245349" y="5212080"/>
-            <a:ext cx="1746503" cy="329184"/>
+            <a:off x="6245349" y="4882896"/>
+            <a:ext cx="1746503" cy="292608"/>
           </a:xfrm>
           <a:prstGeom prst="rect">
             <a:avLst/>
@@ -4341,7 +4341,7 @@
           <a:p>
             <a:pPr algn="l"/>
             <a:r>
-              <a:rPr sz="1300" b="1">
+              <a:rPr sz="1200" b="1">
                 <a:solidFill>
                   <a:srgbClr val="8B1A2B"/>
                 </a:solidFill>
@@ -4361,8 +4361,8 @@
         </p:nvSpPr>
         <p:spPr>
           <a:xfrm>
-            <a:off x="8138156" y="4773168"/>
-            <a:ext cx="1874519" cy="841248"/>
+            <a:off x="8138156" y="4517136"/>
+            <a:ext cx="1874519" cy="713232"/>
           </a:xfrm>
           <a:prstGeom prst="rect">
             <a:avLst/>
@@ -4406,8 +4406,8 @@
         </p:nvSpPr>
         <p:spPr>
           <a:xfrm>
-            <a:off x="8211308" y="4809744"/>
-            <a:ext cx="1746503" cy="182880"/>
+            <a:off x="8211308" y="4535424"/>
+            <a:ext cx="1746503" cy="164592"/>
           </a:xfrm>
           <a:prstGeom prst="rect">
             <a:avLst/>
@@ -4442,8 +4442,8 @@
         </p:nvSpPr>
         <p:spPr>
           <a:xfrm>
-            <a:off x="8211308" y="4992624"/>
-            <a:ext cx="1746503" cy="219456"/>
+            <a:off x="8211308" y="4700016"/>
+            <a:ext cx="1746503" cy="182880"/>
           </a:xfrm>
           <a:prstGeom prst="rect">
             <a:avLst/>
@@ -4478,8 +4478,8 @@
         </p:nvSpPr>
         <p:spPr>
           <a:xfrm>
-            <a:off x="8211308" y="5212080"/>
-            <a:ext cx="1746503" cy="329184"/>
+            <a:off x="8211308" y="4882896"/>
+            <a:ext cx="1746503" cy="292608"/>
           </a:xfrm>
           <a:prstGeom prst="rect">
             <a:avLst/>
@@ -4494,7 +4494,7 @@
           <a:p>
             <a:pPr algn="l"/>
             <a:r>
-              <a:rPr sz="1300" b="1">
+              <a:rPr sz="1200" b="1">
                 <a:solidFill>
                   <a:srgbClr val="8B1A2B"/>
                 </a:solidFill>
@@ -4514,8 +4514,8 @@
         </p:nvSpPr>
         <p:spPr>
           <a:xfrm>
-            <a:off x="10104115" y="4773168"/>
-            <a:ext cx="1874519" cy="841248"/>
+            <a:off x="10104115" y="4517136"/>
+            <a:ext cx="1874519" cy="713232"/>
           </a:xfrm>
           <a:prstGeom prst="rect">
             <a:avLst/>
@@ -4559,8 +4559,8 @@
         </p:nvSpPr>
         <p:spPr>
           <a:xfrm>
-            <a:off x="10177267" y="4809744"/>
-            <a:ext cx="1746503" cy="182880"/>
+            <a:off x="10177267" y="4535424"/>
+            <a:ext cx="1746503" cy="164592"/>
           </a:xfrm>
           <a:prstGeom prst="rect">
             <a:avLst/>
@@ -4595,8 +4595,8 @@
         </p:nvSpPr>
         <p:spPr>
           <a:xfrm>
-            <a:off x="10177267" y="4992624"/>
-            <a:ext cx="1746503" cy="219456"/>
+            <a:off x="10177267" y="4700016"/>
+            <a:ext cx="1746503" cy="182880"/>
           </a:xfrm>
           <a:prstGeom prst="rect">
             <a:avLst/>
@@ -4631,8 +4631,8 @@
         </p:nvSpPr>
         <p:spPr>
           <a:xfrm>
-            <a:off x="10177267" y="5212080"/>
-            <a:ext cx="1746503" cy="329184"/>
+            <a:off x="10177267" y="4882896"/>
+            <a:ext cx="1746503" cy="292608"/>
           </a:xfrm>
           <a:prstGeom prst="rect">
             <a:avLst/>
@@ -4647,7 +4647,7 @@
           <a:p>
             <a:pPr algn="l"/>
             <a:r>
-              <a:rPr sz="1300" b="1">
+              <a:rPr sz="1200" b="1">
                 <a:solidFill>
                   <a:srgbClr val="8B1A2B"/>
                 </a:solidFill>
@@ -4667,8 +4667,8 @@
         </p:nvSpPr>
         <p:spPr>
           <a:xfrm>
-            <a:off x="0" y="5760720"/>
-            <a:ext cx="12191695" cy="1097280"/>
+            <a:off x="0" y="5321808"/>
+            <a:ext cx="12191695" cy="1536192"/>
           </a:xfrm>
           <a:prstGeom prst="rect">
             <a:avLst/>
@@ -4710,8 +4710,8 @@
         </p:nvSpPr>
         <p:spPr>
           <a:xfrm>
-            <a:off x="320040" y="5815584"/>
-            <a:ext cx="11521440" cy="502920"/>
+            <a:off x="320040" y="5367528"/>
+            <a:ext cx="11521440" cy="1170432"/>
           </a:xfrm>
           <a:prstGeom prst="rect">
             <a:avLst/>
@@ -4724,16 +4724,71 @@
           </a:bodyPr>
           <a:lstStyle/>
           <a:p>
-            <a:pPr algn="l"/>
-            <a:r>
-              <a:rPr sz="1100" b="1">
+            <a:pPr algn="l">
+              <a:spcAft>
+                <a:spcPts val="100"/>
+              </a:spcAft>
+            </a:pPr>
+            <a:r>
+              <a:rPr sz="1000" b="1">
                 <a:solidFill>
                   <a:srgbClr val="1A1A1A"/>
                 </a:solidFill>
                 <a:latin typeface="Microsoft YaHei"/>
                 <a:ea typeface="Microsoft YaHei"/>
               </a:rPr>
-              <a:t>技术启示：以 Cost/Token 统一经营与技术目标；把缓存亲和路由、分层权重分发、拓扑感知注入固化进 Serving Stack；按性能压力分阶段演进编排——静态 PD 做成组调度/原地升级/容量防护稳态基座，RBG 做角色解耦与策略协同弹性控制面，持续兑现吞吐提升、时延下降与 GPU 利用率改善。</a:t>
+              <a:t>技术启示：</a:t>
+            </a:r>
+          </a:p>
+          <a:p>
+            <a:pPr algn="l">
+              <a:spcAft>
+                <a:spcPts val="100"/>
+              </a:spcAft>
+            </a:pPr>
+            <a:r>
+              <a:rPr sz="1000" b="0">
+                <a:solidFill>
+                  <a:srgbClr val="1A1A1A"/>
+                </a:solidFill>
+                <a:latin typeface="Microsoft YaHei"/>
+                <a:ea typeface="Microsoft YaHei"/>
+              </a:rPr>
+              <a:t>• Cost/Token 拆三项落地：分子控 GPU 选型/潮汐混部/Spot；分母用 PD 分离、EP/DP、KVCache Offload/复用抬吞吐，用 KV 感知路由与弹性抬利用率；能力按对公式三项的贡献立项与验收。</a:t>
+            </a:r>
+          </a:p>
+          <a:p>
+            <a:pPr algn="l">
+              <a:spcAft>
+                <a:spcPts val="100"/>
+              </a:spcAft>
+            </a:pPr>
+            <a:r>
+              <a:rPr sz="1000" b="0">
+                <a:solidFill>
+                  <a:srgbClr val="1A1A1A"/>
+                </a:solidFill>
+                <a:latin typeface="Microsoft YaHei"/>
+                <a:ea typeface="Microsoft YaHei"/>
+              </a:rPr>
+              <a:t>• Serving Stack 固化默认能力：网关公平调度+负载/缓存亲和；ModelScale 通 OSS→Mooncake→FlashGPU→引擎间 P2P（RDMA+GDR），权重分钟→秒级；InferenceKit 以 Webhook→Wrapper→插件注入 NUMA/启动加速，禁静默降级、Summary 可审计。</a:t>
+            </a:r>
+          </a:p>
+          <a:p>
+            <a:pPr algn="l">
+              <a:spcAft>
+                <a:spcPts val="100"/>
+              </a:spcAft>
+            </a:pPr>
+            <a:r>
+              <a:rPr sz="1000" b="0">
+                <a:solidFill>
+                  <a:srgbClr val="1A1A1A"/>
+                </a:solidFill>
+                <a:latin typeface="Microsoft YaHei"/>
+                <a:ea typeface="Microsoft YaHei"/>
+              </a:rPr>
+              <a:t>• 编排按性能压力分阶段：GroupSet 固定 P:D + Gang + 原地升级/组缓存先稳住发布与冷启；RBG 再把 Router/P/D/Encode/KV 升为独立 Role，按排队/TTFT/TPOT/KV 独立扩缩 + KVCache-Aware 选路；上接快照复用 + Rollout 托管，承接训推一体与 Agent RL。</a:t>
             </a:r>
           </a:p>
         </p:txBody>
@@ -4746,8 +4801,8 @@
         </p:nvSpPr>
         <p:spPr>
           <a:xfrm>
-            <a:off x="320040" y="6309360"/>
-            <a:ext cx="11521440" cy="237744"/>
+            <a:off x="320040" y="6565392"/>
+            <a:ext cx="11521440" cy="201168"/>
           </a:xfrm>
           <a:prstGeom prst="rect">
             <a:avLst/>

</xml_diff>

<commit_message>
Distill ACK×小红书 footer insight into viewpoint, not feature restatement
Rewrite the closing 技术启示 as a higher-level judgment: Cost/Token as platform competition, cold-start/topology as release gates, and role-level policy over fixed grouping.

Co-authored-by: Annie <Annie-Summer@users.noreply.github.com>
</commit_message>
<xml_diff>
--- a/yunqi-2026-agenda-201/docs/洞察一页-08-容器服务 × 小红书：大模型推理与 Agent RL.pptx
+++ b/yunqi-2026-agenda-201/docs/洞察一页-08-容器服务 × 小红书：大模型推理与 Agent RL.pptx
@@ -3336,7 +3336,7 @@
         <p:spPr>
           <a:xfrm>
             <a:off x="274320" y="1956816"/>
-            <a:ext cx="5705856" cy="2267712"/>
+            <a:ext cx="5705856" cy="2450592"/>
           </a:xfrm>
           <a:prstGeom prst="rect">
             <a:avLst/>
@@ -3380,8 +3380,8 @@
         </p:nvSpPr>
         <p:spPr>
           <a:xfrm>
-            <a:off x="420624" y="2029968"/>
-            <a:ext cx="5413248" cy="274320"/>
+            <a:off x="420624" y="2048256"/>
+            <a:ext cx="5413248" cy="292608"/>
           </a:xfrm>
           <a:prstGeom prst="rect">
             <a:avLst/>
@@ -3416,8 +3416,8 @@
         </p:nvSpPr>
         <p:spPr>
           <a:xfrm>
-            <a:off x="420624" y="2322576"/>
-            <a:ext cx="5413248" cy="1828800"/>
+            <a:off x="420624" y="2377440"/>
+            <a:ext cx="5413248" cy="1938528"/>
           </a:xfrm>
           <a:prstGeom prst="rect">
             <a:avLst/>
@@ -3432,11 +3432,11 @@
           <a:p>
             <a:pPr algn="l">
               <a:spcAft>
-                <a:spcPts val="100"/>
+                <a:spcPts val="200"/>
               </a:spcAft>
             </a:pPr>
             <a:r>
-              <a:rPr sz="1000" b="1">
+              <a:rPr sz="1100" b="1">
                 <a:solidFill>
                   <a:srgbClr val="1A1A1A"/>
                 </a:solidFill>
@@ -3449,11 +3449,11 @@
           <a:p>
             <a:pPr algn="l">
               <a:spcAft>
-                <a:spcPts val="100"/>
+                <a:spcPts val="200"/>
               </a:spcAft>
             </a:pPr>
             <a:r>
-              <a:rPr sz="1000" b="0">
+              <a:rPr sz="1100" b="0">
                 <a:solidFill>
                   <a:srgbClr val="4A4A4A"/>
                 </a:solidFill>
@@ -3466,11 +3466,11 @@
           <a:p>
             <a:pPr algn="l">
               <a:spcAft>
-                <a:spcPts val="100"/>
+                <a:spcPts val="200"/>
               </a:spcAft>
             </a:pPr>
             <a:r>
-              <a:rPr sz="1000" b="0">
+              <a:rPr sz="1100" b="0">
                 <a:solidFill>
                   <a:srgbClr val="4A4A4A"/>
                 </a:solidFill>
@@ -3483,11 +3483,11 @@
           <a:p>
             <a:pPr algn="l">
               <a:spcAft>
-                <a:spcPts val="100"/>
+                <a:spcPts val="200"/>
               </a:spcAft>
             </a:pPr>
             <a:r>
-              <a:rPr sz="1000" b="0">
+              <a:rPr sz="1100" b="0">
                 <a:solidFill>
                   <a:srgbClr val="4A4A4A"/>
                 </a:solidFill>
@@ -3500,11 +3500,11 @@
           <a:p>
             <a:pPr algn="l">
               <a:spcAft>
-                <a:spcPts val="100"/>
+                <a:spcPts val="200"/>
               </a:spcAft>
             </a:pPr>
             <a:r>
-              <a:rPr sz="1000" b="0">
+              <a:rPr sz="1100" b="0">
                 <a:solidFill>
                   <a:srgbClr val="4A4A4A"/>
                 </a:solidFill>
@@ -3525,7 +3525,7 @@
         <p:spPr>
           <a:xfrm>
             <a:off x="6181344" y="1956816"/>
-            <a:ext cx="5705856" cy="2267712"/>
+            <a:ext cx="5705856" cy="2450592"/>
           </a:xfrm>
           <a:prstGeom prst="rect">
             <a:avLst/>
@@ -3569,8 +3569,8 @@
         </p:nvSpPr>
         <p:spPr>
           <a:xfrm>
-            <a:off x="6327648" y="2029968"/>
-            <a:ext cx="5413248" cy="274320"/>
+            <a:off x="6327648" y="2048256"/>
+            <a:ext cx="5413248" cy="292608"/>
           </a:xfrm>
           <a:prstGeom prst="rect">
             <a:avLst/>
@@ -3605,8 +3605,8 @@
         </p:nvSpPr>
         <p:spPr>
           <a:xfrm>
-            <a:off x="6327648" y="2322576"/>
-            <a:ext cx="5413248" cy="1828800"/>
+            <a:off x="6327648" y="2377440"/>
+            <a:ext cx="5413248" cy="1938528"/>
           </a:xfrm>
           <a:prstGeom prst="rect">
             <a:avLst/>
@@ -3621,11 +3621,11 @@
           <a:p>
             <a:pPr algn="l">
               <a:spcAft>
-                <a:spcPts val="100"/>
+                <a:spcPts val="200"/>
               </a:spcAft>
             </a:pPr>
             <a:r>
-              <a:rPr sz="1000" b="1">
+              <a:rPr sz="1100" b="1">
                 <a:solidFill>
                   <a:srgbClr val="1A1A1A"/>
                 </a:solidFill>
@@ -3638,11 +3638,11 @@
           <a:p>
             <a:pPr algn="l">
               <a:spcAft>
-                <a:spcPts val="100"/>
+                <a:spcPts val="200"/>
               </a:spcAft>
             </a:pPr>
             <a:r>
-              <a:rPr sz="1000" b="0">
+              <a:rPr sz="1100" b="0">
                 <a:solidFill>
                   <a:srgbClr val="4A4A4A"/>
                 </a:solidFill>
@@ -3655,11 +3655,11 @@
           <a:p>
             <a:pPr algn="l">
               <a:spcAft>
-                <a:spcPts val="100"/>
+                <a:spcPts val="200"/>
               </a:spcAft>
             </a:pPr>
             <a:r>
-              <a:rPr sz="1000" b="0">
+              <a:rPr sz="1100" b="0">
                 <a:solidFill>
                   <a:srgbClr val="4A4A4A"/>
                 </a:solidFill>
@@ -3672,11 +3672,11 @@
           <a:p>
             <a:pPr algn="l">
               <a:spcAft>
-                <a:spcPts val="100"/>
+                <a:spcPts val="200"/>
               </a:spcAft>
             </a:pPr>
             <a:r>
-              <a:rPr sz="1000" b="0">
+              <a:rPr sz="1100" b="0">
                 <a:solidFill>
                   <a:srgbClr val="4A4A4A"/>
                 </a:solidFill>
@@ -3689,11 +3689,11 @@
           <a:p>
             <a:pPr algn="l">
               <a:spcAft>
-                <a:spcPts val="100"/>
+                <a:spcPts val="200"/>
               </a:spcAft>
             </a:pPr>
             <a:r>
-              <a:rPr sz="1000" b="0">
+              <a:rPr sz="1100" b="0">
                 <a:solidFill>
                   <a:srgbClr val="4A4A4A"/>
                 </a:solidFill>
@@ -3713,8 +3713,8 @@
         </p:nvSpPr>
         <p:spPr>
           <a:xfrm>
-            <a:off x="274320" y="4315968"/>
-            <a:ext cx="9144000" cy="201168"/>
+            <a:off x="274320" y="4535424"/>
+            <a:ext cx="9144000" cy="219456"/>
           </a:xfrm>
           <a:prstGeom prst="rect">
             <a:avLst/>
@@ -3729,7 +3729,7 @@
           <a:p>
             <a:pPr algn="l"/>
             <a:r>
-              <a:rPr sz="1100" b="1">
+              <a:rPr sz="1200" b="1">
                 <a:solidFill>
                   <a:srgbClr val="1A1A1A"/>
                 </a:solidFill>
@@ -3749,8 +3749,8 @@
         </p:nvSpPr>
         <p:spPr>
           <a:xfrm>
-            <a:off x="274320" y="4517136"/>
-            <a:ext cx="1874519" cy="713232"/>
+            <a:off x="274320" y="4773168"/>
+            <a:ext cx="1874519" cy="841248"/>
           </a:xfrm>
           <a:prstGeom prst="rect">
             <a:avLst/>
@@ -3794,8 +3794,8 @@
         </p:nvSpPr>
         <p:spPr>
           <a:xfrm>
-            <a:off x="347472" y="4535424"/>
-            <a:ext cx="1746503" cy="164592"/>
+            <a:off x="347472" y="4809744"/>
+            <a:ext cx="1746503" cy="182880"/>
           </a:xfrm>
           <a:prstGeom prst="rect">
             <a:avLst/>
@@ -3830,8 +3830,8 @@
         </p:nvSpPr>
         <p:spPr>
           <a:xfrm>
-            <a:off x="347472" y="4700016"/>
-            <a:ext cx="1746503" cy="182880"/>
+            <a:off x="347472" y="4992624"/>
+            <a:ext cx="1746503" cy="219456"/>
           </a:xfrm>
           <a:prstGeom prst="rect">
             <a:avLst/>
@@ -3866,8 +3866,8 @@
         </p:nvSpPr>
         <p:spPr>
           <a:xfrm>
-            <a:off x="347472" y="4882896"/>
-            <a:ext cx="1746503" cy="292608"/>
+            <a:off x="347472" y="5212080"/>
+            <a:ext cx="1746503" cy="329184"/>
           </a:xfrm>
           <a:prstGeom prst="rect">
             <a:avLst/>
@@ -3882,7 +3882,7 @@
           <a:p>
             <a:pPr algn="l"/>
             <a:r>
-              <a:rPr sz="1200" b="1">
+              <a:rPr sz="1300" b="1">
                 <a:solidFill>
                   <a:srgbClr val="8B1A2B"/>
                 </a:solidFill>
@@ -3902,8 +3902,8 @@
         </p:nvSpPr>
         <p:spPr>
           <a:xfrm>
-            <a:off x="2240279" y="4517136"/>
-            <a:ext cx="1874519" cy="713232"/>
+            <a:off x="2240279" y="4773168"/>
+            <a:ext cx="1874519" cy="841248"/>
           </a:xfrm>
           <a:prstGeom prst="rect">
             <a:avLst/>
@@ -3947,8 +3947,8 @@
         </p:nvSpPr>
         <p:spPr>
           <a:xfrm>
-            <a:off x="2313431" y="4535424"/>
-            <a:ext cx="1746503" cy="164592"/>
+            <a:off x="2313431" y="4809744"/>
+            <a:ext cx="1746503" cy="182880"/>
           </a:xfrm>
           <a:prstGeom prst="rect">
             <a:avLst/>
@@ -3983,8 +3983,8 @@
         </p:nvSpPr>
         <p:spPr>
           <a:xfrm>
-            <a:off x="2313431" y="4700016"/>
-            <a:ext cx="1746503" cy="182880"/>
+            <a:off x="2313431" y="4992624"/>
+            <a:ext cx="1746503" cy="219456"/>
           </a:xfrm>
           <a:prstGeom prst="rect">
             <a:avLst/>
@@ -4019,8 +4019,8 @@
         </p:nvSpPr>
         <p:spPr>
           <a:xfrm>
-            <a:off x="2313431" y="4882896"/>
-            <a:ext cx="1746503" cy="292608"/>
+            <a:off x="2313431" y="5212080"/>
+            <a:ext cx="1746503" cy="329184"/>
           </a:xfrm>
           <a:prstGeom prst="rect">
             <a:avLst/>
@@ -4035,7 +4035,7 @@
           <a:p>
             <a:pPr algn="l"/>
             <a:r>
-              <a:rPr sz="1200" b="1">
+              <a:rPr sz="1300" b="1">
                 <a:solidFill>
                   <a:srgbClr val="8B1A2B"/>
                 </a:solidFill>
@@ -4055,8 +4055,8 @@
         </p:nvSpPr>
         <p:spPr>
           <a:xfrm>
-            <a:off x="4206238" y="4517136"/>
-            <a:ext cx="1874519" cy="713232"/>
+            <a:off x="4206238" y="4773168"/>
+            <a:ext cx="1874519" cy="841248"/>
           </a:xfrm>
           <a:prstGeom prst="rect">
             <a:avLst/>
@@ -4100,8 +4100,8 @@
         </p:nvSpPr>
         <p:spPr>
           <a:xfrm>
-            <a:off x="4279390" y="4535424"/>
-            <a:ext cx="1746503" cy="164592"/>
+            <a:off x="4279390" y="4809744"/>
+            <a:ext cx="1746503" cy="182880"/>
           </a:xfrm>
           <a:prstGeom prst="rect">
             <a:avLst/>
@@ -4136,8 +4136,8 @@
         </p:nvSpPr>
         <p:spPr>
           <a:xfrm>
-            <a:off x="4279390" y="4700016"/>
-            <a:ext cx="1746503" cy="182880"/>
+            <a:off x="4279390" y="4992624"/>
+            <a:ext cx="1746503" cy="219456"/>
           </a:xfrm>
           <a:prstGeom prst="rect">
             <a:avLst/>
@@ -4172,8 +4172,8 @@
         </p:nvSpPr>
         <p:spPr>
           <a:xfrm>
-            <a:off x="4279390" y="4882896"/>
-            <a:ext cx="1746503" cy="292608"/>
+            <a:off x="4279390" y="5212080"/>
+            <a:ext cx="1746503" cy="329184"/>
           </a:xfrm>
           <a:prstGeom prst="rect">
             <a:avLst/>
@@ -4188,7 +4188,7 @@
           <a:p>
             <a:pPr algn="l"/>
             <a:r>
-              <a:rPr sz="1200" b="1">
+              <a:rPr sz="1300" b="1">
                 <a:solidFill>
                   <a:srgbClr val="8B1A2B"/>
                 </a:solidFill>
@@ -4208,8 +4208,8 @@
         </p:nvSpPr>
         <p:spPr>
           <a:xfrm>
-            <a:off x="6172197" y="4517136"/>
-            <a:ext cx="1874519" cy="713232"/>
+            <a:off x="6172197" y="4773168"/>
+            <a:ext cx="1874519" cy="841248"/>
           </a:xfrm>
           <a:prstGeom prst="rect">
             <a:avLst/>
@@ -4253,8 +4253,8 @@
         </p:nvSpPr>
         <p:spPr>
           <a:xfrm>
-            <a:off x="6245349" y="4535424"/>
-            <a:ext cx="1746503" cy="164592"/>
+            <a:off x="6245349" y="4809744"/>
+            <a:ext cx="1746503" cy="182880"/>
           </a:xfrm>
           <a:prstGeom prst="rect">
             <a:avLst/>
@@ -4289,8 +4289,8 @@
         </p:nvSpPr>
         <p:spPr>
           <a:xfrm>
-            <a:off x="6245349" y="4700016"/>
-            <a:ext cx="1746503" cy="182880"/>
+            <a:off x="6245349" y="4992624"/>
+            <a:ext cx="1746503" cy="219456"/>
           </a:xfrm>
           <a:prstGeom prst="rect">
             <a:avLst/>
@@ -4325,8 +4325,8 @@
         </p:nvSpPr>
         <p:spPr>
           <a:xfrm>
-            <a:off x="6245349" y="4882896"/>
-            <a:ext cx="1746503" cy="292608"/>
+            <a:off x="6245349" y="5212080"/>
+            <a:ext cx="1746503" cy="329184"/>
           </a:xfrm>
           <a:prstGeom prst="rect">
             <a:avLst/>
@@ -4341,7 +4341,7 @@
           <a:p>
             <a:pPr algn="l"/>
             <a:r>
-              <a:rPr sz="1200" b="1">
+              <a:rPr sz="1300" b="1">
                 <a:solidFill>
                   <a:srgbClr val="8B1A2B"/>
                 </a:solidFill>
@@ -4361,8 +4361,8 @@
         </p:nvSpPr>
         <p:spPr>
           <a:xfrm>
-            <a:off x="8138156" y="4517136"/>
-            <a:ext cx="1874519" cy="713232"/>
+            <a:off x="8138156" y="4773168"/>
+            <a:ext cx="1874519" cy="841248"/>
           </a:xfrm>
           <a:prstGeom prst="rect">
             <a:avLst/>
@@ -4406,8 +4406,8 @@
         </p:nvSpPr>
         <p:spPr>
           <a:xfrm>
-            <a:off x="8211308" y="4535424"/>
-            <a:ext cx="1746503" cy="164592"/>
+            <a:off x="8211308" y="4809744"/>
+            <a:ext cx="1746503" cy="182880"/>
           </a:xfrm>
           <a:prstGeom prst="rect">
             <a:avLst/>
@@ -4442,8 +4442,8 @@
         </p:nvSpPr>
         <p:spPr>
           <a:xfrm>
-            <a:off x="8211308" y="4700016"/>
-            <a:ext cx="1746503" cy="182880"/>
+            <a:off x="8211308" y="4992624"/>
+            <a:ext cx="1746503" cy="219456"/>
           </a:xfrm>
           <a:prstGeom prst="rect">
             <a:avLst/>
@@ -4478,8 +4478,8 @@
         </p:nvSpPr>
         <p:spPr>
           <a:xfrm>
-            <a:off x="8211308" y="4882896"/>
-            <a:ext cx="1746503" cy="292608"/>
+            <a:off x="8211308" y="5212080"/>
+            <a:ext cx="1746503" cy="329184"/>
           </a:xfrm>
           <a:prstGeom prst="rect">
             <a:avLst/>
@@ -4494,7 +4494,7 @@
           <a:p>
             <a:pPr algn="l"/>
             <a:r>
-              <a:rPr sz="1200" b="1">
+              <a:rPr sz="1300" b="1">
                 <a:solidFill>
                   <a:srgbClr val="8B1A2B"/>
                 </a:solidFill>
@@ -4514,8 +4514,8 @@
         </p:nvSpPr>
         <p:spPr>
           <a:xfrm>
-            <a:off x="10104115" y="4517136"/>
-            <a:ext cx="1874519" cy="713232"/>
+            <a:off x="10104115" y="4773168"/>
+            <a:ext cx="1874519" cy="841248"/>
           </a:xfrm>
           <a:prstGeom prst="rect">
             <a:avLst/>
@@ -4559,8 +4559,8 @@
         </p:nvSpPr>
         <p:spPr>
           <a:xfrm>
-            <a:off x="10177267" y="4535424"/>
-            <a:ext cx="1746503" cy="164592"/>
+            <a:off x="10177267" y="4809744"/>
+            <a:ext cx="1746503" cy="182880"/>
           </a:xfrm>
           <a:prstGeom prst="rect">
             <a:avLst/>
@@ -4595,8 +4595,8 @@
         </p:nvSpPr>
         <p:spPr>
           <a:xfrm>
-            <a:off x="10177267" y="4700016"/>
-            <a:ext cx="1746503" cy="182880"/>
+            <a:off x="10177267" y="4992624"/>
+            <a:ext cx="1746503" cy="219456"/>
           </a:xfrm>
           <a:prstGeom prst="rect">
             <a:avLst/>
@@ -4631,8 +4631,8 @@
         </p:nvSpPr>
         <p:spPr>
           <a:xfrm>
-            <a:off x="10177267" y="4882896"/>
-            <a:ext cx="1746503" cy="292608"/>
+            <a:off x="10177267" y="5212080"/>
+            <a:ext cx="1746503" cy="329184"/>
           </a:xfrm>
           <a:prstGeom prst="rect">
             <a:avLst/>
@@ -4647,7 +4647,7 @@
           <a:p>
             <a:pPr algn="l"/>
             <a:r>
-              <a:rPr sz="1200" b="1">
+              <a:rPr sz="1300" b="1">
                 <a:solidFill>
                   <a:srgbClr val="8B1A2B"/>
                 </a:solidFill>
@@ -4667,8 +4667,8 @@
         </p:nvSpPr>
         <p:spPr>
           <a:xfrm>
-            <a:off x="0" y="5321808"/>
-            <a:ext cx="12191695" cy="1536192"/>
+            <a:off x="0" y="5760720"/>
+            <a:ext cx="12191695" cy="1097280"/>
           </a:xfrm>
           <a:prstGeom prst="rect">
             <a:avLst/>
@@ -4710,8 +4710,8 @@
         </p:nvSpPr>
         <p:spPr>
           <a:xfrm>
-            <a:off x="320040" y="5367528"/>
-            <a:ext cx="11521440" cy="1170432"/>
+            <a:off x="320040" y="5833872"/>
+            <a:ext cx="11521440" cy="640080"/>
           </a:xfrm>
           <a:prstGeom prst="rect">
             <a:avLst/>
@@ -4724,71 +4724,16 @@
           </a:bodyPr>
           <a:lstStyle/>
           <a:p>
-            <a:pPr algn="l">
-              <a:spcAft>
-                <a:spcPts val="100"/>
-              </a:spcAft>
-            </a:pPr>
-            <a:r>
-              <a:rPr sz="1000" b="1">
+            <a:pPr algn="l"/>
+            <a:r>
+              <a:rPr sz="1200" b="1">
                 <a:solidFill>
                   <a:srgbClr val="1A1A1A"/>
                 </a:solidFill>
                 <a:latin typeface="Microsoft YaHei"/>
                 <a:ea typeface="Microsoft YaHei"/>
               </a:rPr>
-              <a:t>技术启示：</a:t>
-            </a:r>
-          </a:p>
-          <a:p>
-            <a:pPr algn="l">
-              <a:spcAft>
-                <a:spcPts val="100"/>
-              </a:spcAft>
-            </a:pPr>
-            <a:r>
-              <a:rPr sz="1000" b="0">
-                <a:solidFill>
-                  <a:srgbClr val="1A1A1A"/>
-                </a:solidFill>
-                <a:latin typeface="Microsoft YaHei"/>
-                <a:ea typeface="Microsoft YaHei"/>
-              </a:rPr>
-              <a:t>• Cost/Token 拆三项落地：分子控 GPU 选型/潮汐混部/Spot；分母用 PD 分离、EP/DP、KVCache Offload/复用抬吞吐，用 KV 感知路由与弹性抬利用率；能力按对公式三项的贡献立项与验收。</a:t>
-            </a:r>
-          </a:p>
-          <a:p>
-            <a:pPr algn="l">
-              <a:spcAft>
-                <a:spcPts val="100"/>
-              </a:spcAft>
-            </a:pPr>
-            <a:r>
-              <a:rPr sz="1000" b="0">
-                <a:solidFill>
-                  <a:srgbClr val="1A1A1A"/>
-                </a:solidFill>
-                <a:latin typeface="Microsoft YaHei"/>
-                <a:ea typeface="Microsoft YaHei"/>
-              </a:rPr>
-              <a:t>• Serving Stack 固化默认能力：网关公平调度+负载/缓存亲和；ModelScale 通 OSS→Mooncake→FlashGPU→引擎间 P2P（RDMA+GDR），权重分钟→秒级；InferenceKit 以 Webhook→Wrapper→插件注入 NUMA/启动加速，禁静默降级、Summary 可审计。</a:t>
-            </a:r>
-          </a:p>
-          <a:p>
-            <a:pPr algn="l">
-              <a:spcAft>
-                <a:spcPts val="100"/>
-              </a:spcAft>
-            </a:pPr>
-            <a:r>
-              <a:rPr sz="1000" b="0">
-                <a:solidFill>
-                  <a:srgbClr val="1A1A1A"/>
-                </a:solidFill>
-                <a:latin typeface="Microsoft YaHei"/>
-                <a:ea typeface="Microsoft YaHei"/>
-              </a:rPr>
-              <a:t>• 编排按性能压力分阶段：GroupSet 固定 P:D + Gang + 原地升级/组缓存先稳住发布与冷启；RBG 再把 Router/P/D/Encode/KV 升为独立 Role，按排队/TTFT/TPOT/KV 独立扩缩 + KVCache-Aware 选路；上接快照复用 + Rollout 托管，承接训推一体与 Agent RL。</a:t>
+              <a:t>技术启示：推理竞争力已从单引擎调优，转向平台能否系统性改写 Cost/Token——冷启与拓扑正确性必须和在线吞吐同一套发布准入，否则引擎侧收益会被基础设施税抵消；编排上固定成组只是稳态过渡，把协同从「结构绑死」升级为「角色级策略约束」，才是动态负载与 Agent RL 可共享的执行底盘。</a:t>
             </a:r>
           </a:p>
         </p:txBody>
@@ -4801,8 +4746,8 @@
         </p:nvSpPr>
         <p:spPr>
           <a:xfrm>
-            <a:off x="320040" y="6565392"/>
-            <a:ext cx="11521440" cy="201168"/>
+            <a:off x="320040" y="6473952"/>
+            <a:ext cx="11521440" cy="219456"/>
           </a:xfrm>
           <a:prstGeom prst="rect">
             <a:avLst/>

</xml_diff>

<commit_message>
Tune ACK×小红书 insights for leadership and architect briefing
Recast card leads and footer as distilled technical judgments suitable for a mixed audience of leaders and cloud engineers/architects.

Co-authored-by: Annie <Annie-Summer@users.noreply.github.com>
</commit_message>
<xml_diff>
--- a/yunqi-2026-agenda-201/docs/洞察一页-08-容器服务 × 小红书：大模型推理与 Agent RL.pptx
+++ b/yunqi-2026-agenda-201/docs/洞察一页-08-容器服务 × 小红书：大模型推理与 Agent RL.pptx
@@ -3443,7 +3443,7 @@
                 <a:latin typeface="Microsoft YaHei"/>
                 <a:ea typeface="Microsoft YaHei"/>
               </a:rPr>
-              <a:t>技术启示：路由+权重分发+拓扑注入做成平台默认能力</a:t>
+              <a:t>技术启示：冷启命中与拓扑正确性，比引擎峰值更能改写 Token 成本</a:t>
             </a:r>
           </a:p>
           <a:p>
@@ -3632,7 +3632,7 @@
                 <a:latin typeface="Microsoft YaHei"/>
                 <a:ea typeface="Microsoft YaHei"/>
               </a:rPr>
-              <a:t>技术启示：按性能压力分阶段演进编排，先稳态再弹性</a:t>
+              <a:t>技术启示：组级稳态只覆盖生产窗口，Role 级控制面才可规模化弹性</a:t>
             </a:r>
           </a:p>
           <a:p>
@@ -4733,7 +4733,7 @@
                 <a:latin typeface="Microsoft YaHei"/>
                 <a:ea typeface="Microsoft YaHei"/>
               </a:rPr>
-              <a:t>技术启示：以 Cost/Token = GPU·h ÷ (Throughput × Utilization) 作为 Serving 控制面目标函数后，权重命中路径与 NUMA/互联拓扑必须进入与 TTFT/吞吐同级的发布准入与弹性观测，否则引擎侧增益会被冷启与错配放大抵消；编排则需从固定 P:D 的组级原语演进到 Role 级策略约束（独立扩缩、协同发布、KVCache-aware 选路），使动态 PD 与 Agent Rollout 复用同一调度语义与状态面。</a:t>
+              <a:t>技术启示：推理平台应以 Cost/Token 为统一验收口径建设 Serving 控制面——权重命中率、拓扑正确性与 TTFT/吞吐一并纳入发布准入与弹性闭环；编排从固定 P:D 组级稳态演进到 Role 级独立扩缩与 KVCache-aware 选路。这是同 SLO 下持续降本，并承接动态 PD 与 Agent RL 的架构前提，应作为下一代 Serving 默认能力规划。</a:t>
             </a:r>
           </a:p>
         </p:txBody>

</xml_diff>

<commit_message>
Add more technical detail to ACK×小红书 footer insight
Expand release-gate metrics and Role-level policy wording without restating the Cost/Token formula or card feature lists.

Co-authored-by: Annie <Annie-Summer@users.noreply.github.com>
</commit_message>
<xml_diff>
--- a/yunqi-2026-agenda-201/docs/洞察一页-08-容器服务 × 小红书：大模型推理与 Agent RL.pptx
+++ b/yunqi-2026-agenda-201/docs/洞察一页-08-容器服务 × 小红书：大模型推理与 Agent RL.pptx
@@ -4710,8 +4710,8 @@
         </p:nvSpPr>
         <p:spPr>
           <a:xfrm>
-            <a:off x="320040" y="5833872"/>
-            <a:ext cx="11521440" cy="640080"/>
+            <a:off x="320040" y="5815584"/>
+            <a:ext cx="11521440" cy="713232"/>
           </a:xfrm>
           <a:prstGeom prst="rect">
             <a:avLst/>
@@ -4726,14 +4726,14 @@
           <a:p>
             <a:pPr algn="l"/>
             <a:r>
-              <a:rPr sz="1200" b="1">
+              <a:rPr sz="1100" b="1">
                 <a:solidFill>
                   <a:srgbClr val="1A1A1A"/>
                 </a:solidFill>
                 <a:latin typeface="Microsoft YaHei"/>
                 <a:ea typeface="Microsoft YaHei"/>
               </a:rPr>
-              <a:t>技术启示：权重命中路径与 NUMA/互联拓扑必须进入与 TTFT/吞吐同级的发布准入与弹性观测；编排从固定 P:D 组级原语演进到 Role 级策略约束（独立扩缩、协同发布、KVCache-aware 选路），使动态 PD 与 Agent Rollout 复用同一调度语义与状态面。</a:t>
+              <a:t>技术启示：将权重分层命中率、冷启就绪时延与 NUMA/卡间互联拓扑正确性，提升到与 TTFT、吞吐同级的发布准入与弹性观测指标，避免引擎侧优化被冷启与拓扑错配抵消；编排从固定 P:D 的 Group 原语演进到 Role 级策略约束——Router/P/D/KV 等角色独立扩缩与协同发布，叠加 KVCache-aware 扁平选路——使动态 PD 弹性与 Agent Rollout 的快照/轨迹状态复用同一调度语义与状态面。</a:t>
             </a:r>
           </a:p>
         </p:txBody>
@@ -4746,7 +4746,7 @@
         </p:nvSpPr>
         <p:spPr>
           <a:xfrm>
-            <a:off x="320040" y="6473952"/>
+            <a:off x="320040" y="6528816"/>
             <a:ext cx="11521440" cy="219456"/>
           </a:xfrm>
           <a:prstGeom prst="rect">

</xml_diff>

<commit_message>
List footer 技术启示 as bullet points on Agentic and ACK slides
Convert closing insights into numbered-style bullets for clearer briefing readout.

Co-authored-by: Annie <Annie-Summer@users.noreply.github.com>
</commit_message>
<xml_diff>
--- a/yunqi-2026-agenda-201/docs/洞察一页-08-容器服务 × 小红书：大模型推理与 Agent RL.pptx
+++ b/yunqi-2026-agenda-201/docs/洞察一页-08-容器服务 × 小红书：大模型推理与 Agent RL.pptx
@@ -3713,8 +3713,8 @@
         </p:nvSpPr>
         <p:spPr>
           <a:xfrm>
-            <a:off x="274320" y="4535424"/>
-            <a:ext cx="9144000" cy="219456"/>
+            <a:off x="274320" y="4370832"/>
+            <a:ext cx="9144000" cy="201168"/>
           </a:xfrm>
           <a:prstGeom prst="rect">
             <a:avLst/>
@@ -3729,7 +3729,7 @@
           <a:p>
             <a:pPr algn="l"/>
             <a:r>
-              <a:rPr sz="1200" b="1">
+              <a:rPr sz="1100" b="1">
                 <a:solidFill>
                   <a:srgbClr val="1A1A1A"/>
                 </a:solidFill>
@@ -3749,8 +3749,8 @@
         </p:nvSpPr>
         <p:spPr>
           <a:xfrm>
-            <a:off x="274320" y="4773168"/>
-            <a:ext cx="1874519" cy="841248"/>
+            <a:off x="274320" y="4572000"/>
+            <a:ext cx="1874519" cy="713232"/>
           </a:xfrm>
           <a:prstGeom prst="rect">
             <a:avLst/>
@@ -3794,8 +3794,8 @@
         </p:nvSpPr>
         <p:spPr>
           <a:xfrm>
-            <a:off x="347472" y="4809744"/>
-            <a:ext cx="1746503" cy="182880"/>
+            <a:off x="347472" y="4590288"/>
+            <a:ext cx="1746503" cy="164592"/>
           </a:xfrm>
           <a:prstGeom prst="rect">
             <a:avLst/>
@@ -3830,8 +3830,8 @@
         </p:nvSpPr>
         <p:spPr>
           <a:xfrm>
-            <a:off x="347472" y="4992624"/>
-            <a:ext cx="1746503" cy="219456"/>
+            <a:off x="347472" y="4754880"/>
+            <a:ext cx="1746503" cy="182880"/>
           </a:xfrm>
           <a:prstGeom prst="rect">
             <a:avLst/>
@@ -3866,8 +3866,8 @@
         </p:nvSpPr>
         <p:spPr>
           <a:xfrm>
-            <a:off x="347472" y="5212080"/>
-            <a:ext cx="1746503" cy="329184"/>
+            <a:off x="347472" y="4937760"/>
+            <a:ext cx="1746503" cy="292608"/>
           </a:xfrm>
           <a:prstGeom prst="rect">
             <a:avLst/>
@@ -3882,7 +3882,7 @@
           <a:p>
             <a:pPr algn="l"/>
             <a:r>
-              <a:rPr sz="1300" b="1">
+              <a:rPr sz="1200" b="1">
                 <a:solidFill>
                   <a:srgbClr val="8B1A2B"/>
                 </a:solidFill>
@@ -3902,8 +3902,8 @@
         </p:nvSpPr>
         <p:spPr>
           <a:xfrm>
-            <a:off x="2240279" y="4773168"/>
-            <a:ext cx="1874519" cy="841248"/>
+            <a:off x="2240279" y="4572000"/>
+            <a:ext cx="1874519" cy="713232"/>
           </a:xfrm>
           <a:prstGeom prst="rect">
             <a:avLst/>
@@ -3947,8 +3947,8 @@
         </p:nvSpPr>
         <p:spPr>
           <a:xfrm>
-            <a:off x="2313431" y="4809744"/>
-            <a:ext cx="1746503" cy="182880"/>
+            <a:off x="2313431" y="4590288"/>
+            <a:ext cx="1746503" cy="164592"/>
           </a:xfrm>
           <a:prstGeom prst="rect">
             <a:avLst/>
@@ -3983,8 +3983,8 @@
         </p:nvSpPr>
         <p:spPr>
           <a:xfrm>
-            <a:off x="2313431" y="4992624"/>
-            <a:ext cx="1746503" cy="219456"/>
+            <a:off x="2313431" y="4754880"/>
+            <a:ext cx="1746503" cy="182880"/>
           </a:xfrm>
           <a:prstGeom prst="rect">
             <a:avLst/>
@@ -4019,8 +4019,8 @@
         </p:nvSpPr>
         <p:spPr>
           <a:xfrm>
-            <a:off x="2313431" y="5212080"/>
-            <a:ext cx="1746503" cy="329184"/>
+            <a:off x="2313431" y="4937760"/>
+            <a:ext cx="1746503" cy="292608"/>
           </a:xfrm>
           <a:prstGeom prst="rect">
             <a:avLst/>
@@ -4035,7 +4035,7 @@
           <a:p>
             <a:pPr algn="l"/>
             <a:r>
-              <a:rPr sz="1300" b="1">
+              <a:rPr sz="1200" b="1">
                 <a:solidFill>
                   <a:srgbClr val="8B1A2B"/>
                 </a:solidFill>
@@ -4055,8 +4055,8 @@
         </p:nvSpPr>
         <p:spPr>
           <a:xfrm>
-            <a:off x="4206238" y="4773168"/>
-            <a:ext cx="1874519" cy="841248"/>
+            <a:off x="4206238" y="4572000"/>
+            <a:ext cx="1874519" cy="713232"/>
           </a:xfrm>
           <a:prstGeom prst="rect">
             <a:avLst/>
@@ -4100,8 +4100,8 @@
         </p:nvSpPr>
         <p:spPr>
           <a:xfrm>
-            <a:off x="4279390" y="4809744"/>
-            <a:ext cx="1746503" cy="182880"/>
+            <a:off x="4279390" y="4590288"/>
+            <a:ext cx="1746503" cy="164592"/>
           </a:xfrm>
           <a:prstGeom prst="rect">
             <a:avLst/>
@@ -4136,8 +4136,8 @@
         </p:nvSpPr>
         <p:spPr>
           <a:xfrm>
-            <a:off x="4279390" y="4992624"/>
-            <a:ext cx="1746503" cy="219456"/>
+            <a:off x="4279390" y="4754880"/>
+            <a:ext cx="1746503" cy="182880"/>
           </a:xfrm>
           <a:prstGeom prst="rect">
             <a:avLst/>
@@ -4172,8 +4172,8 @@
         </p:nvSpPr>
         <p:spPr>
           <a:xfrm>
-            <a:off x="4279390" y="5212080"/>
-            <a:ext cx="1746503" cy="329184"/>
+            <a:off x="4279390" y="4937760"/>
+            <a:ext cx="1746503" cy="292608"/>
           </a:xfrm>
           <a:prstGeom prst="rect">
             <a:avLst/>
@@ -4188,7 +4188,7 @@
           <a:p>
             <a:pPr algn="l"/>
             <a:r>
-              <a:rPr sz="1300" b="1">
+              <a:rPr sz="1200" b="1">
                 <a:solidFill>
                   <a:srgbClr val="8B1A2B"/>
                 </a:solidFill>
@@ -4208,8 +4208,8 @@
         </p:nvSpPr>
         <p:spPr>
           <a:xfrm>
-            <a:off x="6172197" y="4773168"/>
-            <a:ext cx="1874519" cy="841248"/>
+            <a:off x="6172197" y="4572000"/>
+            <a:ext cx="1874519" cy="713232"/>
           </a:xfrm>
           <a:prstGeom prst="rect">
             <a:avLst/>
@@ -4253,8 +4253,8 @@
         </p:nvSpPr>
         <p:spPr>
           <a:xfrm>
-            <a:off x="6245349" y="4809744"/>
-            <a:ext cx="1746503" cy="182880"/>
+            <a:off x="6245349" y="4590288"/>
+            <a:ext cx="1746503" cy="164592"/>
           </a:xfrm>
           <a:prstGeom prst="rect">
             <a:avLst/>
@@ -4289,8 +4289,8 @@
         </p:nvSpPr>
         <p:spPr>
           <a:xfrm>
-            <a:off x="6245349" y="4992624"/>
-            <a:ext cx="1746503" cy="219456"/>
+            <a:off x="6245349" y="4754880"/>
+            <a:ext cx="1746503" cy="182880"/>
           </a:xfrm>
           <a:prstGeom prst="rect">
             <a:avLst/>
@@ -4325,8 +4325,8 @@
         </p:nvSpPr>
         <p:spPr>
           <a:xfrm>
-            <a:off x="6245349" y="5212080"/>
-            <a:ext cx="1746503" cy="329184"/>
+            <a:off x="6245349" y="4937760"/>
+            <a:ext cx="1746503" cy="292608"/>
           </a:xfrm>
           <a:prstGeom prst="rect">
             <a:avLst/>
@@ -4341,7 +4341,7 @@
           <a:p>
             <a:pPr algn="l"/>
             <a:r>
-              <a:rPr sz="1300" b="1">
+              <a:rPr sz="1200" b="1">
                 <a:solidFill>
                   <a:srgbClr val="8B1A2B"/>
                 </a:solidFill>
@@ -4361,8 +4361,8 @@
         </p:nvSpPr>
         <p:spPr>
           <a:xfrm>
-            <a:off x="8138156" y="4773168"/>
-            <a:ext cx="1874519" cy="841248"/>
+            <a:off x="8138156" y="4572000"/>
+            <a:ext cx="1874519" cy="713232"/>
           </a:xfrm>
           <a:prstGeom prst="rect">
             <a:avLst/>
@@ -4406,8 +4406,8 @@
         </p:nvSpPr>
         <p:spPr>
           <a:xfrm>
-            <a:off x="8211308" y="4809744"/>
-            <a:ext cx="1746503" cy="182880"/>
+            <a:off x="8211308" y="4590288"/>
+            <a:ext cx="1746503" cy="164592"/>
           </a:xfrm>
           <a:prstGeom prst="rect">
             <a:avLst/>
@@ -4442,8 +4442,8 @@
         </p:nvSpPr>
         <p:spPr>
           <a:xfrm>
-            <a:off x="8211308" y="4992624"/>
-            <a:ext cx="1746503" cy="219456"/>
+            <a:off x="8211308" y="4754880"/>
+            <a:ext cx="1746503" cy="182880"/>
           </a:xfrm>
           <a:prstGeom prst="rect">
             <a:avLst/>
@@ -4478,8 +4478,8 @@
         </p:nvSpPr>
         <p:spPr>
           <a:xfrm>
-            <a:off x="8211308" y="5212080"/>
-            <a:ext cx="1746503" cy="329184"/>
+            <a:off x="8211308" y="4937760"/>
+            <a:ext cx="1746503" cy="292608"/>
           </a:xfrm>
           <a:prstGeom prst="rect">
             <a:avLst/>
@@ -4494,7 +4494,7 @@
           <a:p>
             <a:pPr algn="l"/>
             <a:r>
-              <a:rPr sz="1300" b="1">
+              <a:rPr sz="1200" b="1">
                 <a:solidFill>
                   <a:srgbClr val="8B1A2B"/>
                 </a:solidFill>
@@ -4514,8 +4514,8 @@
         </p:nvSpPr>
         <p:spPr>
           <a:xfrm>
-            <a:off x="10104115" y="4773168"/>
-            <a:ext cx="1874519" cy="841248"/>
+            <a:off x="10104115" y="4572000"/>
+            <a:ext cx="1874519" cy="713232"/>
           </a:xfrm>
           <a:prstGeom prst="rect">
             <a:avLst/>
@@ -4559,8 +4559,8 @@
         </p:nvSpPr>
         <p:spPr>
           <a:xfrm>
-            <a:off x="10177267" y="4809744"/>
-            <a:ext cx="1746503" cy="182880"/>
+            <a:off x="10177267" y="4590288"/>
+            <a:ext cx="1746503" cy="164592"/>
           </a:xfrm>
           <a:prstGeom prst="rect">
             <a:avLst/>
@@ -4595,8 +4595,8 @@
         </p:nvSpPr>
         <p:spPr>
           <a:xfrm>
-            <a:off x="10177267" y="4992624"/>
-            <a:ext cx="1746503" cy="219456"/>
+            <a:off x="10177267" y="4754880"/>
+            <a:ext cx="1746503" cy="182880"/>
           </a:xfrm>
           <a:prstGeom prst="rect">
             <a:avLst/>
@@ -4631,8 +4631,8 @@
         </p:nvSpPr>
         <p:spPr>
           <a:xfrm>
-            <a:off x="10177267" y="5212080"/>
-            <a:ext cx="1746503" cy="329184"/>
+            <a:off x="10177267" y="4937760"/>
+            <a:ext cx="1746503" cy="292608"/>
           </a:xfrm>
           <a:prstGeom prst="rect">
             <a:avLst/>
@@ -4647,7 +4647,7 @@
           <a:p>
             <a:pPr algn="l"/>
             <a:r>
-              <a:rPr sz="1300" b="1">
+              <a:rPr sz="1200" b="1">
                 <a:solidFill>
                   <a:srgbClr val="8B1A2B"/>
                 </a:solidFill>
@@ -4667,8 +4667,8 @@
         </p:nvSpPr>
         <p:spPr>
           <a:xfrm>
-            <a:off x="0" y="5760720"/>
-            <a:ext cx="12191695" cy="1097280"/>
+            <a:off x="0" y="5394960"/>
+            <a:ext cx="12191695" cy="1463040"/>
           </a:xfrm>
           <a:prstGeom prst="rect">
             <a:avLst/>
@@ -4710,8 +4710,8 @@
         </p:nvSpPr>
         <p:spPr>
           <a:xfrm>
-            <a:off x="320040" y="5815584"/>
-            <a:ext cx="11521440" cy="713232"/>
+            <a:off x="320040" y="5431536"/>
+            <a:ext cx="11521440" cy="1097280"/>
           </a:xfrm>
           <a:prstGeom prst="rect">
             <a:avLst/>
@@ -4724,7 +4724,11 @@
           </a:bodyPr>
           <a:lstStyle/>
           <a:p>
-            <a:pPr algn="l"/>
+            <a:pPr algn="l">
+              <a:spcAft>
+                <a:spcPts val="200"/>
+              </a:spcAft>
+            </a:pPr>
             <a:r>
               <a:rPr sz="1100" b="1">
                 <a:solidFill>
@@ -4733,7 +4737,58 @@
                 <a:latin typeface="Microsoft YaHei"/>
                 <a:ea typeface="Microsoft YaHei"/>
               </a:rPr>
-              <a:t>技术启示：Serving 发布准入与弹性观测不能只看 TTFT/吞吐，还需把权重分层命中率、冷启就绪时延、NUMA/卡间互联拓扑正确性一并纳入，否则只在推理引擎（如并行策略、batching）上拿到的时延/吞吐收益，会被慢冷启与拓扑错配吞掉；编排上，固定 P:D 的 Group 原语只适合稳态生产窗口，要支撑动态负载需演进到 Role 级策略约束（Router/P/D/KV 独立扩缩、协同发布、KVCache-aware 扁平选路），并让 Agent RL 的环境快照断点续跑与轨迹托管跑在同一套 Role 编排与弹性控制面上。</a:t>
+              <a:t>技术启示：</a:t>
+            </a:r>
+          </a:p>
+          <a:p>
+            <a:pPr algn="l">
+              <a:spcAft>
+                <a:spcPts val="200"/>
+              </a:spcAft>
+            </a:pPr>
+            <a:r>
+              <a:rPr sz="1100" b="0">
+                <a:solidFill>
+                  <a:srgbClr val="1A1A1A"/>
+                </a:solidFill>
+                <a:latin typeface="Microsoft YaHei"/>
+                <a:ea typeface="Microsoft YaHei"/>
+              </a:rPr>
+              <a:t>• Serving 发布准入与弹性观测不能只看 TTFT/吞吐，还需把权重分层命中率、冷启就绪时延、NUMA/卡间互联拓扑正确性一并纳入。</a:t>
+            </a:r>
+          </a:p>
+          <a:p>
+            <a:pPr algn="l">
+              <a:spcAft>
+                <a:spcPts val="200"/>
+              </a:spcAft>
+            </a:pPr>
+            <a:r>
+              <a:rPr sz="1100" b="0">
+                <a:solidFill>
+                  <a:srgbClr val="1A1A1A"/>
+                </a:solidFill>
+                <a:latin typeface="Microsoft YaHei"/>
+                <a:ea typeface="Microsoft YaHei"/>
+              </a:rPr>
+              <a:t>• 否则只在推理引擎（如并行策略、batching）上拿到的时延/吞吐收益，会被慢冷启与拓扑错配吞掉。</a:t>
+            </a:r>
+          </a:p>
+          <a:p>
+            <a:pPr algn="l">
+              <a:spcAft>
+                <a:spcPts val="200"/>
+              </a:spcAft>
+            </a:pPr>
+            <a:r>
+              <a:rPr sz="1100" b="0">
+                <a:solidFill>
+                  <a:srgbClr val="1A1A1A"/>
+                </a:solidFill>
+                <a:latin typeface="Microsoft YaHei"/>
+                <a:ea typeface="Microsoft YaHei"/>
+              </a:rPr>
+              <a:t>• 编排从固定 P:D 的 Group 原语演进到 Role 级策略约束（Router/P/D/KV 独立扩缩、协同发布、KVCache-aware 扁平选路），并让 Agent RL 的环境快照断点续跑与轨迹托管跑在同一套 Role 编排与弹性控制面上。</a:t>
             </a:r>
           </a:p>
         </p:txBody>
@@ -4747,7 +4802,7 @@
         <p:spPr>
           <a:xfrm>
             <a:off x="320040" y="6528816"/>
-            <a:ext cx="11521440" cy="219456"/>
+            <a:ext cx="11521440" cy="201168"/>
           </a:xfrm>
           <a:prstGeom prst="rect">
             <a:avLst/>

</xml_diff>

<commit_message>
Recast footer insights as concrete technical points
Replace advisory phrasing with mechanism-level bullets: scheduling cascade, stack co-delivery, and Auto model routing.

Co-authored-by: Annie <Annie-Summer@users.noreply.github.com>
</commit_message>
<xml_diff>
--- a/yunqi-2026-agenda-201/docs/洞察一页-08-容器服务 × 小红书：大模型推理与 Agent RL.pptx
+++ b/yunqi-2026-agenda-201/docs/洞察一页-08-容器服务 × 小红书：大模型推理与 Agent RL.pptx
@@ -4754,7 +4754,7 @@
                 <a:latin typeface="Microsoft YaHei"/>
                 <a:ea typeface="Microsoft YaHei"/>
               </a:rPr>
-              <a:t>• Serving 发布准入与弹性观测不能只看 TTFT/吞吐，还需把权重分层命中率、冷启就绪时延、NUMA/卡间互联拓扑正确性一并纳入。</a:t>
+              <a:t>• 发布准入与弹性观测指标集：TTFT/吞吐 + 权重分层命中率 + 冷启就绪时延 + NUMA/卡间互联拓扑正确性，形成可闭环验收。</a:t>
             </a:r>
           </a:p>
           <a:p>
@@ -4771,7 +4771,7 @@
                 <a:latin typeface="Microsoft YaHei"/>
                 <a:ea typeface="Microsoft YaHei"/>
               </a:rPr>
-              <a:t>• 否则只在推理引擎（如并行策略、batching）上拿到的时延/吞吐收益，会被慢冷启与拓扑错配吞掉。</a:t>
+              <a:t>• ModelScale 冷温热权重分层（OSS→Mooncake→FlashGPU/P2P）+ InferenceKit 拓扑注入（NUMA/互联），避免仅做引擎并行/batching 时收益被冷启与错配抵消。</a:t>
             </a:r>
           </a:p>
           <a:p>
@@ -4788,7 +4788,7 @@
                 <a:latin typeface="Microsoft YaHei"/>
                 <a:ea typeface="Microsoft YaHei"/>
               </a:rPr>
-              <a:t>• 编排从固定 P:D 的 Group 原语演进到 Role 级策略约束（Router/P/D/KV 独立扩缩、协同发布、KVCache-aware 扁平选路），并让 Agent RL 的环境快照断点续跑与轨迹托管跑在同一套 Role 编排与弹性控制面上。</a:t>
+              <a:t>• 编排从 GroupSet 固定 P:D 演进到 RBG Role 级（Router/P/D/KV 独立扩缩、协同发布、KVCache-aware 扁平选路）；Agent RL 环境快照断点续跑与轨迹托管共用同一 Role 控制面。</a:t>
             </a:r>
           </a:p>
         </p:txBody>

</xml_diff>

<commit_message>
Replace arrows and multiply signs with prose in footer insights
Rewrite Agentic and ACK closing technical points using plain Chinese connectives instead of → and ×.

Co-authored-by: Annie <Annie-Summer@users.noreply.github.com>
</commit_message>
<xml_diff>
--- a/yunqi-2026-agenda-201/docs/洞察一页-08-容器服务 × 小红书：大模型推理与 Agent RL.pptx
+++ b/yunqi-2026-agenda-201/docs/洞察一页-08-容器服务 × 小红书：大模型推理与 Agent RL.pptx
@@ -4754,7 +4754,7 @@
                 <a:latin typeface="Microsoft YaHei"/>
                 <a:ea typeface="Microsoft YaHei"/>
               </a:rPr>
-              <a:t>• 发布准入与弹性观测指标集：TTFT/吞吐 + 权重分层命中率 + 冷启就绪时延 + NUMA/卡间互联拓扑正确性，形成可闭环验收。</a:t>
+              <a:t>• 发布准入与弹性观测指标集：TTFT、吞吐、权重分层命中率、冷启就绪时延、NUMA 与卡间互联拓扑正确性，形成可闭环验收。</a:t>
             </a:r>
           </a:p>
           <a:p>
@@ -4771,7 +4771,7 @@
                 <a:latin typeface="Microsoft YaHei"/>
                 <a:ea typeface="Microsoft YaHei"/>
               </a:rPr>
-              <a:t>• ModelScale 冷温热权重分层（OSS→Mooncake→FlashGPU/P2P）+ InferenceKit 拓扑注入（NUMA/互联），避免仅做引擎并行/batching 时收益被冷启与错配抵消。</a:t>
+              <a:t>• ModelScale 冷温热权重分层（先 OSS，再 Mooncake，再到 FlashGPU/P2P），配合 InferenceKit 拓扑注入（NUMA 与互联），避免仅做引擎并行或 batching 时收益被冷启与错配抵消。</a:t>
             </a:r>
           </a:p>
           <a:p>
@@ -4788,7 +4788,7 @@
                 <a:latin typeface="Microsoft YaHei"/>
                 <a:ea typeface="Microsoft YaHei"/>
               </a:rPr>
-              <a:t>• 编排从 GroupSet 固定 P:D 演进到 RBG Role 级（Router/P/D/KV 独立扩缩、协同发布、KVCache-aware 扁平选路）；Agent RL 环境快照断点续跑与轨迹托管共用同一 Role 控制面。</a:t>
+              <a:t>• 编排从 GroupSet 固定 P:D 演进到 RBG Role 级（Router、P、D、KV 独立扩缩、协同发布、KVCache-aware 扁平选路）；Agent RL 环境快照断点续跑与轨迹托管共用同一 Role 控制面。</a:t>
             </a:r>
           </a:p>
         </p:txBody>

</xml_diff>

<commit_message>
Replace 选路 with clearer KV-prefix instance scheduling wording
Use 按 KV 前缀命中全局选实例 / 在全局实例池中调度请求 instead of KVCache-aware 选路.

Co-authored-by: Annie <Annie-Summer@users.noreply.github.com>
</commit_message>
<xml_diff>
--- a/yunqi-2026-agenda-201/docs/洞察一页-08-容器服务 × 小红书：大模型推理与 Agent RL.pptx
+++ b/yunqi-2026-agenda-201/docs/洞察一页-08-容器服务 × 小红书：大模型推理与 Agent RL.pptx
@@ -3666,7 +3666,7 @@
                 <a:latin typeface="Microsoft YaHei"/>
                 <a:ea typeface="Microsoft YaHei"/>
               </a:rPr>
-              <a:t>• 动态 RBG：Role 一等公民，独立扩缩/发布；KVCache-Aware 选路</a:t>
+              <a:t>• 动态 RBG：Role 一等公民，独立扩缩/发布；按 KV 前缀命中全局选实例</a:t>
             </a:r>
           </a:p>
           <a:p>
@@ -4788,7 +4788,7 @@
                 <a:latin typeface="Microsoft YaHei"/>
                 <a:ea typeface="Microsoft YaHei"/>
               </a:rPr>
-              <a:t>• 编排从 GroupSet 固定 P:D 演进到 RBG Role 级（Router、P、D、KV 独立扩缩、协同发布、KVCache-aware 扁平选路）；Agent RL 环境快照断点续跑与轨迹托管共用同一 Role 控制面。</a:t>
+              <a:t>• 编排从 GroupSet 固定 P:D 演进到 RBG Role 级（Router、P、D、KV 独立扩缩、协同发布，并按 KV 前缀命中在全局实例池中调度请求）；Agent RL 环境快照断点续跑与轨迹托管共用同一 Role 控制面。</a:t>
             </a:r>
           </a:p>
         </p:txBody>

</xml_diff>

<commit_message>
Replace Group/Role jargon with 成组部署 and 分角色扩缩
Make ACK×小红书 orchestration wording more briefing-friendly without 原语.

Co-authored-by: Annie <Annie-Summer@users.noreply.github.com>
</commit_message>
<xml_diff>
--- a/yunqi-2026-agenda-201/docs/洞察一页-08-容器服务 × 小红书：大模型推理与 Agent RL.pptx
+++ b/yunqi-2026-agenda-201/docs/洞察一页-08-容器服务 × 小红书：大模型推理与 Agent RL.pptx
@@ -3632,7 +3632,7 @@
                 <a:latin typeface="Microsoft YaHei"/>
                 <a:ea typeface="Microsoft YaHei"/>
               </a:rPr>
-              <a:t>技术启示：组级稳态只覆盖生产窗口，Role 级控制面才可规模化弹性</a:t>
+              <a:t>技术启示：固定配比成组部署只够稳态，动态负载要分角色扩缩</a:t>
             </a:r>
           </a:p>
           <a:p>
@@ -3649,7 +3649,7 @@
                 <a:latin typeface="Microsoft YaHei"/>
                 <a:ea typeface="Microsoft YaHei"/>
               </a:rPr>
-              <a:t>• 静态 GroupSet：组内 P:D 固定，Gang 成组；原地升级+四级缓存</a:t>
+              <a:t>• 静态成组：组内 P:D 固定，整组调度/扩缩/发布；原地升级+四级缓存</a:t>
             </a:r>
           </a:p>
           <a:p>
@@ -3666,7 +3666,7 @@
                 <a:latin typeface="Microsoft YaHei"/>
                 <a:ea typeface="Microsoft YaHei"/>
               </a:rPr>
-              <a:t>• 动态 RBG：Role 一等公民，独立扩缩/发布；按 KV 前缀命中全局选实例</a:t>
+              <a:t>• 动态分角色：Router/P/D/KV 独立扩缩与发布；按 KV 前缀命中全局选实例</a:t>
             </a:r>
           </a:p>
           <a:p>
@@ -4788,7 +4788,7 @@
                 <a:latin typeface="Microsoft YaHei"/>
                 <a:ea typeface="Microsoft YaHei"/>
               </a:rPr>
-              <a:t>• 编排从 GroupSet 固定 P:D 演进到 RBG Role 级（Router、P、D、KV 独立扩缩、协同发布，并按 KV 前缀命中在全局实例池中调度请求）；Agent RL 环境快照断点续跑与轨迹托管共用同一 Role 控制面。</a:t>
+              <a:t>• 编排上，固定 P:D 成组部署只适合稳态生产；要支撑动态负载，需按 Router、Prefill、Decode、KV 分角色独立扩缩、协同发布，并按 KV 前缀命中在全局实例池中调度请求；Agent RL 的环境快照断点续跑与轨迹托管也跑在同一套角色编排与弹性控制面上。</a:t>
             </a:r>
           </a:p>
         </p:txBody>

</xml_diff>